<commit_message>
Redesign Day 2 roadmap slide as a clean numbered 4x3 grid
Replace the crowded winding-road layout with aligned cards, phase colors,
official tool logos, and a native PowerPoint slide for sharper text.

Co-authored-by: Kethan <kethan-1818@users.noreply.github.com>
</commit_message>
<xml_diff>
--- a/fdc-day2/FDC_Day2_DevOps_Roadmap.pptx
+++ b/fdc-day2/FDC_Day2_DevOps_Roadmap.pptx
@@ -3591,7 +3591,7 @@
       </p:sp>
       <p:pic>
         <p:nvPicPr>
-          <p:cNvPr id="8" name="Picture 7" descr="amazonaws.png"/>
+          <p:cNvPr id="8" name="Picture 7" descr="cloudformation.png"/>
           <p:cNvPicPr>
             <a:picLocks noChangeAspect="1"/>
           </p:cNvPicPr>
@@ -7572,7 +7572,7 @@
     <p:bg>
       <p:bgPr>
         <a:solidFill>
-          <a:srgbClr val="F8FAFC"/>
+          <a:srgbClr val="F6F8FC"/>
         </a:solidFill>
         <a:effectLst/>
       </p:bgPr>
@@ -7584,9 +7584,1109 @@
         <p:nvPr/>
       </p:nvGrpSpPr>
       <p:grpSpPr/>
+      <p:sp>
+        <p:nvSpPr>
+          <p:cNvPr id="2" name="Rectangle 1"/>
+          <p:cNvSpPr/>
+          <p:nvPr/>
+        </p:nvSpPr>
+        <p:spPr>
+          <a:xfrm>
+            <a:off x="0" y="0"/>
+            <a:ext cx="12191695" cy="64008"/>
+          </a:xfrm>
+          <a:prstGeom prst="rect">
+            <a:avLst/>
+          </a:prstGeom>
+          <a:solidFill>
+            <a:srgbClr val="22D3EE"/>
+          </a:solidFill>
+          <a:ln>
+            <a:noFill/>
+          </a:ln>
+        </p:spPr>
+        <p:style>
+          <a:lnRef idx="1">
+            <a:schemeClr val="accent1"/>
+          </a:lnRef>
+          <a:fillRef idx="3">
+            <a:schemeClr val="accent1"/>
+          </a:fillRef>
+          <a:effectRef idx="2">
+            <a:schemeClr val="accent1"/>
+          </a:effectRef>
+          <a:fontRef idx="minor">
+            <a:schemeClr val="lt1"/>
+          </a:fontRef>
+        </p:style>
+        <p:txBody>
+          <a:bodyPr rtlCol="0" anchor="ctr"/>
+          <a:lstStyle/>
+          <a:p>
+            <a:pPr algn="ctr"/>
+          </a:p>
+        </p:txBody>
+      </p:sp>
+      <p:sp>
+        <p:nvSpPr>
+          <p:cNvPr id="3" name="TextBox 2"/>
+          <p:cNvSpPr txBox="1"/>
+          <p:nvPr/>
+        </p:nvSpPr>
+        <p:spPr>
+          <a:xfrm>
+            <a:off x="292608" y="128016"/>
+            <a:ext cx="7315200" cy="438912"/>
+          </a:xfrm>
+          <a:prstGeom prst="rect">
+            <a:avLst/>
+          </a:prstGeom>
+          <a:noFill/>
+        </p:spPr>
+        <p:txBody>
+          <a:bodyPr wrap="square">
+            <a:spAutoFit/>
+          </a:bodyPr>
+          <a:lstStyle/>
+          <a:p>
+            <a:pPr algn="l"/>
+            <a:r>
+              <a:rPr sz="2800" b="1">
+                <a:solidFill>
+                  <a:srgbClr val="141E2E"/>
+                </a:solidFill>
+                <a:latin typeface="Calibri"/>
+              </a:rPr>
+              <a:t>DevOps Roadmap</a:t>
+            </a:r>
+          </a:p>
+        </p:txBody>
+      </p:sp>
+      <p:sp>
+        <p:nvSpPr>
+          <p:cNvPr id="4" name="TextBox 3"/>
+          <p:cNvSpPr txBox="1"/>
+          <p:nvPr/>
+        </p:nvSpPr>
+        <p:spPr>
+          <a:xfrm>
+            <a:off x="292608" y="493776"/>
+            <a:ext cx="8686800" cy="256032"/>
+          </a:xfrm>
+          <a:prstGeom prst="rect">
+            <a:avLst/>
+          </a:prstGeom>
+          <a:noFill/>
+        </p:spPr>
+        <p:txBody>
+          <a:bodyPr wrap="square">
+            <a:spAutoFit/>
+          </a:bodyPr>
+          <a:lstStyle/>
+          <a:p>
+            <a:pPr algn="l"/>
+            <a:r>
+              <a:rPr sz="1100" b="0">
+                <a:solidFill>
+                  <a:srgbClr val="606E7E"/>
+                </a:solidFill>
+                <a:latin typeface="Calibri"/>
+              </a:rPr>
+              <a:t>Beginner’s Guide to Cloud Automation  ·  Friday Deployment Club  ·  Day 2</a:t>
+            </a:r>
+          </a:p>
+        </p:txBody>
+      </p:sp>
+      <p:sp>
+        <p:nvSpPr>
+          <p:cNvPr id="5" name="Rounded Rectangle 4"/>
+          <p:cNvSpPr/>
+          <p:nvPr/>
+        </p:nvSpPr>
+        <p:spPr>
+          <a:xfrm>
+            <a:off x="292608" y="804672"/>
+            <a:ext cx="164592" cy="128016"/>
+          </a:xfrm>
+          <a:prstGeom prst="roundRect">
+            <a:avLst/>
+          </a:prstGeom>
+          <a:solidFill>
+            <a:srgbClr val="F58220"/>
+          </a:solidFill>
+          <a:ln>
+            <a:noFill/>
+          </a:ln>
+        </p:spPr>
+        <p:style>
+          <a:lnRef idx="1">
+            <a:schemeClr val="accent1"/>
+          </a:lnRef>
+          <a:fillRef idx="3">
+            <a:schemeClr val="accent1"/>
+          </a:fillRef>
+          <a:effectRef idx="2">
+            <a:schemeClr val="accent1"/>
+          </a:effectRef>
+          <a:fontRef idx="minor">
+            <a:schemeClr val="lt1"/>
+          </a:fontRef>
+        </p:style>
+        <p:txBody>
+          <a:bodyPr rtlCol="0" anchor="ctr"/>
+          <a:lstStyle/>
+          <a:p>
+            <a:pPr algn="ctr"/>
+          </a:p>
+        </p:txBody>
+      </p:sp>
+      <p:sp>
+        <p:nvSpPr>
+          <p:cNvPr id="6" name="TextBox 5"/>
+          <p:cNvSpPr txBox="1"/>
+          <p:nvPr/>
+        </p:nvSpPr>
+        <p:spPr>
+          <a:xfrm>
+            <a:off x="493776" y="768096"/>
+            <a:ext cx="1920240" cy="201168"/>
+          </a:xfrm>
+          <a:prstGeom prst="rect">
+            <a:avLst/>
+          </a:prstGeom>
+          <a:noFill/>
+        </p:spPr>
+        <p:txBody>
+          <a:bodyPr wrap="square">
+            <a:spAutoFit/>
+          </a:bodyPr>
+          <a:lstStyle/>
+          <a:p>
+            <a:pPr algn="l"/>
+            <a:r>
+              <a:rPr sz="1000" b="1">
+                <a:solidFill>
+                  <a:srgbClr val="606E7E"/>
+                </a:solidFill>
+                <a:latin typeface="Calibri"/>
+              </a:rPr>
+              <a:t>Foundations</a:t>
+            </a:r>
+          </a:p>
+        </p:txBody>
+      </p:sp>
+      <p:sp>
+        <p:nvSpPr>
+          <p:cNvPr id="7" name="Rounded Rectangle 6"/>
+          <p:cNvSpPr/>
+          <p:nvPr/>
+        </p:nvSpPr>
+        <p:spPr>
+          <a:xfrm>
+            <a:off x="2441448" y="804672"/>
+            <a:ext cx="164592" cy="128016"/>
+          </a:xfrm>
+          <a:prstGeom prst="roundRect">
+            <a:avLst/>
+          </a:prstGeom>
+          <a:solidFill>
+            <a:srgbClr val="7C5CD4"/>
+          </a:solidFill>
+          <a:ln>
+            <a:noFill/>
+          </a:ln>
+        </p:spPr>
+        <p:style>
+          <a:lnRef idx="1">
+            <a:schemeClr val="accent1"/>
+          </a:lnRef>
+          <a:fillRef idx="3">
+            <a:schemeClr val="accent1"/>
+          </a:fillRef>
+          <a:effectRef idx="2">
+            <a:schemeClr val="accent1"/>
+          </a:effectRef>
+          <a:fontRef idx="minor">
+            <a:schemeClr val="lt1"/>
+          </a:fontRef>
+        </p:style>
+        <p:txBody>
+          <a:bodyPr rtlCol="0" anchor="ctr"/>
+          <a:lstStyle/>
+          <a:p>
+            <a:pPr algn="ctr"/>
+          </a:p>
+        </p:txBody>
+      </p:sp>
+      <p:sp>
+        <p:nvSpPr>
+          <p:cNvPr id="8" name="TextBox 7"/>
+          <p:cNvSpPr txBox="1"/>
+          <p:nvPr/>
+        </p:nvSpPr>
+        <p:spPr>
+          <a:xfrm>
+            <a:off x="2642616" y="768096"/>
+            <a:ext cx="1920240" cy="201168"/>
+          </a:xfrm>
+          <a:prstGeom prst="rect">
+            <a:avLst/>
+          </a:prstGeom>
+          <a:noFill/>
+        </p:spPr>
+        <p:txBody>
+          <a:bodyPr wrap="square">
+            <a:spAutoFit/>
+          </a:bodyPr>
+          <a:lstStyle/>
+          <a:p>
+            <a:pPr algn="l"/>
+            <a:r>
+              <a:rPr sz="1000" b="1">
+                <a:solidFill>
+                  <a:srgbClr val="606E7E"/>
+                </a:solidFill>
+                <a:latin typeface="Calibri"/>
+              </a:rPr>
+              <a:t>Containers &amp; CI/CD</a:t>
+            </a:r>
+          </a:p>
+        </p:txBody>
+      </p:sp>
+      <p:sp>
+        <p:nvSpPr>
+          <p:cNvPr id="9" name="Rounded Rectangle 8"/>
+          <p:cNvSpPr/>
+          <p:nvPr/>
+        </p:nvSpPr>
+        <p:spPr>
+          <a:xfrm>
+            <a:off x="4590288" y="804672"/>
+            <a:ext cx="164592" cy="128016"/>
+          </a:xfrm>
+          <a:prstGeom prst="roundRect">
+            <a:avLst/>
+          </a:prstGeom>
+          <a:solidFill>
+            <a:srgbClr val="387ED6"/>
+          </a:solidFill>
+          <a:ln>
+            <a:noFill/>
+          </a:ln>
+        </p:spPr>
+        <p:style>
+          <a:lnRef idx="1">
+            <a:schemeClr val="accent1"/>
+          </a:lnRef>
+          <a:fillRef idx="3">
+            <a:schemeClr val="accent1"/>
+          </a:fillRef>
+          <a:effectRef idx="2">
+            <a:schemeClr val="accent1"/>
+          </a:effectRef>
+          <a:fontRef idx="minor">
+            <a:schemeClr val="lt1"/>
+          </a:fontRef>
+        </p:style>
+        <p:txBody>
+          <a:bodyPr rtlCol="0" anchor="ctr"/>
+          <a:lstStyle/>
+          <a:p>
+            <a:pPr algn="ctr"/>
+          </a:p>
+        </p:txBody>
+      </p:sp>
+      <p:sp>
+        <p:nvSpPr>
+          <p:cNvPr id="10" name="TextBox 9"/>
+          <p:cNvSpPr txBox="1"/>
+          <p:nvPr/>
+        </p:nvSpPr>
+        <p:spPr>
+          <a:xfrm>
+            <a:off x="4791455" y="768096"/>
+            <a:ext cx="1920240" cy="201168"/>
+          </a:xfrm>
+          <a:prstGeom prst="rect">
+            <a:avLst/>
+          </a:prstGeom>
+          <a:noFill/>
+        </p:spPr>
+        <p:txBody>
+          <a:bodyPr wrap="square">
+            <a:spAutoFit/>
+          </a:bodyPr>
+          <a:lstStyle/>
+          <a:p>
+            <a:pPr algn="l"/>
+            <a:r>
+              <a:rPr sz="1000" b="1">
+                <a:solidFill>
+                  <a:srgbClr val="606E7E"/>
+                </a:solidFill>
+                <a:latin typeface="Calibri"/>
+              </a:rPr>
+              <a:t>Cloud</a:t>
+            </a:r>
+          </a:p>
+        </p:txBody>
+      </p:sp>
+      <p:sp>
+        <p:nvSpPr>
+          <p:cNvPr id="11" name="Rounded Rectangle 10"/>
+          <p:cNvSpPr/>
+          <p:nvPr/>
+        </p:nvSpPr>
+        <p:spPr>
+          <a:xfrm>
+            <a:off x="6739127" y="804672"/>
+            <a:ext cx="164592" cy="128016"/>
+          </a:xfrm>
+          <a:prstGeom prst="roundRect">
+            <a:avLst/>
+          </a:prstGeom>
+          <a:solidFill>
+            <a:srgbClr val="4F46B4"/>
+          </a:solidFill>
+          <a:ln>
+            <a:noFill/>
+          </a:ln>
+        </p:spPr>
+        <p:style>
+          <a:lnRef idx="1">
+            <a:schemeClr val="accent1"/>
+          </a:lnRef>
+          <a:fillRef idx="3">
+            <a:schemeClr val="accent1"/>
+          </a:fillRef>
+          <a:effectRef idx="2">
+            <a:schemeClr val="accent1"/>
+          </a:effectRef>
+          <a:fontRef idx="minor">
+            <a:schemeClr val="lt1"/>
+          </a:fontRef>
+        </p:style>
+        <p:txBody>
+          <a:bodyPr rtlCol="0" anchor="ctr"/>
+          <a:lstStyle/>
+          <a:p>
+            <a:pPr algn="ctr"/>
+          </a:p>
+        </p:txBody>
+      </p:sp>
+      <p:sp>
+        <p:nvSpPr>
+          <p:cNvPr id="12" name="TextBox 11"/>
+          <p:cNvSpPr txBox="1"/>
+          <p:nvPr/>
+        </p:nvSpPr>
+        <p:spPr>
+          <a:xfrm>
+            <a:off x="6940295" y="768096"/>
+            <a:ext cx="1920240" cy="201168"/>
+          </a:xfrm>
+          <a:prstGeom prst="rect">
+            <a:avLst/>
+          </a:prstGeom>
+          <a:noFill/>
+        </p:spPr>
+        <p:txBody>
+          <a:bodyPr wrap="square">
+            <a:spAutoFit/>
+          </a:bodyPr>
+          <a:lstStyle/>
+          <a:p>
+            <a:pPr algn="l"/>
+            <a:r>
+              <a:rPr sz="1000" b="1">
+                <a:solidFill>
+                  <a:srgbClr val="606E7E"/>
+                </a:solidFill>
+                <a:latin typeface="Calibri"/>
+              </a:rPr>
+              <a:t>Infra &amp; Orchestration</a:t>
+            </a:r>
+          </a:p>
+        </p:txBody>
+      </p:sp>
+      <p:sp>
+        <p:nvSpPr>
+          <p:cNvPr id="13" name="Rounded Rectangle 12"/>
+          <p:cNvSpPr/>
+          <p:nvPr/>
+        </p:nvSpPr>
+        <p:spPr>
+          <a:xfrm>
+            <a:off x="8887967" y="804672"/>
+            <a:ext cx="164592" cy="128016"/>
+          </a:xfrm>
+          <a:prstGeom prst="roundRect">
+            <a:avLst/>
+          </a:prstGeom>
+          <a:solidFill>
+            <a:srgbClr val="22A062"/>
+          </a:solidFill>
+          <a:ln>
+            <a:noFill/>
+          </a:ln>
+        </p:spPr>
+        <p:style>
+          <a:lnRef idx="1">
+            <a:schemeClr val="accent1"/>
+          </a:lnRef>
+          <a:fillRef idx="3">
+            <a:schemeClr val="accent1"/>
+          </a:fillRef>
+          <a:effectRef idx="2">
+            <a:schemeClr val="accent1"/>
+          </a:effectRef>
+          <a:fontRef idx="minor">
+            <a:schemeClr val="lt1"/>
+          </a:fontRef>
+        </p:style>
+        <p:txBody>
+          <a:bodyPr rtlCol="0" anchor="ctr"/>
+          <a:lstStyle/>
+          <a:p>
+            <a:pPr algn="ctr"/>
+          </a:p>
+        </p:txBody>
+      </p:sp>
+      <p:sp>
+        <p:nvSpPr>
+          <p:cNvPr id="14" name="TextBox 13"/>
+          <p:cNvSpPr txBox="1"/>
+          <p:nvPr/>
+        </p:nvSpPr>
+        <p:spPr>
+          <a:xfrm>
+            <a:off x="9089136" y="768096"/>
+            <a:ext cx="1920240" cy="201168"/>
+          </a:xfrm>
+          <a:prstGeom prst="rect">
+            <a:avLst/>
+          </a:prstGeom>
+          <a:noFill/>
+        </p:spPr>
+        <p:txBody>
+          <a:bodyPr wrap="square">
+            <a:spAutoFit/>
+          </a:bodyPr>
+          <a:lstStyle/>
+          <a:p>
+            <a:pPr algn="l"/>
+            <a:r>
+              <a:rPr sz="1000" b="1">
+                <a:solidFill>
+                  <a:srgbClr val="606E7E"/>
+                </a:solidFill>
+                <a:latin typeface="Calibri"/>
+              </a:rPr>
+              <a:t>Security &amp; Monitoring</a:t>
+            </a:r>
+          </a:p>
+        </p:txBody>
+      </p:sp>
+      <p:sp>
+        <p:nvSpPr>
+          <p:cNvPr id="15" name="Right Arrow 14"/>
+          <p:cNvSpPr/>
+          <p:nvPr/>
+        </p:nvSpPr>
+        <p:spPr>
+          <a:xfrm>
+            <a:off x="3079927" y="1783079"/>
+            <a:ext cx="128015" cy="146304"/>
+          </a:xfrm>
+          <a:prstGeom prst="rightArrow">
+            <a:avLst/>
+          </a:prstGeom>
+          <a:solidFill>
+            <a:srgbClr val="B8C0CC"/>
+          </a:solidFill>
+          <a:ln>
+            <a:noFill/>
+          </a:ln>
+        </p:spPr>
+        <p:style>
+          <a:lnRef idx="1">
+            <a:schemeClr val="accent1"/>
+          </a:lnRef>
+          <a:fillRef idx="3">
+            <a:schemeClr val="accent1"/>
+          </a:fillRef>
+          <a:effectRef idx="2">
+            <a:schemeClr val="accent1"/>
+          </a:effectRef>
+          <a:fontRef idx="minor">
+            <a:schemeClr val="lt1"/>
+          </a:fontRef>
+        </p:style>
+        <p:txBody>
+          <a:bodyPr rtlCol="0" anchor="ctr"/>
+          <a:lstStyle/>
+          <a:p>
+            <a:pPr algn="ctr"/>
+          </a:p>
+        </p:txBody>
+      </p:sp>
+      <p:sp>
+        <p:nvSpPr>
+          <p:cNvPr id="16" name="Right Arrow 15"/>
+          <p:cNvSpPr/>
+          <p:nvPr/>
+        </p:nvSpPr>
+        <p:spPr>
+          <a:xfrm>
+            <a:off x="6031839" y="1783079"/>
+            <a:ext cx="128015" cy="146304"/>
+          </a:xfrm>
+          <a:prstGeom prst="rightArrow">
+            <a:avLst/>
+          </a:prstGeom>
+          <a:solidFill>
+            <a:srgbClr val="B8C0CC"/>
+          </a:solidFill>
+          <a:ln>
+            <a:noFill/>
+          </a:ln>
+        </p:spPr>
+        <p:style>
+          <a:lnRef idx="1">
+            <a:schemeClr val="accent1"/>
+          </a:lnRef>
+          <a:fillRef idx="3">
+            <a:schemeClr val="accent1"/>
+          </a:fillRef>
+          <a:effectRef idx="2">
+            <a:schemeClr val="accent1"/>
+          </a:effectRef>
+          <a:fontRef idx="minor">
+            <a:schemeClr val="lt1"/>
+          </a:fontRef>
+        </p:style>
+        <p:txBody>
+          <a:bodyPr rtlCol="0" anchor="ctr"/>
+          <a:lstStyle/>
+          <a:p>
+            <a:pPr algn="ctr"/>
+          </a:p>
+        </p:txBody>
+      </p:sp>
+      <p:sp>
+        <p:nvSpPr>
+          <p:cNvPr id="17" name="Right Arrow 16"/>
+          <p:cNvSpPr/>
+          <p:nvPr/>
+        </p:nvSpPr>
+        <p:spPr>
+          <a:xfrm>
+            <a:off x="8983751" y="1783079"/>
+            <a:ext cx="128015" cy="146304"/>
+          </a:xfrm>
+          <a:prstGeom prst="rightArrow">
+            <a:avLst/>
+          </a:prstGeom>
+          <a:solidFill>
+            <a:srgbClr val="B8C0CC"/>
+          </a:solidFill>
+          <a:ln>
+            <a:noFill/>
+          </a:ln>
+        </p:spPr>
+        <p:style>
+          <a:lnRef idx="1">
+            <a:schemeClr val="accent1"/>
+          </a:lnRef>
+          <a:fillRef idx="3">
+            <a:schemeClr val="accent1"/>
+          </a:fillRef>
+          <a:effectRef idx="2">
+            <a:schemeClr val="accent1"/>
+          </a:effectRef>
+          <a:fontRef idx="minor">
+            <a:schemeClr val="lt1"/>
+          </a:fontRef>
+        </p:style>
+        <p:txBody>
+          <a:bodyPr rtlCol="0" anchor="ctr"/>
+          <a:lstStyle/>
+          <a:p>
+            <a:pPr algn="ctr"/>
+          </a:p>
+        </p:txBody>
+      </p:sp>
+      <p:sp>
+        <p:nvSpPr>
+          <p:cNvPr id="18" name="Right Arrow 17"/>
+          <p:cNvSpPr/>
+          <p:nvPr/>
+        </p:nvSpPr>
+        <p:spPr>
+          <a:xfrm>
+            <a:off x="3079927" y="3593591"/>
+            <a:ext cx="128015" cy="146304"/>
+          </a:xfrm>
+          <a:prstGeom prst="rightArrow">
+            <a:avLst/>
+          </a:prstGeom>
+          <a:solidFill>
+            <a:srgbClr val="B8C0CC"/>
+          </a:solidFill>
+          <a:ln>
+            <a:noFill/>
+          </a:ln>
+        </p:spPr>
+        <p:style>
+          <a:lnRef idx="1">
+            <a:schemeClr val="accent1"/>
+          </a:lnRef>
+          <a:fillRef idx="3">
+            <a:schemeClr val="accent1"/>
+          </a:fillRef>
+          <a:effectRef idx="2">
+            <a:schemeClr val="accent1"/>
+          </a:effectRef>
+          <a:fontRef idx="minor">
+            <a:schemeClr val="lt1"/>
+          </a:fontRef>
+        </p:style>
+        <p:txBody>
+          <a:bodyPr rtlCol="0" anchor="ctr"/>
+          <a:lstStyle/>
+          <a:p>
+            <a:pPr algn="ctr"/>
+          </a:p>
+        </p:txBody>
+      </p:sp>
+      <p:sp>
+        <p:nvSpPr>
+          <p:cNvPr id="19" name="Right Arrow 18"/>
+          <p:cNvSpPr/>
+          <p:nvPr/>
+        </p:nvSpPr>
+        <p:spPr>
+          <a:xfrm>
+            <a:off x="6031839" y="3593591"/>
+            <a:ext cx="128015" cy="146304"/>
+          </a:xfrm>
+          <a:prstGeom prst="rightArrow">
+            <a:avLst/>
+          </a:prstGeom>
+          <a:solidFill>
+            <a:srgbClr val="B8C0CC"/>
+          </a:solidFill>
+          <a:ln>
+            <a:noFill/>
+          </a:ln>
+        </p:spPr>
+        <p:style>
+          <a:lnRef idx="1">
+            <a:schemeClr val="accent1"/>
+          </a:lnRef>
+          <a:fillRef idx="3">
+            <a:schemeClr val="accent1"/>
+          </a:fillRef>
+          <a:effectRef idx="2">
+            <a:schemeClr val="accent1"/>
+          </a:effectRef>
+          <a:fontRef idx="minor">
+            <a:schemeClr val="lt1"/>
+          </a:fontRef>
+        </p:style>
+        <p:txBody>
+          <a:bodyPr rtlCol="0" anchor="ctr"/>
+          <a:lstStyle/>
+          <a:p>
+            <a:pPr algn="ctr"/>
+          </a:p>
+        </p:txBody>
+      </p:sp>
+      <p:sp>
+        <p:nvSpPr>
+          <p:cNvPr id="20" name="Right Arrow 19"/>
+          <p:cNvSpPr/>
+          <p:nvPr/>
+        </p:nvSpPr>
+        <p:spPr>
+          <a:xfrm>
+            <a:off x="8983751" y="3593591"/>
+            <a:ext cx="128015" cy="146304"/>
+          </a:xfrm>
+          <a:prstGeom prst="rightArrow">
+            <a:avLst/>
+          </a:prstGeom>
+          <a:solidFill>
+            <a:srgbClr val="B8C0CC"/>
+          </a:solidFill>
+          <a:ln>
+            <a:noFill/>
+          </a:ln>
+        </p:spPr>
+        <p:style>
+          <a:lnRef idx="1">
+            <a:schemeClr val="accent1"/>
+          </a:lnRef>
+          <a:fillRef idx="3">
+            <a:schemeClr val="accent1"/>
+          </a:fillRef>
+          <a:effectRef idx="2">
+            <a:schemeClr val="accent1"/>
+          </a:effectRef>
+          <a:fontRef idx="minor">
+            <a:schemeClr val="lt1"/>
+          </a:fontRef>
+        </p:style>
+        <p:txBody>
+          <a:bodyPr rtlCol="0" anchor="ctr"/>
+          <a:lstStyle/>
+          <a:p>
+            <a:pPr algn="ctr"/>
+          </a:p>
+        </p:txBody>
+      </p:sp>
+      <p:sp>
+        <p:nvSpPr>
+          <p:cNvPr id="21" name="Right Arrow 20"/>
+          <p:cNvSpPr/>
+          <p:nvPr/>
+        </p:nvSpPr>
+        <p:spPr>
+          <a:xfrm>
+            <a:off x="3079927" y="5404103"/>
+            <a:ext cx="128015" cy="146304"/>
+          </a:xfrm>
+          <a:prstGeom prst="rightArrow">
+            <a:avLst/>
+          </a:prstGeom>
+          <a:solidFill>
+            <a:srgbClr val="B8C0CC"/>
+          </a:solidFill>
+          <a:ln>
+            <a:noFill/>
+          </a:ln>
+        </p:spPr>
+        <p:style>
+          <a:lnRef idx="1">
+            <a:schemeClr val="accent1"/>
+          </a:lnRef>
+          <a:fillRef idx="3">
+            <a:schemeClr val="accent1"/>
+          </a:fillRef>
+          <a:effectRef idx="2">
+            <a:schemeClr val="accent1"/>
+          </a:effectRef>
+          <a:fontRef idx="minor">
+            <a:schemeClr val="lt1"/>
+          </a:fontRef>
+        </p:style>
+        <p:txBody>
+          <a:bodyPr rtlCol="0" anchor="ctr"/>
+          <a:lstStyle/>
+          <a:p>
+            <a:pPr algn="ctr"/>
+          </a:p>
+        </p:txBody>
+      </p:sp>
+      <p:sp>
+        <p:nvSpPr>
+          <p:cNvPr id="22" name="Right Arrow 21"/>
+          <p:cNvSpPr/>
+          <p:nvPr/>
+        </p:nvSpPr>
+        <p:spPr>
+          <a:xfrm>
+            <a:off x="6031839" y="5404103"/>
+            <a:ext cx="128015" cy="146304"/>
+          </a:xfrm>
+          <a:prstGeom prst="rightArrow">
+            <a:avLst/>
+          </a:prstGeom>
+          <a:solidFill>
+            <a:srgbClr val="B8C0CC"/>
+          </a:solidFill>
+          <a:ln>
+            <a:noFill/>
+          </a:ln>
+        </p:spPr>
+        <p:style>
+          <a:lnRef idx="1">
+            <a:schemeClr val="accent1"/>
+          </a:lnRef>
+          <a:fillRef idx="3">
+            <a:schemeClr val="accent1"/>
+          </a:fillRef>
+          <a:effectRef idx="2">
+            <a:schemeClr val="accent1"/>
+          </a:effectRef>
+          <a:fontRef idx="minor">
+            <a:schemeClr val="lt1"/>
+          </a:fontRef>
+        </p:style>
+        <p:txBody>
+          <a:bodyPr rtlCol="0" anchor="ctr"/>
+          <a:lstStyle/>
+          <a:p>
+            <a:pPr algn="ctr"/>
+          </a:p>
+        </p:txBody>
+      </p:sp>
+      <p:sp>
+        <p:nvSpPr>
+          <p:cNvPr id="23" name="Right Arrow 22"/>
+          <p:cNvSpPr/>
+          <p:nvPr/>
+        </p:nvSpPr>
+        <p:spPr>
+          <a:xfrm>
+            <a:off x="8983751" y="5404103"/>
+            <a:ext cx="128015" cy="146304"/>
+          </a:xfrm>
+          <a:prstGeom prst="rightArrow">
+            <a:avLst/>
+          </a:prstGeom>
+          <a:solidFill>
+            <a:srgbClr val="B8C0CC"/>
+          </a:solidFill>
+          <a:ln>
+            <a:noFill/>
+          </a:ln>
+        </p:spPr>
+        <p:style>
+          <a:lnRef idx="1">
+            <a:schemeClr val="accent1"/>
+          </a:lnRef>
+          <a:fillRef idx="3">
+            <a:schemeClr val="accent1"/>
+          </a:fillRef>
+          <a:effectRef idx="2">
+            <a:schemeClr val="accent1"/>
+          </a:effectRef>
+          <a:fontRef idx="minor">
+            <a:schemeClr val="lt1"/>
+          </a:fontRef>
+        </p:style>
+        <p:txBody>
+          <a:bodyPr rtlCol="0" anchor="ctr"/>
+          <a:lstStyle/>
+          <a:p>
+            <a:pPr algn="ctr"/>
+          </a:p>
+        </p:txBody>
+      </p:sp>
+      <p:sp>
+        <p:nvSpPr>
+          <p:cNvPr id="24" name="Rounded Rectangle 23"/>
+          <p:cNvSpPr/>
+          <p:nvPr/>
+        </p:nvSpPr>
+        <p:spPr>
+          <a:xfrm>
+            <a:off x="274320" y="1024128"/>
+            <a:ext cx="2787319" cy="1664207"/>
+          </a:xfrm>
+          <a:prstGeom prst="roundRect">
+            <a:avLst/>
+          </a:prstGeom>
+          <a:solidFill>
+            <a:srgbClr val="F8FAFC"/>
+          </a:solidFill>
+          <a:ln w="19050">
+            <a:solidFill>
+              <a:srgbClr val="E2E8F0"/>
+            </a:solidFill>
+          </a:ln>
+        </p:spPr>
+        <p:style>
+          <a:lnRef idx="1">
+            <a:schemeClr val="accent1"/>
+          </a:lnRef>
+          <a:fillRef idx="3">
+            <a:schemeClr val="accent1"/>
+          </a:fillRef>
+          <a:effectRef idx="2">
+            <a:schemeClr val="accent1"/>
+          </a:effectRef>
+          <a:fontRef idx="minor">
+            <a:schemeClr val="lt1"/>
+          </a:fontRef>
+        </p:style>
+        <p:txBody>
+          <a:bodyPr rtlCol="0" anchor="ctr"/>
+          <a:lstStyle/>
+          <a:p>
+            <a:pPr algn="ctr"/>
+          </a:p>
+        </p:txBody>
+      </p:sp>
+      <p:sp>
+        <p:nvSpPr>
+          <p:cNvPr id="25" name="Rounded Rectangle 24"/>
+          <p:cNvSpPr/>
+          <p:nvPr/>
+        </p:nvSpPr>
+        <p:spPr>
+          <a:xfrm>
+            <a:off x="274320" y="1024128"/>
+            <a:ext cx="91440" cy="1664207"/>
+          </a:xfrm>
+          <a:prstGeom prst="roundRect">
+            <a:avLst/>
+          </a:prstGeom>
+          <a:solidFill>
+            <a:srgbClr val="F58220"/>
+          </a:solidFill>
+          <a:ln>
+            <a:noFill/>
+          </a:ln>
+        </p:spPr>
+        <p:style>
+          <a:lnRef idx="1">
+            <a:schemeClr val="accent1"/>
+          </a:lnRef>
+          <a:fillRef idx="3">
+            <a:schemeClr val="accent1"/>
+          </a:fillRef>
+          <a:effectRef idx="2">
+            <a:schemeClr val="accent1"/>
+          </a:effectRef>
+          <a:fontRef idx="minor">
+            <a:schemeClr val="lt1"/>
+          </a:fontRef>
+        </p:style>
+        <p:txBody>
+          <a:bodyPr rtlCol="0" anchor="ctr"/>
+          <a:lstStyle/>
+          <a:p>
+            <a:pPr algn="ctr"/>
+          </a:p>
+        </p:txBody>
+      </p:sp>
+      <p:sp>
+        <p:nvSpPr>
+          <p:cNvPr id="26" name="Rounded Rectangle 25"/>
+          <p:cNvSpPr/>
+          <p:nvPr/>
+        </p:nvSpPr>
+        <p:spPr>
+          <a:xfrm>
+            <a:off x="438912" y="1133856"/>
+            <a:ext cx="438912" cy="256032"/>
+          </a:xfrm>
+          <a:prstGeom prst="roundRect">
+            <a:avLst/>
+          </a:prstGeom>
+          <a:solidFill>
+            <a:srgbClr val="F58220"/>
+          </a:solidFill>
+          <a:ln>
+            <a:noFill/>
+          </a:ln>
+        </p:spPr>
+        <p:style>
+          <a:lnRef idx="1">
+            <a:schemeClr val="accent1"/>
+          </a:lnRef>
+          <a:fillRef idx="3">
+            <a:schemeClr val="accent1"/>
+          </a:fillRef>
+          <a:effectRef idx="2">
+            <a:schemeClr val="accent1"/>
+          </a:effectRef>
+          <a:fontRef idx="minor">
+            <a:schemeClr val="lt1"/>
+          </a:fontRef>
+        </p:style>
+        <p:txBody>
+          <a:bodyPr rtlCol="0" anchor="ctr" wrap="square"/>
+          <a:lstStyle/>
+          <a:p>
+            <a:pPr algn="ctr"/>
+            <a:r>
+              <a:rPr sz="1100" b="1">
+                <a:solidFill>
+                  <a:srgbClr val="F8FAFC"/>
+                </a:solidFill>
+                <a:latin typeface="Calibri"/>
+              </a:rPr>
+              <a:t>01</a:t>
+            </a:r>
+          </a:p>
+        </p:txBody>
+      </p:sp>
+      <p:sp>
+        <p:nvSpPr>
+          <p:cNvPr id="27" name="TextBox 26"/>
+          <p:cNvSpPr txBox="1"/>
+          <p:nvPr/>
+        </p:nvSpPr>
+        <p:spPr>
+          <a:xfrm>
+            <a:off x="932688" y="1115568"/>
+            <a:ext cx="2010079" cy="292608"/>
+          </a:xfrm>
+          <a:prstGeom prst="rect">
+            <a:avLst/>
+          </a:prstGeom>
+          <a:noFill/>
+        </p:spPr>
+        <p:txBody>
+          <a:bodyPr wrap="square">
+            <a:spAutoFit/>
+          </a:bodyPr>
+          <a:lstStyle/>
+          <a:p>
+            <a:pPr algn="l"/>
+            <a:r>
+              <a:rPr sz="1300" b="1">
+                <a:solidFill>
+                  <a:srgbClr val="141E2E"/>
+                </a:solidFill>
+                <a:latin typeface="Calibri"/>
+              </a:rPr>
+              <a:t>Foundations</a:t>
+            </a:r>
+          </a:p>
+        </p:txBody>
+      </p:sp>
+      <p:sp>
+        <p:nvSpPr>
+          <p:cNvPr id="28" name="TextBox 27"/>
+          <p:cNvSpPr txBox="1"/>
+          <p:nvPr/>
+        </p:nvSpPr>
+        <p:spPr>
+          <a:xfrm>
+            <a:off x="932688" y="1371600"/>
+            <a:ext cx="2010079" cy="237744"/>
+          </a:xfrm>
+          <a:prstGeom prst="rect">
+            <a:avLst/>
+          </a:prstGeom>
+          <a:noFill/>
+        </p:spPr>
+        <p:txBody>
+          <a:bodyPr wrap="square">
+            <a:spAutoFit/>
+          </a:bodyPr>
+          <a:lstStyle/>
+          <a:p>
+            <a:pPr algn="l"/>
+            <a:r>
+              <a:rPr sz="1000" b="0">
+                <a:solidFill>
+                  <a:srgbClr val="606E7E"/>
+                </a:solidFill>
+                <a:latin typeface="Calibri"/>
+              </a:rPr>
+              <a:t>Linux · Bash · Git</a:t>
+            </a:r>
+          </a:p>
+        </p:txBody>
+      </p:sp>
       <p:pic>
         <p:nvPicPr>
-          <p:cNvPr id="2" name="Picture 1" descr="devops_roadmap_infographic.png"/>
+          <p:cNvPr id="29" name="Picture 28" descr="linux.png"/>
           <p:cNvPicPr>
             <a:picLocks noChangeAspect="1"/>
           </p:cNvPicPr>
@@ -7600,14 +8700,2992 @@
         </p:blipFill>
         <p:spPr>
           <a:xfrm>
-            <a:off x="0" y="0"/>
-            <a:ext cx="12191695" cy="6858000"/>
+            <a:off x="1027899" y="1664208"/>
+            <a:ext cx="365760" cy="365760"/>
           </a:xfrm>
           <a:prstGeom prst="rect">
             <a:avLst/>
           </a:prstGeom>
         </p:spPr>
       </p:pic>
+      <p:pic>
+        <p:nvPicPr>
+          <p:cNvPr id="30" name="Picture 29" descr="bash.png"/>
+          <p:cNvPicPr>
+            <a:picLocks noChangeAspect="1"/>
+          </p:cNvPicPr>
+          <p:nvPr/>
+        </p:nvPicPr>
+        <p:blipFill>
+          <a:blip r:embed="rId3"/>
+          <a:stretch>
+            <a:fillRect/>
+          </a:stretch>
+        </p:blipFill>
+        <p:spPr>
+          <a:xfrm>
+            <a:off x="1485099" y="1664208"/>
+            <a:ext cx="365760" cy="365760"/>
+          </a:xfrm>
+          <a:prstGeom prst="rect">
+            <a:avLst/>
+          </a:prstGeom>
+        </p:spPr>
+      </p:pic>
+      <p:pic>
+        <p:nvPicPr>
+          <p:cNvPr id="31" name="Picture 30" descr="git.png"/>
+          <p:cNvPicPr>
+            <a:picLocks noChangeAspect="1"/>
+          </p:cNvPicPr>
+          <p:nvPr/>
+        </p:nvPicPr>
+        <p:blipFill>
+          <a:blip r:embed="rId4"/>
+          <a:stretch>
+            <a:fillRect/>
+          </a:stretch>
+        </p:blipFill>
+        <p:spPr>
+          <a:xfrm>
+            <a:off x="1942299" y="1664208"/>
+            <a:ext cx="365760" cy="365760"/>
+          </a:xfrm>
+          <a:prstGeom prst="rect">
+            <a:avLst/>
+          </a:prstGeom>
+        </p:spPr>
+      </p:pic>
+      <p:sp>
+        <p:nvSpPr>
+          <p:cNvPr id="32" name="Rounded Rectangle 31"/>
+          <p:cNvSpPr/>
+          <p:nvPr/>
+        </p:nvSpPr>
+        <p:spPr>
+          <a:xfrm>
+            <a:off x="3226231" y="1024128"/>
+            <a:ext cx="2787319" cy="1664207"/>
+          </a:xfrm>
+          <a:prstGeom prst="roundRect">
+            <a:avLst/>
+          </a:prstGeom>
+          <a:solidFill>
+            <a:srgbClr val="F8FAFC"/>
+          </a:solidFill>
+          <a:ln w="19050">
+            <a:solidFill>
+              <a:srgbClr val="E2E8F0"/>
+            </a:solidFill>
+          </a:ln>
+        </p:spPr>
+        <p:style>
+          <a:lnRef idx="1">
+            <a:schemeClr val="accent1"/>
+          </a:lnRef>
+          <a:fillRef idx="3">
+            <a:schemeClr val="accent1"/>
+          </a:fillRef>
+          <a:effectRef idx="2">
+            <a:schemeClr val="accent1"/>
+          </a:effectRef>
+          <a:fontRef idx="minor">
+            <a:schemeClr val="lt1"/>
+          </a:fontRef>
+        </p:style>
+        <p:txBody>
+          <a:bodyPr rtlCol="0" anchor="ctr"/>
+          <a:lstStyle/>
+          <a:p>
+            <a:pPr algn="ctr"/>
+          </a:p>
+        </p:txBody>
+      </p:sp>
+      <p:sp>
+        <p:nvSpPr>
+          <p:cNvPr id="33" name="Rounded Rectangle 32"/>
+          <p:cNvSpPr/>
+          <p:nvPr/>
+        </p:nvSpPr>
+        <p:spPr>
+          <a:xfrm>
+            <a:off x="3226231" y="1024128"/>
+            <a:ext cx="91440" cy="1664207"/>
+          </a:xfrm>
+          <a:prstGeom prst="roundRect">
+            <a:avLst/>
+          </a:prstGeom>
+          <a:solidFill>
+            <a:srgbClr val="F58220"/>
+          </a:solidFill>
+          <a:ln>
+            <a:noFill/>
+          </a:ln>
+        </p:spPr>
+        <p:style>
+          <a:lnRef idx="1">
+            <a:schemeClr val="accent1"/>
+          </a:lnRef>
+          <a:fillRef idx="3">
+            <a:schemeClr val="accent1"/>
+          </a:fillRef>
+          <a:effectRef idx="2">
+            <a:schemeClr val="accent1"/>
+          </a:effectRef>
+          <a:fontRef idx="minor">
+            <a:schemeClr val="lt1"/>
+          </a:fontRef>
+        </p:style>
+        <p:txBody>
+          <a:bodyPr rtlCol="0" anchor="ctr"/>
+          <a:lstStyle/>
+          <a:p>
+            <a:pPr algn="ctr"/>
+          </a:p>
+        </p:txBody>
+      </p:sp>
+      <p:sp>
+        <p:nvSpPr>
+          <p:cNvPr id="34" name="Rounded Rectangle 33"/>
+          <p:cNvSpPr/>
+          <p:nvPr/>
+        </p:nvSpPr>
+        <p:spPr>
+          <a:xfrm>
+            <a:off x="3390823" y="1133856"/>
+            <a:ext cx="438912" cy="256032"/>
+          </a:xfrm>
+          <a:prstGeom prst="roundRect">
+            <a:avLst/>
+          </a:prstGeom>
+          <a:solidFill>
+            <a:srgbClr val="F58220"/>
+          </a:solidFill>
+          <a:ln>
+            <a:noFill/>
+          </a:ln>
+        </p:spPr>
+        <p:style>
+          <a:lnRef idx="1">
+            <a:schemeClr val="accent1"/>
+          </a:lnRef>
+          <a:fillRef idx="3">
+            <a:schemeClr val="accent1"/>
+          </a:fillRef>
+          <a:effectRef idx="2">
+            <a:schemeClr val="accent1"/>
+          </a:effectRef>
+          <a:fontRef idx="minor">
+            <a:schemeClr val="lt1"/>
+          </a:fontRef>
+        </p:style>
+        <p:txBody>
+          <a:bodyPr rtlCol="0" anchor="ctr" wrap="square"/>
+          <a:lstStyle/>
+          <a:p>
+            <a:pPr algn="ctr"/>
+            <a:r>
+              <a:rPr sz="1100" b="1">
+                <a:solidFill>
+                  <a:srgbClr val="F8FAFC"/>
+                </a:solidFill>
+                <a:latin typeface="Calibri"/>
+              </a:rPr>
+              <a:t>02</a:t>
+            </a:r>
+          </a:p>
+        </p:txBody>
+      </p:sp>
+      <p:sp>
+        <p:nvSpPr>
+          <p:cNvPr id="35" name="TextBox 34"/>
+          <p:cNvSpPr txBox="1"/>
+          <p:nvPr/>
+        </p:nvSpPr>
+        <p:spPr>
+          <a:xfrm>
+            <a:off x="3884599" y="1115568"/>
+            <a:ext cx="2010079" cy="292608"/>
+          </a:xfrm>
+          <a:prstGeom prst="rect">
+            <a:avLst/>
+          </a:prstGeom>
+          <a:noFill/>
+        </p:spPr>
+        <p:txBody>
+          <a:bodyPr wrap="square">
+            <a:spAutoFit/>
+          </a:bodyPr>
+          <a:lstStyle/>
+          <a:p>
+            <a:pPr algn="l"/>
+            <a:r>
+              <a:rPr sz="1300" b="1">
+                <a:solidFill>
+                  <a:srgbClr val="141E2E"/>
+                </a:solidFill>
+                <a:latin typeface="Calibri"/>
+              </a:rPr>
+              <a:t>Source Control</a:t>
+            </a:r>
+          </a:p>
+        </p:txBody>
+      </p:sp>
+      <p:sp>
+        <p:nvSpPr>
+          <p:cNvPr id="36" name="TextBox 35"/>
+          <p:cNvSpPr txBox="1"/>
+          <p:nvPr/>
+        </p:nvSpPr>
+        <p:spPr>
+          <a:xfrm>
+            <a:off x="3884599" y="1371600"/>
+            <a:ext cx="2010079" cy="237744"/>
+          </a:xfrm>
+          <a:prstGeom prst="rect">
+            <a:avLst/>
+          </a:prstGeom>
+          <a:noFill/>
+        </p:spPr>
+        <p:txBody>
+          <a:bodyPr wrap="square">
+            <a:spAutoFit/>
+          </a:bodyPr>
+          <a:lstStyle/>
+          <a:p>
+            <a:pPr algn="l"/>
+            <a:r>
+              <a:rPr sz="1000" b="0">
+                <a:solidFill>
+                  <a:srgbClr val="606E7E"/>
+                </a:solidFill>
+                <a:latin typeface="Calibri"/>
+              </a:rPr>
+              <a:t>Branches · PRs · Reviews</a:t>
+            </a:r>
+          </a:p>
+        </p:txBody>
+      </p:sp>
+      <p:pic>
+        <p:nvPicPr>
+          <p:cNvPr id="37" name="Picture 36" descr="git.png"/>
+          <p:cNvPicPr>
+            <a:picLocks noChangeAspect="1"/>
+          </p:cNvPicPr>
+          <p:nvPr/>
+        </p:nvPicPr>
+        <p:blipFill>
+          <a:blip r:embed="rId4"/>
+          <a:stretch>
+            <a:fillRect/>
+          </a:stretch>
+        </p:blipFill>
+        <p:spPr>
+          <a:xfrm>
+            <a:off x="4208411" y="1664208"/>
+            <a:ext cx="365760" cy="365760"/>
+          </a:xfrm>
+          <a:prstGeom prst="rect">
+            <a:avLst/>
+          </a:prstGeom>
+        </p:spPr>
+      </p:pic>
+      <p:pic>
+        <p:nvPicPr>
+          <p:cNvPr id="38" name="Picture 37" descr="github.png"/>
+          <p:cNvPicPr>
+            <a:picLocks noChangeAspect="1"/>
+          </p:cNvPicPr>
+          <p:nvPr/>
+        </p:nvPicPr>
+        <p:blipFill>
+          <a:blip r:embed="rId5"/>
+          <a:stretch>
+            <a:fillRect/>
+          </a:stretch>
+        </p:blipFill>
+        <p:spPr>
+          <a:xfrm>
+            <a:off x="4665611" y="1664208"/>
+            <a:ext cx="365760" cy="365760"/>
+          </a:xfrm>
+          <a:prstGeom prst="rect">
+            <a:avLst/>
+          </a:prstGeom>
+        </p:spPr>
+      </p:pic>
+      <p:sp>
+        <p:nvSpPr>
+          <p:cNvPr id="39" name="Rounded Rectangle 38"/>
+          <p:cNvSpPr/>
+          <p:nvPr/>
+        </p:nvSpPr>
+        <p:spPr>
+          <a:xfrm>
+            <a:off x="6178143" y="1024128"/>
+            <a:ext cx="2787319" cy="1664207"/>
+          </a:xfrm>
+          <a:prstGeom prst="roundRect">
+            <a:avLst/>
+          </a:prstGeom>
+          <a:solidFill>
+            <a:srgbClr val="F8FAFC"/>
+          </a:solidFill>
+          <a:ln w="19050">
+            <a:solidFill>
+              <a:srgbClr val="E2E8F0"/>
+            </a:solidFill>
+          </a:ln>
+        </p:spPr>
+        <p:style>
+          <a:lnRef idx="1">
+            <a:schemeClr val="accent1"/>
+          </a:lnRef>
+          <a:fillRef idx="3">
+            <a:schemeClr val="accent1"/>
+          </a:fillRef>
+          <a:effectRef idx="2">
+            <a:schemeClr val="accent1"/>
+          </a:effectRef>
+          <a:fontRef idx="minor">
+            <a:schemeClr val="lt1"/>
+          </a:fontRef>
+        </p:style>
+        <p:txBody>
+          <a:bodyPr rtlCol="0" anchor="ctr"/>
+          <a:lstStyle/>
+          <a:p>
+            <a:pPr algn="ctr"/>
+          </a:p>
+        </p:txBody>
+      </p:sp>
+      <p:sp>
+        <p:nvSpPr>
+          <p:cNvPr id="40" name="Rounded Rectangle 39"/>
+          <p:cNvSpPr/>
+          <p:nvPr/>
+        </p:nvSpPr>
+        <p:spPr>
+          <a:xfrm>
+            <a:off x="6178143" y="1024128"/>
+            <a:ext cx="91440" cy="1664207"/>
+          </a:xfrm>
+          <a:prstGeom prst="roundRect">
+            <a:avLst/>
+          </a:prstGeom>
+          <a:solidFill>
+            <a:srgbClr val="7C5CD4"/>
+          </a:solidFill>
+          <a:ln>
+            <a:noFill/>
+          </a:ln>
+        </p:spPr>
+        <p:style>
+          <a:lnRef idx="1">
+            <a:schemeClr val="accent1"/>
+          </a:lnRef>
+          <a:fillRef idx="3">
+            <a:schemeClr val="accent1"/>
+          </a:fillRef>
+          <a:effectRef idx="2">
+            <a:schemeClr val="accent1"/>
+          </a:effectRef>
+          <a:fontRef idx="minor">
+            <a:schemeClr val="lt1"/>
+          </a:fontRef>
+        </p:style>
+        <p:txBody>
+          <a:bodyPr rtlCol="0" anchor="ctr"/>
+          <a:lstStyle/>
+          <a:p>
+            <a:pPr algn="ctr"/>
+          </a:p>
+        </p:txBody>
+      </p:sp>
+      <p:sp>
+        <p:nvSpPr>
+          <p:cNvPr id="41" name="Rounded Rectangle 40"/>
+          <p:cNvSpPr/>
+          <p:nvPr/>
+        </p:nvSpPr>
+        <p:spPr>
+          <a:xfrm>
+            <a:off x="6342735" y="1133856"/>
+            <a:ext cx="438912" cy="256032"/>
+          </a:xfrm>
+          <a:prstGeom prst="roundRect">
+            <a:avLst/>
+          </a:prstGeom>
+          <a:solidFill>
+            <a:srgbClr val="7C5CD4"/>
+          </a:solidFill>
+          <a:ln>
+            <a:noFill/>
+          </a:ln>
+        </p:spPr>
+        <p:style>
+          <a:lnRef idx="1">
+            <a:schemeClr val="accent1"/>
+          </a:lnRef>
+          <a:fillRef idx="3">
+            <a:schemeClr val="accent1"/>
+          </a:fillRef>
+          <a:effectRef idx="2">
+            <a:schemeClr val="accent1"/>
+          </a:effectRef>
+          <a:fontRef idx="minor">
+            <a:schemeClr val="lt1"/>
+          </a:fontRef>
+        </p:style>
+        <p:txBody>
+          <a:bodyPr rtlCol="0" anchor="ctr" wrap="square"/>
+          <a:lstStyle/>
+          <a:p>
+            <a:pPr algn="ctr"/>
+            <a:r>
+              <a:rPr sz="1100" b="1">
+                <a:solidFill>
+                  <a:srgbClr val="F8FAFC"/>
+                </a:solidFill>
+                <a:latin typeface="Calibri"/>
+              </a:rPr>
+              <a:t>03</a:t>
+            </a:r>
+          </a:p>
+        </p:txBody>
+      </p:sp>
+      <p:sp>
+        <p:nvSpPr>
+          <p:cNvPr id="42" name="TextBox 41"/>
+          <p:cNvSpPr txBox="1"/>
+          <p:nvPr/>
+        </p:nvSpPr>
+        <p:spPr>
+          <a:xfrm>
+            <a:off x="6836511" y="1115568"/>
+            <a:ext cx="2010079" cy="292608"/>
+          </a:xfrm>
+          <a:prstGeom prst="rect">
+            <a:avLst/>
+          </a:prstGeom>
+          <a:noFill/>
+        </p:spPr>
+        <p:txBody>
+          <a:bodyPr wrap="square">
+            <a:spAutoFit/>
+          </a:bodyPr>
+          <a:lstStyle/>
+          <a:p>
+            <a:pPr algn="l"/>
+            <a:r>
+              <a:rPr sz="1300" b="1">
+                <a:solidFill>
+                  <a:srgbClr val="141E2E"/>
+                </a:solidFill>
+                <a:latin typeface="Calibri"/>
+              </a:rPr>
+              <a:t>Containerization</a:t>
+            </a:r>
+          </a:p>
+        </p:txBody>
+      </p:sp>
+      <p:sp>
+        <p:nvSpPr>
+          <p:cNvPr id="43" name="TextBox 42"/>
+          <p:cNvSpPr txBox="1"/>
+          <p:nvPr/>
+        </p:nvSpPr>
+        <p:spPr>
+          <a:xfrm>
+            <a:off x="6836511" y="1371600"/>
+            <a:ext cx="2010079" cy="237744"/>
+          </a:xfrm>
+          <a:prstGeom prst="rect">
+            <a:avLst/>
+          </a:prstGeom>
+          <a:noFill/>
+        </p:spPr>
+        <p:txBody>
+          <a:bodyPr wrap="square">
+            <a:spAutoFit/>
+          </a:bodyPr>
+          <a:lstStyle/>
+          <a:p>
+            <a:pPr algn="l"/>
+            <a:r>
+              <a:rPr sz="1000" b="0">
+                <a:solidFill>
+                  <a:srgbClr val="606E7E"/>
+                </a:solidFill>
+                <a:latin typeface="Calibri"/>
+              </a:rPr>
+              <a:t>Docker &amp; Images</a:t>
+            </a:r>
+          </a:p>
+        </p:txBody>
+      </p:sp>
+      <p:pic>
+        <p:nvPicPr>
+          <p:cNvPr id="44" name="Picture 43" descr="docker.png"/>
+          <p:cNvPicPr>
+            <a:picLocks noChangeAspect="1"/>
+          </p:cNvPicPr>
+          <p:nvPr/>
+        </p:nvPicPr>
+        <p:blipFill>
+          <a:blip r:embed="rId6"/>
+          <a:stretch>
+            <a:fillRect/>
+          </a:stretch>
+        </p:blipFill>
+        <p:spPr>
+          <a:xfrm>
+            <a:off x="7388923" y="1664208"/>
+            <a:ext cx="365760" cy="365760"/>
+          </a:xfrm>
+          <a:prstGeom prst="rect">
+            <a:avLst/>
+          </a:prstGeom>
+        </p:spPr>
+      </p:pic>
+      <p:sp>
+        <p:nvSpPr>
+          <p:cNvPr id="45" name="Rounded Rectangle 44"/>
+          <p:cNvSpPr/>
+          <p:nvPr/>
+        </p:nvSpPr>
+        <p:spPr>
+          <a:xfrm>
+            <a:off x="9130055" y="1024128"/>
+            <a:ext cx="2787319" cy="1664207"/>
+          </a:xfrm>
+          <a:prstGeom prst="roundRect">
+            <a:avLst/>
+          </a:prstGeom>
+          <a:solidFill>
+            <a:srgbClr val="F8FAFC"/>
+          </a:solidFill>
+          <a:ln w="19050">
+            <a:solidFill>
+              <a:srgbClr val="E2E8F0"/>
+            </a:solidFill>
+          </a:ln>
+        </p:spPr>
+        <p:style>
+          <a:lnRef idx="1">
+            <a:schemeClr val="accent1"/>
+          </a:lnRef>
+          <a:fillRef idx="3">
+            <a:schemeClr val="accent1"/>
+          </a:fillRef>
+          <a:effectRef idx="2">
+            <a:schemeClr val="accent1"/>
+          </a:effectRef>
+          <a:fontRef idx="minor">
+            <a:schemeClr val="lt1"/>
+          </a:fontRef>
+        </p:style>
+        <p:txBody>
+          <a:bodyPr rtlCol="0" anchor="ctr"/>
+          <a:lstStyle/>
+          <a:p>
+            <a:pPr algn="ctr"/>
+          </a:p>
+        </p:txBody>
+      </p:sp>
+      <p:sp>
+        <p:nvSpPr>
+          <p:cNvPr id="46" name="Rounded Rectangle 45"/>
+          <p:cNvSpPr/>
+          <p:nvPr/>
+        </p:nvSpPr>
+        <p:spPr>
+          <a:xfrm>
+            <a:off x="9130055" y="1024128"/>
+            <a:ext cx="91440" cy="1664207"/>
+          </a:xfrm>
+          <a:prstGeom prst="roundRect">
+            <a:avLst/>
+          </a:prstGeom>
+          <a:solidFill>
+            <a:srgbClr val="7C5CD4"/>
+          </a:solidFill>
+          <a:ln>
+            <a:noFill/>
+          </a:ln>
+        </p:spPr>
+        <p:style>
+          <a:lnRef idx="1">
+            <a:schemeClr val="accent1"/>
+          </a:lnRef>
+          <a:fillRef idx="3">
+            <a:schemeClr val="accent1"/>
+          </a:fillRef>
+          <a:effectRef idx="2">
+            <a:schemeClr val="accent1"/>
+          </a:effectRef>
+          <a:fontRef idx="minor">
+            <a:schemeClr val="lt1"/>
+          </a:fontRef>
+        </p:style>
+        <p:txBody>
+          <a:bodyPr rtlCol="0" anchor="ctr"/>
+          <a:lstStyle/>
+          <a:p>
+            <a:pPr algn="ctr"/>
+          </a:p>
+        </p:txBody>
+      </p:sp>
+      <p:sp>
+        <p:nvSpPr>
+          <p:cNvPr id="47" name="Rounded Rectangle 46"/>
+          <p:cNvSpPr/>
+          <p:nvPr/>
+        </p:nvSpPr>
+        <p:spPr>
+          <a:xfrm>
+            <a:off x="9294647" y="1133856"/>
+            <a:ext cx="438912" cy="256032"/>
+          </a:xfrm>
+          <a:prstGeom prst="roundRect">
+            <a:avLst/>
+          </a:prstGeom>
+          <a:solidFill>
+            <a:srgbClr val="7C5CD4"/>
+          </a:solidFill>
+          <a:ln>
+            <a:noFill/>
+          </a:ln>
+        </p:spPr>
+        <p:style>
+          <a:lnRef idx="1">
+            <a:schemeClr val="accent1"/>
+          </a:lnRef>
+          <a:fillRef idx="3">
+            <a:schemeClr val="accent1"/>
+          </a:fillRef>
+          <a:effectRef idx="2">
+            <a:schemeClr val="accent1"/>
+          </a:effectRef>
+          <a:fontRef idx="minor">
+            <a:schemeClr val="lt1"/>
+          </a:fontRef>
+        </p:style>
+        <p:txBody>
+          <a:bodyPr rtlCol="0" anchor="ctr" wrap="square"/>
+          <a:lstStyle/>
+          <a:p>
+            <a:pPr algn="ctr"/>
+            <a:r>
+              <a:rPr sz="1100" b="1">
+                <a:solidFill>
+                  <a:srgbClr val="F8FAFC"/>
+                </a:solidFill>
+                <a:latin typeface="Calibri"/>
+              </a:rPr>
+              <a:t>04</a:t>
+            </a:r>
+          </a:p>
+        </p:txBody>
+      </p:sp>
+      <p:sp>
+        <p:nvSpPr>
+          <p:cNvPr id="48" name="TextBox 47"/>
+          <p:cNvSpPr txBox="1"/>
+          <p:nvPr/>
+        </p:nvSpPr>
+        <p:spPr>
+          <a:xfrm>
+            <a:off x="9788423" y="1115568"/>
+            <a:ext cx="2010079" cy="292608"/>
+          </a:xfrm>
+          <a:prstGeom prst="rect">
+            <a:avLst/>
+          </a:prstGeom>
+          <a:noFill/>
+        </p:spPr>
+        <p:txBody>
+          <a:bodyPr wrap="square">
+            <a:spAutoFit/>
+          </a:bodyPr>
+          <a:lstStyle/>
+          <a:p>
+            <a:pPr algn="l"/>
+            <a:r>
+              <a:rPr sz="1300" b="1">
+                <a:solidFill>
+                  <a:srgbClr val="141E2E"/>
+                </a:solidFill>
+                <a:latin typeface="Calibri"/>
+              </a:rPr>
+              <a:t>CI / CD</a:t>
+            </a:r>
+          </a:p>
+        </p:txBody>
+      </p:sp>
+      <p:sp>
+        <p:nvSpPr>
+          <p:cNvPr id="49" name="TextBox 48"/>
+          <p:cNvSpPr txBox="1"/>
+          <p:nvPr/>
+        </p:nvSpPr>
+        <p:spPr>
+          <a:xfrm>
+            <a:off x="9788423" y="1371600"/>
+            <a:ext cx="2010079" cy="237744"/>
+          </a:xfrm>
+          <a:prstGeom prst="rect">
+            <a:avLst/>
+          </a:prstGeom>
+          <a:noFill/>
+        </p:spPr>
+        <p:txBody>
+          <a:bodyPr wrap="square">
+            <a:spAutoFit/>
+          </a:bodyPr>
+          <a:lstStyle/>
+          <a:p>
+            <a:pPr algn="l"/>
+            <a:r>
+              <a:rPr sz="1000" b="0">
+                <a:solidFill>
+                  <a:srgbClr val="606E7E"/>
+                </a:solidFill>
+                <a:latin typeface="Calibri"/>
+              </a:rPr>
+              <a:t>Jenkins · GitHub Actions</a:t>
+            </a:r>
+          </a:p>
+        </p:txBody>
+      </p:sp>
+      <p:pic>
+        <p:nvPicPr>
+          <p:cNvPr id="50" name="Picture 49" descr="jenkins.png"/>
+          <p:cNvPicPr>
+            <a:picLocks noChangeAspect="1"/>
+          </p:cNvPicPr>
+          <p:nvPr/>
+        </p:nvPicPr>
+        <p:blipFill>
+          <a:blip r:embed="rId7"/>
+          <a:stretch>
+            <a:fillRect/>
+          </a:stretch>
+        </p:blipFill>
+        <p:spPr>
+          <a:xfrm>
+            <a:off x="10112235" y="1664208"/>
+            <a:ext cx="365760" cy="365760"/>
+          </a:xfrm>
+          <a:prstGeom prst="rect">
+            <a:avLst/>
+          </a:prstGeom>
+        </p:spPr>
+      </p:pic>
+      <p:pic>
+        <p:nvPicPr>
+          <p:cNvPr id="51" name="Picture 50" descr="githubactions.png"/>
+          <p:cNvPicPr>
+            <a:picLocks noChangeAspect="1"/>
+          </p:cNvPicPr>
+          <p:nvPr/>
+        </p:nvPicPr>
+        <p:blipFill>
+          <a:blip r:embed="rId8"/>
+          <a:stretch>
+            <a:fillRect/>
+          </a:stretch>
+        </p:blipFill>
+        <p:spPr>
+          <a:xfrm>
+            <a:off x="10569435" y="1664208"/>
+            <a:ext cx="365760" cy="365760"/>
+          </a:xfrm>
+          <a:prstGeom prst="rect">
+            <a:avLst/>
+          </a:prstGeom>
+        </p:spPr>
+      </p:pic>
+      <p:sp>
+        <p:nvSpPr>
+          <p:cNvPr id="52" name="Rounded Rectangle 51"/>
+          <p:cNvSpPr/>
+          <p:nvPr/>
+        </p:nvSpPr>
+        <p:spPr>
+          <a:xfrm>
+            <a:off x="274320" y="2834639"/>
+            <a:ext cx="2787319" cy="1664207"/>
+          </a:xfrm>
+          <a:prstGeom prst="roundRect">
+            <a:avLst/>
+          </a:prstGeom>
+          <a:solidFill>
+            <a:srgbClr val="F8FAFC"/>
+          </a:solidFill>
+          <a:ln w="19050">
+            <a:solidFill>
+              <a:srgbClr val="E2E8F0"/>
+            </a:solidFill>
+          </a:ln>
+        </p:spPr>
+        <p:style>
+          <a:lnRef idx="1">
+            <a:schemeClr val="accent1"/>
+          </a:lnRef>
+          <a:fillRef idx="3">
+            <a:schemeClr val="accent1"/>
+          </a:fillRef>
+          <a:effectRef idx="2">
+            <a:schemeClr val="accent1"/>
+          </a:effectRef>
+          <a:fontRef idx="minor">
+            <a:schemeClr val="lt1"/>
+          </a:fontRef>
+        </p:style>
+        <p:txBody>
+          <a:bodyPr rtlCol="0" anchor="ctr"/>
+          <a:lstStyle/>
+          <a:p>
+            <a:pPr algn="ctr"/>
+          </a:p>
+        </p:txBody>
+      </p:sp>
+      <p:sp>
+        <p:nvSpPr>
+          <p:cNvPr id="53" name="Rounded Rectangle 52"/>
+          <p:cNvSpPr/>
+          <p:nvPr/>
+        </p:nvSpPr>
+        <p:spPr>
+          <a:xfrm>
+            <a:off x="274320" y="2834639"/>
+            <a:ext cx="91440" cy="1664207"/>
+          </a:xfrm>
+          <a:prstGeom prst="roundRect">
+            <a:avLst/>
+          </a:prstGeom>
+          <a:solidFill>
+            <a:srgbClr val="387ED6"/>
+          </a:solidFill>
+          <a:ln>
+            <a:noFill/>
+          </a:ln>
+        </p:spPr>
+        <p:style>
+          <a:lnRef idx="1">
+            <a:schemeClr val="accent1"/>
+          </a:lnRef>
+          <a:fillRef idx="3">
+            <a:schemeClr val="accent1"/>
+          </a:fillRef>
+          <a:effectRef idx="2">
+            <a:schemeClr val="accent1"/>
+          </a:effectRef>
+          <a:fontRef idx="minor">
+            <a:schemeClr val="lt1"/>
+          </a:fontRef>
+        </p:style>
+        <p:txBody>
+          <a:bodyPr rtlCol="0" anchor="ctr"/>
+          <a:lstStyle/>
+          <a:p>
+            <a:pPr algn="ctr"/>
+          </a:p>
+        </p:txBody>
+      </p:sp>
+      <p:sp>
+        <p:nvSpPr>
+          <p:cNvPr id="54" name="Rounded Rectangle 53"/>
+          <p:cNvSpPr/>
+          <p:nvPr/>
+        </p:nvSpPr>
+        <p:spPr>
+          <a:xfrm>
+            <a:off x="438912" y="2944368"/>
+            <a:ext cx="438912" cy="256032"/>
+          </a:xfrm>
+          <a:prstGeom prst="roundRect">
+            <a:avLst/>
+          </a:prstGeom>
+          <a:solidFill>
+            <a:srgbClr val="387ED6"/>
+          </a:solidFill>
+          <a:ln>
+            <a:noFill/>
+          </a:ln>
+        </p:spPr>
+        <p:style>
+          <a:lnRef idx="1">
+            <a:schemeClr val="accent1"/>
+          </a:lnRef>
+          <a:fillRef idx="3">
+            <a:schemeClr val="accent1"/>
+          </a:fillRef>
+          <a:effectRef idx="2">
+            <a:schemeClr val="accent1"/>
+          </a:effectRef>
+          <a:fontRef idx="minor">
+            <a:schemeClr val="lt1"/>
+          </a:fontRef>
+        </p:style>
+        <p:txBody>
+          <a:bodyPr rtlCol="0" anchor="ctr" wrap="square"/>
+          <a:lstStyle/>
+          <a:p>
+            <a:pPr algn="ctr"/>
+            <a:r>
+              <a:rPr sz="1100" b="1">
+                <a:solidFill>
+                  <a:srgbClr val="F8FAFC"/>
+                </a:solidFill>
+                <a:latin typeface="Calibri"/>
+              </a:rPr>
+              <a:t>05</a:t>
+            </a:r>
+          </a:p>
+        </p:txBody>
+      </p:sp>
+      <p:sp>
+        <p:nvSpPr>
+          <p:cNvPr id="55" name="TextBox 54"/>
+          <p:cNvSpPr txBox="1"/>
+          <p:nvPr/>
+        </p:nvSpPr>
+        <p:spPr>
+          <a:xfrm>
+            <a:off x="932688" y="2926079"/>
+            <a:ext cx="2010079" cy="292608"/>
+          </a:xfrm>
+          <a:prstGeom prst="rect">
+            <a:avLst/>
+          </a:prstGeom>
+          <a:noFill/>
+        </p:spPr>
+        <p:txBody>
+          <a:bodyPr wrap="square">
+            <a:spAutoFit/>
+          </a:bodyPr>
+          <a:lstStyle/>
+          <a:p>
+            <a:pPr algn="l"/>
+            <a:r>
+              <a:rPr sz="1300" b="1">
+                <a:solidFill>
+                  <a:srgbClr val="141E2E"/>
+                </a:solidFill>
+                <a:latin typeface="Calibri"/>
+              </a:rPr>
+              <a:t>Cloud Platforms</a:t>
+            </a:r>
+          </a:p>
+        </p:txBody>
+      </p:sp>
+      <p:sp>
+        <p:nvSpPr>
+          <p:cNvPr id="56" name="TextBox 55"/>
+          <p:cNvSpPr txBox="1"/>
+          <p:nvPr/>
+        </p:nvSpPr>
+        <p:spPr>
+          <a:xfrm>
+            <a:off x="932688" y="3182111"/>
+            <a:ext cx="2010079" cy="237744"/>
+          </a:xfrm>
+          <a:prstGeom prst="rect">
+            <a:avLst/>
+          </a:prstGeom>
+          <a:noFill/>
+        </p:spPr>
+        <p:txBody>
+          <a:bodyPr wrap="square">
+            <a:spAutoFit/>
+          </a:bodyPr>
+          <a:lstStyle/>
+          <a:p>
+            <a:pPr algn="l"/>
+            <a:r>
+              <a:rPr sz="1000" b="0">
+                <a:solidFill>
+                  <a:srgbClr val="606E7E"/>
+                </a:solidFill>
+                <a:latin typeface="Calibri"/>
+              </a:rPr>
+              <a:t>EC2 · VPC · IAM · S3 · ECS/EKS</a:t>
+            </a:r>
+          </a:p>
+        </p:txBody>
+      </p:sp>
+      <p:pic>
+        <p:nvPicPr>
+          <p:cNvPr id="57" name="Picture 56" descr="amazonaws.png"/>
+          <p:cNvPicPr>
+            <a:picLocks noChangeAspect="1"/>
+          </p:cNvPicPr>
+          <p:nvPr/>
+        </p:nvPicPr>
+        <p:blipFill>
+          <a:blip r:embed="rId9"/>
+          <a:stretch>
+            <a:fillRect/>
+          </a:stretch>
+        </p:blipFill>
+        <p:spPr>
+          <a:xfrm>
+            <a:off x="1027899" y="3474720"/>
+            <a:ext cx="365760" cy="365760"/>
+          </a:xfrm>
+          <a:prstGeom prst="rect">
+            <a:avLst/>
+          </a:prstGeom>
+        </p:spPr>
+      </p:pic>
+      <p:pic>
+        <p:nvPicPr>
+          <p:cNvPr id="58" name="Picture 57" descr="googlecloud.png"/>
+          <p:cNvPicPr>
+            <a:picLocks noChangeAspect="1"/>
+          </p:cNvPicPr>
+          <p:nvPr/>
+        </p:nvPicPr>
+        <p:blipFill>
+          <a:blip r:embed="rId10"/>
+          <a:stretch>
+            <a:fillRect/>
+          </a:stretch>
+        </p:blipFill>
+        <p:spPr>
+          <a:xfrm>
+            <a:off x="1485099" y="3474720"/>
+            <a:ext cx="365760" cy="365760"/>
+          </a:xfrm>
+          <a:prstGeom prst="rect">
+            <a:avLst/>
+          </a:prstGeom>
+        </p:spPr>
+      </p:pic>
+      <p:pic>
+        <p:nvPicPr>
+          <p:cNvPr id="59" name="Picture 58" descr="microsoftazure.png"/>
+          <p:cNvPicPr>
+            <a:picLocks noChangeAspect="1"/>
+          </p:cNvPicPr>
+          <p:nvPr/>
+        </p:nvPicPr>
+        <p:blipFill>
+          <a:blip r:embed="rId11"/>
+          <a:stretch>
+            <a:fillRect/>
+          </a:stretch>
+        </p:blipFill>
+        <p:spPr>
+          <a:xfrm>
+            <a:off x="1942299" y="3474720"/>
+            <a:ext cx="365760" cy="365760"/>
+          </a:xfrm>
+          <a:prstGeom prst="rect">
+            <a:avLst/>
+          </a:prstGeom>
+        </p:spPr>
+      </p:pic>
+      <p:sp>
+        <p:nvSpPr>
+          <p:cNvPr id="60" name="Rounded Rectangle 59"/>
+          <p:cNvSpPr/>
+          <p:nvPr/>
+        </p:nvSpPr>
+        <p:spPr>
+          <a:xfrm>
+            <a:off x="3226231" y="2834639"/>
+            <a:ext cx="2787319" cy="1664207"/>
+          </a:xfrm>
+          <a:prstGeom prst="roundRect">
+            <a:avLst/>
+          </a:prstGeom>
+          <a:solidFill>
+            <a:srgbClr val="F8FAFC"/>
+          </a:solidFill>
+          <a:ln w="19050">
+            <a:solidFill>
+              <a:srgbClr val="E2E8F0"/>
+            </a:solidFill>
+          </a:ln>
+        </p:spPr>
+        <p:style>
+          <a:lnRef idx="1">
+            <a:schemeClr val="accent1"/>
+          </a:lnRef>
+          <a:fillRef idx="3">
+            <a:schemeClr val="accent1"/>
+          </a:fillRef>
+          <a:effectRef idx="2">
+            <a:schemeClr val="accent1"/>
+          </a:effectRef>
+          <a:fontRef idx="minor">
+            <a:schemeClr val="lt1"/>
+          </a:fontRef>
+        </p:style>
+        <p:txBody>
+          <a:bodyPr rtlCol="0" anchor="ctr"/>
+          <a:lstStyle/>
+          <a:p>
+            <a:pPr algn="ctr"/>
+          </a:p>
+        </p:txBody>
+      </p:sp>
+      <p:sp>
+        <p:nvSpPr>
+          <p:cNvPr id="61" name="Rounded Rectangle 60"/>
+          <p:cNvSpPr/>
+          <p:nvPr/>
+        </p:nvSpPr>
+        <p:spPr>
+          <a:xfrm>
+            <a:off x="3226231" y="2834639"/>
+            <a:ext cx="91440" cy="1664207"/>
+          </a:xfrm>
+          <a:prstGeom prst="roundRect">
+            <a:avLst/>
+          </a:prstGeom>
+          <a:solidFill>
+            <a:srgbClr val="4F46B4"/>
+          </a:solidFill>
+          <a:ln>
+            <a:noFill/>
+          </a:ln>
+        </p:spPr>
+        <p:style>
+          <a:lnRef idx="1">
+            <a:schemeClr val="accent1"/>
+          </a:lnRef>
+          <a:fillRef idx="3">
+            <a:schemeClr val="accent1"/>
+          </a:fillRef>
+          <a:effectRef idx="2">
+            <a:schemeClr val="accent1"/>
+          </a:effectRef>
+          <a:fontRef idx="minor">
+            <a:schemeClr val="lt1"/>
+          </a:fontRef>
+        </p:style>
+        <p:txBody>
+          <a:bodyPr rtlCol="0" anchor="ctr"/>
+          <a:lstStyle/>
+          <a:p>
+            <a:pPr algn="ctr"/>
+          </a:p>
+        </p:txBody>
+      </p:sp>
+      <p:sp>
+        <p:nvSpPr>
+          <p:cNvPr id="62" name="Rounded Rectangle 61"/>
+          <p:cNvSpPr/>
+          <p:nvPr/>
+        </p:nvSpPr>
+        <p:spPr>
+          <a:xfrm>
+            <a:off x="3390823" y="2944368"/>
+            <a:ext cx="438912" cy="256032"/>
+          </a:xfrm>
+          <a:prstGeom prst="roundRect">
+            <a:avLst/>
+          </a:prstGeom>
+          <a:solidFill>
+            <a:srgbClr val="4F46B4"/>
+          </a:solidFill>
+          <a:ln>
+            <a:noFill/>
+          </a:ln>
+        </p:spPr>
+        <p:style>
+          <a:lnRef idx="1">
+            <a:schemeClr val="accent1"/>
+          </a:lnRef>
+          <a:fillRef idx="3">
+            <a:schemeClr val="accent1"/>
+          </a:fillRef>
+          <a:effectRef idx="2">
+            <a:schemeClr val="accent1"/>
+          </a:effectRef>
+          <a:fontRef idx="minor">
+            <a:schemeClr val="lt1"/>
+          </a:fontRef>
+        </p:style>
+        <p:txBody>
+          <a:bodyPr rtlCol="0" anchor="ctr" wrap="square"/>
+          <a:lstStyle/>
+          <a:p>
+            <a:pPr algn="ctr"/>
+            <a:r>
+              <a:rPr sz="1100" b="1">
+                <a:solidFill>
+                  <a:srgbClr val="F8FAFC"/>
+                </a:solidFill>
+                <a:latin typeface="Calibri"/>
+              </a:rPr>
+              <a:t>06</a:t>
+            </a:r>
+          </a:p>
+        </p:txBody>
+      </p:sp>
+      <p:sp>
+        <p:nvSpPr>
+          <p:cNvPr id="63" name="TextBox 62"/>
+          <p:cNvSpPr txBox="1"/>
+          <p:nvPr/>
+        </p:nvSpPr>
+        <p:spPr>
+          <a:xfrm>
+            <a:off x="3884599" y="2926079"/>
+            <a:ext cx="2010079" cy="292608"/>
+          </a:xfrm>
+          <a:prstGeom prst="rect">
+            <a:avLst/>
+          </a:prstGeom>
+          <a:noFill/>
+        </p:spPr>
+        <p:txBody>
+          <a:bodyPr wrap="square">
+            <a:spAutoFit/>
+          </a:bodyPr>
+          <a:lstStyle/>
+          <a:p>
+            <a:pPr algn="l"/>
+            <a:r>
+              <a:rPr sz="1300" b="1">
+                <a:solidFill>
+                  <a:srgbClr val="141E2E"/>
+                </a:solidFill>
+                <a:latin typeface="Calibri"/>
+              </a:rPr>
+              <a:t>Infrastructure as Code</a:t>
+            </a:r>
+          </a:p>
+        </p:txBody>
+      </p:sp>
+      <p:sp>
+        <p:nvSpPr>
+          <p:cNvPr id="64" name="TextBox 63"/>
+          <p:cNvSpPr txBox="1"/>
+          <p:nvPr/>
+        </p:nvSpPr>
+        <p:spPr>
+          <a:xfrm>
+            <a:off x="3884599" y="3182111"/>
+            <a:ext cx="2010079" cy="237744"/>
+          </a:xfrm>
+          <a:prstGeom prst="rect">
+            <a:avLst/>
+          </a:prstGeom>
+          <a:noFill/>
+        </p:spPr>
+        <p:txBody>
+          <a:bodyPr wrap="square">
+            <a:spAutoFit/>
+          </a:bodyPr>
+          <a:lstStyle/>
+          <a:p>
+            <a:pPr algn="l"/>
+            <a:r>
+              <a:rPr sz="1000" b="0">
+                <a:solidFill>
+                  <a:srgbClr val="606E7E"/>
+                </a:solidFill>
+                <a:latin typeface="Calibri"/>
+              </a:rPr>
+              <a:t>Terraform · CloudFormation</a:t>
+            </a:r>
+          </a:p>
+        </p:txBody>
+      </p:sp>
+      <p:pic>
+        <p:nvPicPr>
+          <p:cNvPr id="65" name="Picture 64" descr="terraform.png"/>
+          <p:cNvPicPr>
+            <a:picLocks noChangeAspect="1"/>
+          </p:cNvPicPr>
+          <p:nvPr/>
+        </p:nvPicPr>
+        <p:blipFill>
+          <a:blip r:embed="rId12"/>
+          <a:stretch>
+            <a:fillRect/>
+          </a:stretch>
+        </p:blipFill>
+        <p:spPr>
+          <a:xfrm>
+            <a:off x="4208411" y="3474720"/>
+            <a:ext cx="365760" cy="365760"/>
+          </a:xfrm>
+          <a:prstGeom prst="rect">
+            <a:avLst/>
+          </a:prstGeom>
+        </p:spPr>
+      </p:pic>
+      <p:pic>
+        <p:nvPicPr>
+          <p:cNvPr id="66" name="Picture 65" descr="cloudformation.png"/>
+          <p:cNvPicPr>
+            <a:picLocks noChangeAspect="1"/>
+          </p:cNvPicPr>
+          <p:nvPr/>
+        </p:nvPicPr>
+        <p:blipFill>
+          <a:blip r:embed="rId13"/>
+          <a:stretch>
+            <a:fillRect/>
+          </a:stretch>
+        </p:blipFill>
+        <p:spPr>
+          <a:xfrm>
+            <a:off x="4665611" y="3474720"/>
+            <a:ext cx="365760" cy="365760"/>
+          </a:xfrm>
+          <a:prstGeom prst="rect">
+            <a:avLst/>
+          </a:prstGeom>
+        </p:spPr>
+      </p:pic>
+      <p:sp>
+        <p:nvSpPr>
+          <p:cNvPr id="67" name="Rounded Rectangle 66"/>
+          <p:cNvSpPr/>
+          <p:nvPr/>
+        </p:nvSpPr>
+        <p:spPr>
+          <a:xfrm>
+            <a:off x="6178143" y="2834639"/>
+            <a:ext cx="2787319" cy="1664207"/>
+          </a:xfrm>
+          <a:prstGeom prst="roundRect">
+            <a:avLst/>
+          </a:prstGeom>
+          <a:solidFill>
+            <a:srgbClr val="F8FAFC"/>
+          </a:solidFill>
+          <a:ln w="19050">
+            <a:solidFill>
+              <a:srgbClr val="E2E8F0"/>
+            </a:solidFill>
+          </a:ln>
+        </p:spPr>
+        <p:style>
+          <a:lnRef idx="1">
+            <a:schemeClr val="accent1"/>
+          </a:lnRef>
+          <a:fillRef idx="3">
+            <a:schemeClr val="accent1"/>
+          </a:fillRef>
+          <a:effectRef idx="2">
+            <a:schemeClr val="accent1"/>
+          </a:effectRef>
+          <a:fontRef idx="minor">
+            <a:schemeClr val="lt1"/>
+          </a:fontRef>
+        </p:style>
+        <p:txBody>
+          <a:bodyPr rtlCol="0" anchor="ctr"/>
+          <a:lstStyle/>
+          <a:p>
+            <a:pPr algn="ctr"/>
+          </a:p>
+        </p:txBody>
+      </p:sp>
+      <p:sp>
+        <p:nvSpPr>
+          <p:cNvPr id="68" name="Rounded Rectangle 67"/>
+          <p:cNvSpPr/>
+          <p:nvPr/>
+        </p:nvSpPr>
+        <p:spPr>
+          <a:xfrm>
+            <a:off x="6178143" y="2834639"/>
+            <a:ext cx="91440" cy="1664207"/>
+          </a:xfrm>
+          <a:prstGeom prst="roundRect">
+            <a:avLst/>
+          </a:prstGeom>
+          <a:solidFill>
+            <a:srgbClr val="4F46B4"/>
+          </a:solidFill>
+          <a:ln>
+            <a:noFill/>
+          </a:ln>
+        </p:spPr>
+        <p:style>
+          <a:lnRef idx="1">
+            <a:schemeClr val="accent1"/>
+          </a:lnRef>
+          <a:fillRef idx="3">
+            <a:schemeClr val="accent1"/>
+          </a:fillRef>
+          <a:effectRef idx="2">
+            <a:schemeClr val="accent1"/>
+          </a:effectRef>
+          <a:fontRef idx="minor">
+            <a:schemeClr val="lt1"/>
+          </a:fontRef>
+        </p:style>
+        <p:txBody>
+          <a:bodyPr rtlCol="0" anchor="ctr"/>
+          <a:lstStyle/>
+          <a:p>
+            <a:pPr algn="ctr"/>
+          </a:p>
+        </p:txBody>
+      </p:sp>
+      <p:sp>
+        <p:nvSpPr>
+          <p:cNvPr id="69" name="Rounded Rectangle 68"/>
+          <p:cNvSpPr/>
+          <p:nvPr/>
+        </p:nvSpPr>
+        <p:spPr>
+          <a:xfrm>
+            <a:off x="6342735" y="2944368"/>
+            <a:ext cx="438912" cy="256032"/>
+          </a:xfrm>
+          <a:prstGeom prst="roundRect">
+            <a:avLst/>
+          </a:prstGeom>
+          <a:solidFill>
+            <a:srgbClr val="4F46B4"/>
+          </a:solidFill>
+          <a:ln>
+            <a:noFill/>
+          </a:ln>
+        </p:spPr>
+        <p:style>
+          <a:lnRef idx="1">
+            <a:schemeClr val="accent1"/>
+          </a:lnRef>
+          <a:fillRef idx="3">
+            <a:schemeClr val="accent1"/>
+          </a:fillRef>
+          <a:effectRef idx="2">
+            <a:schemeClr val="accent1"/>
+          </a:effectRef>
+          <a:fontRef idx="minor">
+            <a:schemeClr val="lt1"/>
+          </a:fontRef>
+        </p:style>
+        <p:txBody>
+          <a:bodyPr rtlCol="0" anchor="ctr" wrap="square"/>
+          <a:lstStyle/>
+          <a:p>
+            <a:pPr algn="ctr"/>
+            <a:r>
+              <a:rPr sz="1100" b="1">
+                <a:solidFill>
+                  <a:srgbClr val="F8FAFC"/>
+                </a:solidFill>
+                <a:latin typeface="Calibri"/>
+              </a:rPr>
+              <a:t>07</a:t>
+            </a:r>
+          </a:p>
+        </p:txBody>
+      </p:sp>
+      <p:sp>
+        <p:nvSpPr>
+          <p:cNvPr id="70" name="TextBox 69"/>
+          <p:cNvSpPr txBox="1"/>
+          <p:nvPr/>
+        </p:nvSpPr>
+        <p:spPr>
+          <a:xfrm>
+            <a:off x="6836511" y="2926079"/>
+            <a:ext cx="2010079" cy="292608"/>
+          </a:xfrm>
+          <a:prstGeom prst="rect">
+            <a:avLst/>
+          </a:prstGeom>
+          <a:noFill/>
+        </p:spPr>
+        <p:txBody>
+          <a:bodyPr wrap="square">
+            <a:spAutoFit/>
+          </a:bodyPr>
+          <a:lstStyle/>
+          <a:p>
+            <a:pPr algn="l"/>
+            <a:r>
+              <a:rPr sz="1300" b="1">
+                <a:solidFill>
+                  <a:srgbClr val="141E2E"/>
+                </a:solidFill>
+                <a:latin typeface="Calibri"/>
+              </a:rPr>
+              <a:t>Config &amp; Automation</a:t>
+            </a:r>
+          </a:p>
+        </p:txBody>
+      </p:sp>
+      <p:sp>
+        <p:nvSpPr>
+          <p:cNvPr id="71" name="TextBox 70"/>
+          <p:cNvSpPr txBox="1"/>
+          <p:nvPr/>
+        </p:nvSpPr>
+        <p:spPr>
+          <a:xfrm>
+            <a:off x="6836511" y="3182111"/>
+            <a:ext cx="2010079" cy="237744"/>
+          </a:xfrm>
+          <a:prstGeom prst="rect">
+            <a:avLst/>
+          </a:prstGeom>
+          <a:noFill/>
+        </p:spPr>
+        <p:txBody>
+          <a:bodyPr wrap="square">
+            <a:spAutoFit/>
+          </a:bodyPr>
+          <a:lstStyle/>
+          <a:p>
+            <a:pPr algn="l"/>
+            <a:r>
+              <a:rPr sz="1000" b="0">
+                <a:solidFill>
+                  <a:srgbClr val="606E7E"/>
+                </a:solidFill>
+                <a:latin typeface="Calibri"/>
+              </a:rPr>
+              <a:t>Ansible · AWS SSM</a:t>
+            </a:r>
+          </a:p>
+        </p:txBody>
+      </p:sp>
+      <p:pic>
+        <p:nvPicPr>
+          <p:cNvPr id="72" name="Picture 71" descr="ansible.png"/>
+          <p:cNvPicPr>
+            <a:picLocks noChangeAspect="1"/>
+          </p:cNvPicPr>
+          <p:nvPr/>
+        </p:nvPicPr>
+        <p:blipFill>
+          <a:blip r:embed="rId14"/>
+          <a:stretch>
+            <a:fillRect/>
+          </a:stretch>
+        </p:blipFill>
+        <p:spPr>
+          <a:xfrm>
+            <a:off x="7388923" y="3474720"/>
+            <a:ext cx="365760" cy="365760"/>
+          </a:xfrm>
+          <a:prstGeom prst="rect">
+            <a:avLst/>
+          </a:prstGeom>
+        </p:spPr>
+      </p:pic>
+      <p:sp>
+        <p:nvSpPr>
+          <p:cNvPr id="73" name="Rounded Rectangle 72"/>
+          <p:cNvSpPr/>
+          <p:nvPr/>
+        </p:nvSpPr>
+        <p:spPr>
+          <a:xfrm>
+            <a:off x="9130055" y="2834639"/>
+            <a:ext cx="2787319" cy="1664207"/>
+          </a:xfrm>
+          <a:prstGeom prst="roundRect">
+            <a:avLst/>
+          </a:prstGeom>
+          <a:solidFill>
+            <a:srgbClr val="F8FAFC"/>
+          </a:solidFill>
+          <a:ln w="19050">
+            <a:solidFill>
+              <a:srgbClr val="E2E8F0"/>
+            </a:solidFill>
+          </a:ln>
+        </p:spPr>
+        <p:style>
+          <a:lnRef idx="1">
+            <a:schemeClr val="accent1"/>
+          </a:lnRef>
+          <a:fillRef idx="3">
+            <a:schemeClr val="accent1"/>
+          </a:fillRef>
+          <a:effectRef idx="2">
+            <a:schemeClr val="accent1"/>
+          </a:effectRef>
+          <a:fontRef idx="minor">
+            <a:schemeClr val="lt1"/>
+          </a:fontRef>
+        </p:style>
+        <p:txBody>
+          <a:bodyPr rtlCol="0" anchor="ctr"/>
+          <a:lstStyle/>
+          <a:p>
+            <a:pPr algn="ctr"/>
+          </a:p>
+        </p:txBody>
+      </p:sp>
+      <p:sp>
+        <p:nvSpPr>
+          <p:cNvPr id="74" name="Rounded Rectangle 73"/>
+          <p:cNvSpPr/>
+          <p:nvPr/>
+        </p:nvSpPr>
+        <p:spPr>
+          <a:xfrm>
+            <a:off x="9130055" y="2834639"/>
+            <a:ext cx="91440" cy="1664207"/>
+          </a:xfrm>
+          <a:prstGeom prst="roundRect">
+            <a:avLst/>
+          </a:prstGeom>
+          <a:solidFill>
+            <a:srgbClr val="4F46B4"/>
+          </a:solidFill>
+          <a:ln>
+            <a:noFill/>
+          </a:ln>
+        </p:spPr>
+        <p:style>
+          <a:lnRef idx="1">
+            <a:schemeClr val="accent1"/>
+          </a:lnRef>
+          <a:fillRef idx="3">
+            <a:schemeClr val="accent1"/>
+          </a:fillRef>
+          <a:effectRef idx="2">
+            <a:schemeClr val="accent1"/>
+          </a:effectRef>
+          <a:fontRef idx="minor">
+            <a:schemeClr val="lt1"/>
+          </a:fontRef>
+        </p:style>
+        <p:txBody>
+          <a:bodyPr rtlCol="0" anchor="ctr"/>
+          <a:lstStyle/>
+          <a:p>
+            <a:pPr algn="ctr"/>
+          </a:p>
+        </p:txBody>
+      </p:sp>
+      <p:sp>
+        <p:nvSpPr>
+          <p:cNvPr id="75" name="Rounded Rectangle 74"/>
+          <p:cNvSpPr/>
+          <p:nvPr/>
+        </p:nvSpPr>
+        <p:spPr>
+          <a:xfrm>
+            <a:off x="9294647" y="2944368"/>
+            <a:ext cx="438912" cy="256032"/>
+          </a:xfrm>
+          <a:prstGeom prst="roundRect">
+            <a:avLst/>
+          </a:prstGeom>
+          <a:solidFill>
+            <a:srgbClr val="4F46B4"/>
+          </a:solidFill>
+          <a:ln>
+            <a:noFill/>
+          </a:ln>
+        </p:spPr>
+        <p:style>
+          <a:lnRef idx="1">
+            <a:schemeClr val="accent1"/>
+          </a:lnRef>
+          <a:fillRef idx="3">
+            <a:schemeClr val="accent1"/>
+          </a:fillRef>
+          <a:effectRef idx="2">
+            <a:schemeClr val="accent1"/>
+          </a:effectRef>
+          <a:fontRef idx="minor">
+            <a:schemeClr val="lt1"/>
+          </a:fontRef>
+        </p:style>
+        <p:txBody>
+          <a:bodyPr rtlCol="0" anchor="ctr" wrap="square"/>
+          <a:lstStyle/>
+          <a:p>
+            <a:pPr algn="ctr"/>
+            <a:r>
+              <a:rPr sz="1100" b="1">
+                <a:solidFill>
+                  <a:srgbClr val="F8FAFC"/>
+                </a:solidFill>
+                <a:latin typeface="Calibri"/>
+              </a:rPr>
+              <a:t>08</a:t>
+            </a:r>
+          </a:p>
+        </p:txBody>
+      </p:sp>
+      <p:sp>
+        <p:nvSpPr>
+          <p:cNvPr id="76" name="TextBox 75"/>
+          <p:cNvSpPr txBox="1"/>
+          <p:nvPr/>
+        </p:nvSpPr>
+        <p:spPr>
+          <a:xfrm>
+            <a:off x="9788423" y="2926079"/>
+            <a:ext cx="2010079" cy="292608"/>
+          </a:xfrm>
+          <a:prstGeom prst="rect">
+            <a:avLst/>
+          </a:prstGeom>
+          <a:noFill/>
+        </p:spPr>
+        <p:txBody>
+          <a:bodyPr wrap="square">
+            <a:spAutoFit/>
+          </a:bodyPr>
+          <a:lstStyle/>
+          <a:p>
+            <a:pPr algn="l"/>
+            <a:r>
+              <a:rPr sz="1300" b="1">
+                <a:solidFill>
+                  <a:srgbClr val="141E2E"/>
+                </a:solidFill>
+                <a:latin typeface="Calibri"/>
+              </a:rPr>
+              <a:t>Kubernetes</a:t>
+            </a:r>
+          </a:p>
+        </p:txBody>
+      </p:sp>
+      <p:sp>
+        <p:nvSpPr>
+          <p:cNvPr id="77" name="TextBox 76"/>
+          <p:cNvSpPr txBox="1"/>
+          <p:nvPr/>
+        </p:nvSpPr>
+        <p:spPr>
+          <a:xfrm>
+            <a:off x="9788423" y="3182111"/>
+            <a:ext cx="2010079" cy="237744"/>
+          </a:xfrm>
+          <a:prstGeom prst="rect">
+            <a:avLst/>
+          </a:prstGeom>
+          <a:noFill/>
+        </p:spPr>
+        <p:txBody>
+          <a:bodyPr wrap="square">
+            <a:spAutoFit/>
+          </a:bodyPr>
+          <a:lstStyle/>
+          <a:p>
+            <a:pPr algn="l"/>
+            <a:r>
+              <a:rPr sz="1000" b="0">
+                <a:solidFill>
+                  <a:srgbClr val="606E7E"/>
+                </a:solidFill>
+                <a:latin typeface="Calibri"/>
+              </a:rPr>
+              <a:t>K8s · Helm</a:t>
+            </a:r>
+          </a:p>
+        </p:txBody>
+      </p:sp>
+      <p:pic>
+        <p:nvPicPr>
+          <p:cNvPr id="78" name="Picture 77" descr="kubernetes.png"/>
+          <p:cNvPicPr>
+            <a:picLocks noChangeAspect="1"/>
+          </p:cNvPicPr>
+          <p:nvPr/>
+        </p:nvPicPr>
+        <p:blipFill>
+          <a:blip r:embed="rId15"/>
+          <a:stretch>
+            <a:fillRect/>
+          </a:stretch>
+        </p:blipFill>
+        <p:spPr>
+          <a:xfrm>
+            <a:off x="10112235" y="3474720"/>
+            <a:ext cx="365760" cy="365760"/>
+          </a:xfrm>
+          <a:prstGeom prst="rect">
+            <a:avLst/>
+          </a:prstGeom>
+        </p:spPr>
+      </p:pic>
+      <p:pic>
+        <p:nvPicPr>
+          <p:cNvPr id="79" name="Picture 78" descr="helm.png"/>
+          <p:cNvPicPr>
+            <a:picLocks noChangeAspect="1"/>
+          </p:cNvPicPr>
+          <p:nvPr/>
+        </p:nvPicPr>
+        <p:blipFill>
+          <a:blip r:embed="rId16"/>
+          <a:stretch>
+            <a:fillRect/>
+          </a:stretch>
+        </p:blipFill>
+        <p:spPr>
+          <a:xfrm>
+            <a:off x="10569435" y="3474720"/>
+            <a:ext cx="365760" cy="365760"/>
+          </a:xfrm>
+          <a:prstGeom prst="rect">
+            <a:avLst/>
+          </a:prstGeom>
+        </p:spPr>
+      </p:pic>
+      <p:sp>
+        <p:nvSpPr>
+          <p:cNvPr id="80" name="Rounded Rectangle 79"/>
+          <p:cNvSpPr/>
+          <p:nvPr/>
+        </p:nvSpPr>
+        <p:spPr>
+          <a:xfrm>
+            <a:off x="274320" y="4645151"/>
+            <a:ext cx="2787319" cy="1664207"/>
+          </a:xfrm>
+          <a:prstGeom prst="roundRect">
+            <a:avLst/>
+          </a:prstGeom>
+          <a:solidFill>
+            <a:srgbClr val="F8FAFC"/>
+          </a:solidFill>
+          <a:ln w="19050">
+            <a:solidFill>
+              <a:srgbClr val="E2E8F0"/>
+            </a:solidFill>
+          </a:ln>
+        </p:spPr>
+        <p:style>
+          <a:lnRef idx="1">
+            <a:schemeClr val="accent1"/>
+          </a:lnRef>
+          <a:fillRef idx="3">
+            <a:schemeClr val="accent1"/>
+          </a:fillRef>
+          <a:effectRef idx="2">
+            <a:schemeClr val="accent1"/>
+          </a:effectRef>
+          <a:fontRef idx="minor">
+            <a:schemeClr val="lt1"/>
+          </a:fontRef>
+        </p:style>
+        <p:txBody>
+          <a:bodyPr rtlCol="0" anchor="ctr"/>
+          <a:lstStyle/>
+          <a:p>
+            <a:pPr algn="ctr"/>
+          </a:p>
+        </p:txBody>
+      </p:sp>
+      <p:sp>
+        <p:nvSpPr>
+          <p:cNvPr id="81" name="Rounded Rectangle 80"/>
+          <p:cNvSpPr/>
+          <p:nvPr/>
+        </p:nvSpPr>
+        <p:spPr>
+          <a:xfrm>
+            <a:off x="274320" y="4645151"/>
+            <a:ext cx="91440" cy="1664207"/>
+          </a:xfrm>
+          <a:prstGeom prst="roundRect">
+            <a:avLst/>
+          </a:prstGeom>
+          <a:solidFill>
+            <a:srgbClr val="22A062"/>
+          </a:solidFill>
+          <a:ln>
+            <a:noFill/>
+          </a:ln>
+        </p:spPr>
+        <p:style>
+          <a:lnRef idx="1">
+            <a:schemeClr val="accent1"/>
+          </a:lnRef>
+          <a:fillRef idx="3">
+            <a:schemeClr val="accent1"/>
+          </a:fillRef>
+          <a:effectRef idx="2">
+            <a:schemeClr val="accent1"/>
+          </a:effectRef>
+          <a:fontRef idx="minor">
+            <a:schemeClr val="lt1"/>
+          </a:fontRef>
+        </p:style>
+        <p:txBody>
+          <a:bodyPr rtlCol="0" anchor="ctr"/>
+          <a:lstStyle/>
+          <a:p>
+            <a:pPr algn="ctr"/>
+          </a:p>
+        </p:txBody>
+      </p:sp>
+      <p:sp>
+        <p:nvSpPr>
+          <p:cNvPr id="82" name="Rounded Rectangle 81"/>
+          <p:cNvSpPr/>
+          <p:nvPr/>
+        </p:nvSpPr>
+        <p:spPr>
+          <a:xfrm>
+            <a:off x="438912" y="4754879"/>
+            <a:ext cx="438912" cy="256032"/>
+          </a:xfrm>
+          <a:prstGeom prst="roundRect">
+            <a:avLst/>
+          </a:prstGeom>
+          <a:solidFill>
+            <a:srgbClr val="22A062"/>
+          </a:solidFill>
+          <a:ln>
+            <a:noFill/>
+          </a:ln>
+        </p:spPr>
+        <p:style>
+          <a:lnRef idx="1">
+            <a:schemeClr val="accent1"/>
+          </a:lnRef>
+          <a:fillRef idx="3">
+            <a:schemeClr val="accent1"/>
+          </a:fillRef>
+          <a:effectRef idx="2">
+            <a:schemeClr val="accent1"/>
+          </a:effectRef>
+          <a:fontRef idx="minor">
+            <a:schemeClr val="lt1"/>
+          </a:fontRef>
+        </p:style>
+        <p:txBody>
+          <a:bodyPr rtlCol="0" anchor="ctr" wrap="square"/>
+          <a:lstStyle/>
+          <a:p>
+            <a:pPr algn="ctr"/>
+            <a:r>
+              <a:rPr sz="1100" b="1">
+                <a:solidFill>
+                  <a:srgbClr val="F8FAFC"/>
+                </a:solidFill>
+                <a:latin typeface="Calibri"/>
+              </a:rPr>
+              <a:t>09</a:t>
+            </a:r>
+          </a:p>
+        </p:txBody>
+      </p:sp>
+      <p:sp>
+        <p:nvSpPr>
+          <p:cNvPr id="83" name="TextBox 82"/>
+          <p:cNvSpPr txBox="1"/>
+          <p:nvPr/>
+        </p:nvSpPr>
+        <p:spPr>
+          <a:xfrm>
+            <a:off x="932688" y="4736591"/>
+            <a:ext cx="2010079" cy="292608"/>
+          </a:xfrm>
+          <a:prstGeom prst="rect">
+            <a:avLst/>
+          </a:prstGeom>
+          <a:noFill/>
+        </p:spPr>
+        <p:txBody>
+          <a:bodyPr wrap="square">
+            <a:spAutoFit/>
+          </a:bodyPr>
+          <a:lstStyle/>
+          <a:p>
+            <a:pPr algn="l"/>
+            <a:r>
+              <a:rPr sz="1300" b="1">
+                <a:solidFill>
+                  <a:srgbClr val="141E2E"/>
+                </a:solidFill>
+                <a:latin typeface="Calibri"/>
+              </a:rPr>
+              <a:t>Security</a:t>
+            </a:r>
+          </a:p>
+        </p:txBody>
+      </p:sp>
+      <p:sp>
+        <p:nvSpPr>
+          <p:cNvPr id="84" name="TextBox 83"/>
+          <p:cNvSpPr txBox="1"/>
+          <p:nvPr/>
+        </p:nvSpPr>
+        <p:spPr>
+          <a:xfrm>
+            <a:off x="932688" y="4992623"/>
+            <a:ext cx="2010079" cy="237744"/>
+          </a:xfrm>
+          <a:prstGeom prst="rect">
+            <a:avLst/>
+          </a:prstGeom>
+          <a:noFill/>
+        </p:spPr>
+        <p:txBody>
+          <a:bodyPr wrap="square">
+            <a:spAutoFit/>
+          </a:bodyPr>
+          <a:lstStyle/>
+          <a:p>
+            <a:pPr algn="l"/>
+            <a:r>
+              <a:rPr sz="1000" b="0">
+                <a:solidFill>
+                  <a:srgbClr val="606E7E"/>
+                </a:solidFill>
+                <a:latin typeface="Calibri"/>
+              </a:rPr>
+              <a:t>IAM · Scanning · Secrets</a:t>
+            </a:r>
+          </a:p>
+        </p:txBody>
+      </p:sp>
+      <p:pic>
+        <p:nvPicPr>
+          <p:cNvPr id="85" name="Picture 84" descr="security.png"/>
+          <p:cNvPicPr>
+            <a:picLocks noChangeAspect="1"/>
+          </p:cNvPicPr>
+          <p:nvPr/>
+        </p:nvPicPr>
+        <p:blipFill>
+          <a:blip r:embed="rId17"/>
+          <a:stretch>
+            <a:fillRect/>
+          </a:stretch>
+        </p:blipFill>
+        <p:spPr>
+          <a:xfrm>
+            <a:off x="1485099" y="5285231"/>
+            <a:ext cx="365760" cy="365760"/>
+          </a:xfrm>
+          <a:prstGeom prst="rect">
+            <a:avLst/>
+          </a:prstGeom>
+        </p:spPr>
+      </p:pic>
+      <p:sp>
+        <p:nvSpPr>
+          <p:cNvPr id="86" name="Rounded Rectangle 85"/>
+          <p:cNvSpPr/>
+          <p:nvPr/>
+        </p:nvSpPr>
+        <p:spPr>
+          <a:xfrm>
+            <a:off x="3226231" y="4645151"/>
+            <a:ext cx="2787319" cy="1664207"/>
+          </a:xfrm>
+          <a:prstGeom prst="roundRect">
+            <a:avLst/>
+          </a:prstGeom>
+          <a:solidFill>
+            <a:srgbClr val="F8FAFC"/>
+          </a:solidFill>
+          <a:ln w="19050">
+            <a:solidFill>
+              <a:srgbClr val="E2E8F0"/>
+            </a:solidFill>
+          </a:ln>
+        </p:spPr>
+        <p:style>
+          <a:lnRef idx="1">
+            <a:schemeClr val="accent1"/>
+          </a:lnRef>
+          <a:fillRef idx="3">
+            <a:schemeClr val="accent1"/>
+          </a:fillRef>
+          <a:effectRef idx="2">
+            <a:schemeClr val="accent1"/>
+          </a:effectRef>
+          <a:fontRef idx="minor">
+            <a:schemeClr val="lt1"/>
+          </a:fontRef>
+        </p:style>
+        <p:txBody>
+          <a:bodyPr rtlCol="0" anchor="ctr"/>
+          <a:lstStyle/>
+          <a:p>
+            <a:pPr algn="ctr"/>
+          </a:p>
+        </p:txBody>
+      </p:sp>
+      <p:sp>
+        <p:nvSpPr>
+          <p:cNvPr id="87" name="Rounded Rectangle 86"/>
+          <p:cNvSpPr/>
+          <p:nvPr/>
+        </p:nvSpPr>
+        <p:spPr>
+          <a:xfrm>
+            <a:off x="3226231" y="4645151"/>
+            <a:ext cx="91440" cy="1664207"/>
+          </a:xfrm>
+          <a:prstGeom prst="roundRect">
+            <a:avLst/>
+          </a:prstGeom>
+          <a:solidFill>
+            <a:srgbClr val="22A062"/>
+          </a:solidFill>
+          <a:ln>
+            <a:noFill/>
+          </a:ln>
+        </p:spPr>
+        <p:style>
+          <a:lnRef idx="1">
+            <a:schemeClr val="accent1"/>
+          </a:lnRef>
+          <a:fillRef idx="3">
+            <a:schemeClr val="accent1"/>
+          </a:fillRef>
+          <a:effectRef idx="2">
+            <a:schemeClr val="accent1"/>
+          </a:effectRef>
+          <a:fontRef idx="minor">
+            <a:schemeClr val="lt1"/>
+          </a:fontRef>
+        </p:style>
+        <p:txBody>
+          <a:bodyPr rtlCol="0" anchor="ctr"/>
+          <a:lstStyle/>
+          <a:p>
+            <a:pPr algn="ctr"/>
+          </a:p>
+        </p:txBody>
+      </p:sp>
+      <p:sp>
+        <p:nvSpPr>
+          <p:cNvPr id="88" name="Rounded Rectangle 87"/>
+          <p:cNvSpPr/>
+          <p:nvPr/>
+        </p:nvSpPr>
+        <p:spPr>
+          <a:xfrm>
+            <a:off x="3390823" y="4754879"/>
+            <a:ext cx="438912" cy="256032"/>
+          </a:xfrm>
+          <a:prstGeom prst="roundRect">
+            <a:avLst/>
+          </a:prstGeom>
+          <a:solidFill>
+            <a:srgbClr val="22A062"/>
+          </a:solidFill>
+          <a:ln>
+            <a:noFill/>
+          </a:ln>
+        </p:spPr>
+        <p:style>
+          <a:lnRef idx="1">
+            <a:schemeClr val="accent1"/>
+          </a:lnRef>
+          <a:fillRef idx="3">
+            <a:schemeClr val="accent1"/>
+          </a:fillRef>
+          <a:effectRef idx="2">
+            <a:schemeClr val="accent1"/>
+          </a:effectRef>
+          <a:fontRef idx="minor">
+            <a:schemeClr val="lt1"/>
+          </a:fontRef>
+        </p:style>
+        <p:txBody>
+          <a:bodyPr rtlCol="0" anchor="ctr" wrap="square"/>
+          <a:lstStyle/>
+          <a:p>
+            <a:pPr algn="ctr"/>
+            <a:r>
+              <a:rPr sz="1100" b="1">
+                <a:solidFill>
+                  <a:srgbClr val="F8FAFC"/>
+                </a:solidFill>
+                <a:latin typeface="Calibri"/>
+              </a:rPr>
+              <a:t>10</a:t>
+            </a:r>
+          </a:p>
+        </p:txBody>
+      </p:sp>
+      <p:sp>
+        <p:nvSpPr>
+          <p:cNvPr id="89" name="TextBox 88"/>
+          <p:cNvSpPr txBox="1"/>
+          <p:nvPr/>
+        </p:nvSpPr>
+        <p:spPr>
+          <a:xfrm>
+            <a:off x="3884599" y="4736591"/>
+            <a:ext cx="2010079" cy="292608"/>
+          </a:xfrm>
+          <a:prstGeom prst="rect">
+            <a:avLst/>
+          </a:prstGeom>
+          <a:noFill/>
+        </p:spPr>
+        <p:txBody>
+          <a:bodyPr wrap="square">
+            <a:spAutoFit/>
+          </a:bodyPr>
+          <a:lstStyle/>
+          <a:p>
+            <a:pPr algn="l"/>
+            <a:r>
+              <a:rPr sz="1300" b="1">
+                <a:solidFill>
+                  <a:srgbClr val="141E2E"/>
+                </a:solidFill>
+                <a:latin typeface="Calibri"/>
+              </a:rPr>
+              <a:t>Observability</a:t>
+            </a:r>
+          </a:p>
+        </p:txBody>
+      </p:sp>
+      <p:sp>
+        <p:nvSpPr>
+          <p:cNvPr id="90" name="TextBox 89"/>
+          <p:cNvSpPr txBox="1"/>
+          <p:nvPr/>
+        </p:nvSpPr>
+        <p:spPr>
+          <a:xfrm>
+            <a:off x="3884599" y="4992623"/>
+            <a:ext cx="2010079" cy="237744"/>
+          </a:xfrm>
+          <a:prstGeom prst="rect">
+            <a:avLst/>
+          </a:prstGeom>
+          <a:noFill/>
+        </p:spPr>
+        <p:txBody>
+          <a:bodyPr wrap="square">
+            <a:spAutoFit/>
+          </a:bodyPr>
+          <a:lstStyle/>
+          <a:p>
+            <a:pPr algn="l"/>
+            <a:r>
+              <a:rPr sz="1000" b="0">
+                <a:solidFill>
+                  <a:srgbClr val="606E7E"/>
+                </a:solidFill>
+                <a:latin typeface="Calibri"/>
+              </a:rPr>
+              <a:t>Prometheus · Grafana · Logs</a:t>
+            </a:r>
+          </a:p>
+        </p:txBody>
+      </p:sp>
+      <p:pic>
+        <p:nvPicPr>
+          <p:cNvPr id="91" name="Picture 90" descr="prometheus.png"/>
+          <p:cNvPicPr>
+            <a:picLocks noChangeAspect="1"/>
+          </p:cNvPicPr>
+          <p:nvPr/>
+        </p:nvPicPr>
+        <p:blipFill>
+          <a:blip r:embed="rId18"/>
+          <a:stretch>
+            <a:fillRect/>
+          </a:stretch>
+        </p:blipFill>
+        <p:spPr>
+          <a:xfrm>
+            <a:off x="4208411" y="5285231"/>
+            <a:ext cx="365760" cy="365760"/>
+          </a:xfrm>
+          <a:prstGeom prst="rect">
+            <a:avLst/>
+          </a:prstGeom>
+        </p:spPr>
+      </p:pic>
+      <p:pic>
+        <p:nvPicPr>
+          <p:cNvPr id="92" name="Picture 91" descr="grafana.png"/>
+          <p:cNvPicPr>
+            <a:picLocks noChangeAspect="1"/>
+          </p:cNvPicPr>
+          <p:nvPr/>
+        </p:nvPicPr>
+        <p:blipFill>
+          <a:blip r:embed="rId19"/>
+          <a:stretch>
+            <a:fillRect/>
+          </a:stretch>
+        </p:blipFill>
+        <p:spPr>
+          <a:xfrm>
+            <a:off x="4665611" y="5285231"/>
+            <a:ext cx="365760" cy="365760"/>
+          </a:xfrm>
+          <a:prstGeom prst="rect">
+            <a:avLst/>
+          </a:prstGeom>
+        </p:spPr>
+      </p:pic>
+      <p:sp>
+        <p:nvSpPr>
+          <p:cNvPr id="93" name="Rounded Rectangle 92"/>
+          <p:cNvSpPr/>
+          <p:nvPr/>
+        </p:nvSpPr>
+        <p:spPr>
+          <a:xfrm>
+            <a:off x="6178143" y="4645151"/>
+            <a:ext cx="2787319" cy="1664207"/>
+          </a:xfrm>
+          <a:prstGeom prst="roundRect">
+            <a:avLst/>
+          </a:prstGeom>
+          <a:solidFill>
+            <a:srgbClr val="F8FAFC"/>
+          </a:solidFill>
+          <a:ln w="19050">
+            <a:solidFill>
+              <a:srgbClr val="E2E8F0"/>
+            </a:solidFill>
+          </a:ln>
+        </p:spPr>
+        <p:style>
+          <a:lnRef idx="1">
+            <a:schemeClr val="accent1"/>
+          </a:lnRef>
+          <a:fillRef idx="3">
+            <a:schemeClr val="accent1"/>
+          </a:fillRef>
+          <a:effectRef idx="2">
+            <a:schemeClr val="accent1"/>
+          </a:effectRef>
+          <a:fontRef idx="minor">
+            <a:schemeClr val="lt1"/>
+          </a:fontRef>
+        </p:style>
+        <p:txBody>
+          <a:bodyPr rtlCol="0" anchor="ctr"/>
+          <a:lstStyle/>
+          <a:p>
+            <a:pPr algn="ctr"/>
+          </a:p>
+        </p:txBody>
+      </p:sp>
+      <p:sp>
+        <p:nvSpPr>
+          <p:cNvPr id="94" name="Rounded Rectangle 93"/>
+          <p:cNvSpPr/>
+          <p:nvPr/>
+        </p:nvSpPr>
+        <p:spPr>
+          <a:xfrm>
+            <a:off x="6178143" y="4645151"/>
+            <a:ext cx="91440" cy="1664207"/>
+          </a:xfrm>
+          <a:prstGeom prst="roundRect">
+            <a:avLst/>
+          </a:prstGeom>
+          <a:solidFill>
+            <a:srgbClr val="22A062"/>
+          </a:solidFill>
+          <a:ln>
+            <a:noFill/>
+          </a:ln>
+        </p:spPr>
+        <p:style>
+          <a:lnRef idx="1">
+            <a:schemeClr val="accent1"/>
+          </a:lnRef>
+          <a:fillRef idx="3">
+            <a:schemeClr val="accent1"/>
+          </a:fillRef>
+          <a:effectRef idx="2">
+            <a:schemeClr val="accent1"/>
+          </a:effectRef>
+          <a:fontRef idx="minor">
+            <a:schemeClr val="lt1"/>
+          </a:fontRef>
+        </p:style>
+        <p:txBody>
+          <a:bodyPr rtlCol="0" anchor="ctr"/>
+          <a:lstStyle/>
+          <a:p>
+            <a:pPr algn="ctr"/>
+          </a:p>
+        </p:txBody>
+      </p:sp>
+      <p:sp>
+        <p:nvSpPr>
+          <p:cNvPr id="95" name="Rounded Rectangle 94"/>
+          <p:cNvSpPr/>
+          <p:nvPr/>
+        </p:nvSpPr>
+        <p:spPr>
+          <a:xfrm>
+            <a:off x="6342735" y="4754879"/>
+            <a:ext cx="438912" cy="256032"/>
+          </a:xfrm>
+          <a:prstGeom prst="roundRect">
+            <a:avLst/>
+          </a:prstGeom>
+          <a:solidFill>
+            <a:srgbClr val="22A062"/>
+          </a:solidFill>
+          <a:ln>
+            <a:noFill/>
+          </a:ln>
+        </p:spPr>
+        <p:style>
+          <a:lnRef idx="1">
+            <a:schemeClr val="accent1"/>
+          </a:lnRef>
+          <a:fillRef idx="3">
+            <a:schemeClr val="accent1"/>
+          </a:fillRef>
+          <a:effectRef idx="2">
+            <a:schemeClr val="accent1"/>
+          </a:effectRef>
+          <a:fontRef idx="minor">
+            <a:schemeClr val="lt1"/>
+          </a:fontRef>
+        </p:style>
+        <p:txBody>
+          <a:bodyPr rtlCol="0" anchor="ctr" wrap="square"/>
+          <a:lstStyle/>
+          <a:p>
+            <a:pPr algn="ctr"/>
+            <a:r>
+              <a:rPr sz="1100" b="1">
+                <a:solidFill>
+                  <a:srgbClr val="F8FAFC"/>
+                </a:solidFill>
+                <a:latin typeface="Calibri"/>
+              </a:rPr>
+              <a:t>11</a:t>
+            </a:r>
+          </a:p>
+        </p:txBody>
+      </p:sp>
+      <p:sp>
+        <p:nvSpPr>
+          <p:cNvPr id="96" name="TextBox 95"/>
+          <p:cNvSpPr txBox="1"/>
+          <p:nvPr/>
+        </p:nvSpPr>
+        <p:spPr>
+          <a:xfrm>
+            <a:off x="6836511" y="4736591"/>
+            <a:ext cx="2010079" cy="292608"/>
+          </a:xfrm>
+          <a:prstGeom prst="rect">
+            <a:avLst/>
+          </a:prstGeom>
+          <a:noFill/>
+        </p:spPr>
+        <p:txBody>
+          <a:bodyPr wrap="square">
+            <a:spAutoFit/>
+          </a:bodyPr>
+          <a:lstStyle/>
+          <a:p>
+            <a:pPr algn="l"/>
+            <a:r>
+              <a:rPr sz="1300" b="1">
+                <a:solidFill>
+                  <a:srgbClr val="141E2E"/>
+                </a:solidFill>
+                <a:latin typeface="Calibri"/>
+              </a:rPr>
+              <a:t>GitOps</a:t>
+            </a:r>
+          </a:p>
+        </p:txBody>
+      </p:sp>
+      <p:sp>
+        <p:nvSpPr>
+          <p:cNvPr id="97" name="TextBox 96"/>
+          <p:cNvSpPr txBox="1"/>
+          <p:nvPr/>
+        </p:nvSpPr>
+        <p:spPr>
+          <a:xfrm>
+            <a:off x="6836511" y="4992623"/>
+            <a:ext cx="2010079" cy="237744"/>
+          </a:xfrm>
+          <a:prstGeom prst="rect">
+            <a:avLst/>
+          </a:prstGeom>
+          <a:noFill/>
+        </p:spPr>
+        <p:txBody>
+          <a:bodyPr wrap="square">
+            <a:spAutoFit/>
+          </a:bodyPr>
+          <a:lstStyle/>
+          <a:p>
+            <a:pPr algn="l"/>
+            <a:r>
+              <a:rPr sz="1000" b="0">
+                <a:solidFill>
+                  <a:srgbClr val="606E7E"/>
+                </a:solidFill>
+                <a:latin typeface="Calibri"/>
+              </a:rPr>
+              <a:t>ArgoCD · Flux</a:t>
+            </a:r>
+          </a:p>
+        </p:txBody>
+      </p:sp>
+      <p:pic>
+        <p:nvPicPr>
+          <p:cNvPr id="98" name="Picture 97" descr="argocd.png"/>
+          <p:cNvPicPr>
+            <a:picLocks noChangeAspect="1"/>
+          </p:cNvPicPr>
+          <p:nvPr/>
+        </p:nvPicPr>
+        <p:blipFill>
+          <a:blip r:embed="rId20"/>
+          <a:stretch>
+            <a:fillRect/>
+          </a:stretch>
+        </p:blipFill>
+        <p:spPr>
+          <a:xfrm>
+            <a:off x="6931723" y="5285231"/>
+            <a:ext cx="365760" cy="365760"/>
+          </a:xfrm>
+          <a:prstGeom prst="rect">
+            <a:avLst/>
+          </a:prstGeom>
+        </p:spPr>
+      </p:pic>
+      <p:pic>
+        <p:nvPicPr>
+          <p:cNvPr id="99" name="Picture 98" descr="flux.png"/>
+          <p:cNvPicPr>
+            <a:picLocks noChangeAspect="1"/>
+          </p:cNvPicPr>
+          <p:nvPr/>
+        </p:nvPicPr>
+        <p:blipFill>
+          <a:blip r:embed="rId21"/>
+          <a:stretch>
+            <a:fillRect/>
+          </a:stretch>
+        </p:blipFill>
+        <p:spPr>
+          <a:xfrm>
+            <a:off x="7388923" y="5285231"/>
+            <a:ext cx="365760" cy="365760"/>
+          </a:xfrm>
+          <a:prstGeom prst="rect">
+            <a:avLst/>
+          </a:prstGeom>
+        </p:spPr>
+      </p:pic>
+      <p:pic>
+        <p:nvPicPr>
+          <p:cNvPr id="100" name="Picture 99" descr="git.png"/>
+          <p:cNvPicPr>
+            <a:picLocks noChangeAspect="1"/>
+          </p:cNvPicPr>
+          <p:nvPr/>
+        </p:nvPicPr>
+        <p:blipFill>
+          <a:blip r:embed="rId4"/>
+          <a:stretch>
+            <a:fillRect/>
+          </a:stretch>
+        </p:blipFill>
+        <p:spPr>
+          <a:xfrm>
+            <a:off x="7846123" y="5285231"/>
+            <a:ext cx="365760" cy="365760"/>
+          </a:xfrm>
+          <a:prstGeom prst="rect">
+            <a:avLst/>
+          </a:prstGeom>
+        </p:spPr>
+      </p:pic>
+      <p:sp>
+        <p:nvSpPr>
+          <p:cNvPr id="101" name="Rounded Rectangle 100"/>
+          <p:cNvSpPr/>
+          <p:nvPr/>
+        </p:nvSpPr>
+        <p:spPr>
+          <a:xfrm>
+            <a:off x="9130055" y="4645151"/>
+            <a:ext cx="2787319" cy="1664207"/>
+          </a:xfrm>
+          <a:prstGeom prst="roundRect">
+            <a:avLst/>
+          </a:prstGeom>
+          <a:solidFill>
+            <a:srgbClr val="141E2E"/>
+          </a:solidFill>
+          <a:ln>
+            <a:noFill/>
+          </a:ln>
+        </p:spPr>
+        <p:style>
+          <a:lnRef idx="1">
+            <a:schemeClr val="accent1"/>
+          </a:lnRef>
+          <a:fillRef idx="3">
+            <a:schemeClr val="accent1"/>
+          </a:fillRef>
+          <a:effectRef idx="2">
+            <a:schemeClr val="accent1"/>
+          </a:effectRef>
+          <a:fontRef idx="minor">
+            <a:schemeClr val="lt1"/>
+          </a:fontRef>
+        </p:style>
+        <p:txBody>
+          <a:bodyPr rtlCol="0" anchor="ctr"/>
+          <a:lstStyle/>
+          <a:p>
+            <a:pPr algn="ctr"/>
+          </a:p>
+        </p:txBody>
+      </p:sp>
+      <p:sp>
+        <p:nvSpPr>
+          <p:cNvPr id="102" name="Rounded Rectangle 101"/>
+          <p:cNvSpPr/>
+          <p:nvPr/>
+        </p:nvSpPr>
+        <p:spPr>
+          <a:xfrm>
+            <a:off x="9130055" y="4645151"/>
+            <a:ext cx="91440" cy="1664207"/>
+          </a:xfrm>
+          <a:prstGeom prst="roundRect">
+            <a:avLst/>
+          </a:prstGeom>
+          <a:solidFill>
+            <a:srgbClr val="EC4899"/>
+          </a:solidFill>
+          <a:ln>
+            <a:noFill/>
+          </a:ln>
+        </p:spPr>
+        <p:style>
+          <a:lnRef idx="1">
+            <a:schemeClr val="accent1"/>
+          </a:lnRef>
+          <a:fillRef idx="3">
+            <a:schemeClr val="accent1"/>
+          </a:fillRef>
+          <a:effectRef idx="2">
+            <a:schemeClr val="accent1"/>
+          </a:effectRef>
+          <a:fontRef idx="minor">
+            <a:schemeClr val="lt1"/>
+          </a:fontRef>
+        </p:style>
+        <p:txBody>
+          <a:bodyPr rtlCol="0" anchor="ctr"/>
+          <a:lstStyle/>
+          <a:p>
+            <a:pPr algn="ctr"/>
+          </a:p>
+        </p:txBody>
+      </p:sp>
+      <p:sp>
+        <p:nvSpPr>
+          <p:cNvPr id="103" name="TextBox 102"/>
+          <p:cNvSpPr txBox="1"/>
+          <p:nvPr/>
+        </p:nvSpPr>
+        <p:spPr>
+          <a:xfrm>
+            <a:off x="9331223" y="4754879"/>
+            <a:ext cx="2467279" cy="237744"/>
+          </a:xfrm>
+          <a:prstGeom prst="rect">
+            <a:avLst/>
+          </a:prstGeom>
+          <a:noFill/>
+        </p:spPr>
+        <p:txBody>
+          <a:bodyPr wrap="square">
+            <a:spAutoFit/>
+          </a:bodyPr>
+          <a:lstStyle/>
+          <a:p>
+            <a:pPr algn="l"/>
+            <a:r>
+              <a:rPr sz="1100" b="1">
+                <a:solidFill>
+                  <a:srgbClr val="EC4899"/>
+                </a:solidFill>
+                <a:latin typeface="Calibri"/>
+              </a:rPr>
+              <a:t>GOAL</a:t>
+            </a:r>
+          </a:p>
+        </p:txBody>
+      </p:sp>
+      <p:sp>
+        <p:nvSpPr>
+          <p:cNvPr id="104" name="TextBox 103"/>
+          <p:cNvSpPr txBox="1"/>
+          <p:nvPr/>
+        </p:nvSpPr>
+        <p:spPr>
+          <a:xfrm>
+            <a:off x="9331223" y="5010912"/>
+            <a:ext cx="2467279" cy="292608"/>
+          </a:xfrm>
+          <a:prstGeom prst="rect">
+            <a:avLst/>
+          </a:prstGeom>
+          <a:noFill/>
+        </p:spPr>
+        <p:txBody>
+          <a:bodyPr wrap="square">
+            <a:spAutoFit/>
+          </a:bodyPr>
+          <a:lstStyle/>
+          <a:p>
+            <a:pPr algn="l"/>
+            <a:r>
+              <a:rPr sz="1600" b="1">
+                <a:solidFill>
+                  <a:srgbClr val="F8FAFC"/>
+                </a:solidFill>
+                <a:latin typeface="Calibri"/>
+              </a:rPr>
+              <a:t>Build</a:t>
+            </a:r>
+          </a:p>
+        </p:txBody>
+      </p:sp>
+      <p:sp>
+        <p:nvSpPr>
+          <p:cNvPr id="105" name="TextBox 104"/>
+          <p:cNvSpPr txBox="1"/>
+          <p:nvPr/>
+        </p:nvSpPr>
+        <p:spPr>
+          <a:xfrm>
+            <a:off x="9331223" y="5303520"/>
+            <a:ext cx="2467279" cy="292608"/>
+          </a:xfrm>
+          <a:prstGeom prst="rect">
+            <a:avLst/>
+          </a:prstGeom>
+          <a:noFill/>
+        </p:spPr>
+        <p:txBody>
+          <a:bodyPr wrap="square">
+            <a:spAutoFit/>
+          </a:bodyPr>
+          <a:lstStyle/>
+          <a:p>
+            <a:pPr algn="l"/>
+            <a:r>
+              <a:rPr sz="1600" b="1">
+                <a:solidFill>
+                  <a:srgbClr val="F8FAFC"/>
+                </a:solidFill>
+                <a:latin typeface="Calibri"/>
+              </a:rPr>
+              <a:t>Automate</a:t>
+            </a:r>
+          </a:p>
+        </p:txBody>
+      </p:sp>
+      <p:sp>
+        <p:nvSpPr>
+          <p:cNvPr id="106" name="TextBox 105"/>
+          <p:cNvSpPr txBox="1"/>
+          <p:nvPr/>
+        </p:nvSpPr>
+        <p:spPr>
+          <a:xfrm>
+            <a:off x="9331223" y="5596127"/>
+            <a:ext cx="2467279" cy="292608"/>
+          </a:xfrm>
+          <a:prstGeom prst="rect">
+            <a:avLst/>
+          </a:prstGeom>
+          <a:noFill/>
+        </p:spPr>
+        <p:txBody>
+          <a:bodyPr wrap="square">
+            <a:spAutoFit/>
+          </a:bodyPr>
+          <a:lstStyle/>
+          <a:p>
+            <a:pPr algn="l"/>
+            <a:r>
+              <a:rPr sz="1600" b="1">
+                <a:solidFill>
+                  <a:srgbClr val="F8FAFC"/>
+                </a:solidFill>
+                <a:latin typeface="Calibri"/>
+              </a:rPr>
+              <a:t>Monitor</a:t>
+            </a:r>
+          </a:p>
+        </p:txBody>
+      </p:sp>
+      <p:sp>
+        <p:nvSpPr>
+          <p:cNvPr id="107" name="TextBox 106"/>
+          <p:cNvSpPr txBox="1"/>
+          <p:nvPr/>
+        </p:nvSpPr>
+        <p:spPr>
+          <a:xfrm>
+            <a:off x="9331223" y="5888736"/>
+            <a:ext cx="2467279" cy="292608"/>
+          </a:xfrm>
+          <a:prstGeom prst="rect">
+            <a:avLst/>
+          </a:prstGeom>
+          <a:noFill/>
+        </p:spPr>
+        <p:txBody>
+          <a:bodyPr wrap="square">
+            <a:spAutoFit/>
+          </a:bodyPr>
+          <a:lstStyle/>
+          <a:p>
+            <a:pPr algn="l"/>
+            <a:r>
+              <a:rPr sz="1600" b="1">
+                <a:solidFill>
+                  <a:srgbClr val="F8FAFC"/>
+                </a:solidFill>
+                <a:latin typeface="Calibri"/>
+              </a:rPr>
+              <a:t>Deploy</a:t>
+            </a:r>
+          </a:p>
+        </p:txBody>
+      </p:sp>
+      <p:sp>
+        <p:nvSpPr>
+          <p:cNvPr id="108" name="Rounded Rectangle 107"/>
+          <p:cNvSpPr/>
+          <p:nvPr/>
+        </p:nvSpPr>
+        <p:spPr>
+          <a:xfrm>
+            <a:off x="274320" y="6419088"/>
+            <a:ext cx="11640312" cy="347472"/>
+          </a:xfrm>
+          <a:prstGeom prst="roundRect">
+            <a:avLst/>
+          </a:prstGeom>
+          <a:solidFill>
+            <a:srgbClr val="141E2E"/>
+          </a:solidFill>
+          <a:ln>
+            <a:noFill/>
+          </a:ln>
+        </p:spPr>
+        <p:style>
+          <a:lnRef idx="1">
+            <a:schemeClr val="accent1"/>
+          </a:lnRef>
+          <a:fillRef idx="3">
+            <a:schemeClr val="accent1"/>
+          </a:fillRef>
+          <a:effectRef idx="2">
+            <a:schemeClr val="accent1"/>
+          </a:effectRef>
+          <a:fontRef idx="minor">
+            <a:schemeClr val="lt1"/>
+          </a:fontRef>
+        </p:style>
+        <p:txBody>
+          <a:bodyPr rtlCol="0" anchor="ctr"/>
+          <a:lstStyle/>
+          <a:p>
+            <a:pPr algn="ctr"/>
+          </a:p>
+        </p:txBody>
+      </p:sp>
+      <p:sp>
+        <p:nvSpPr>
+          <p:cNvPr id="109" name="TextBox 108"/>
+          <p:cNvSpPr txBox="1"/>
+          <p:nvPr/>
+        </p:nvSpPr>
+        <p:spPr>
+          <a:xfrm>
+            <a:off x="411480" y="6446520"/>
+            <a:ext cx="7772400" cy="292608"/>
+          </a:xfrm>
+          <a:prstGeom prst="rect">
+            <a:avLst/>
+          </a:prstGeom>
+          <a:noFill/>
+        </p:spPr>
+        <p:txBody>
+          <a:bodyPr wrap="square">
+            <a:spAutoFit/>
+          </a:bodyPr>
+          <a:lstStyle/>
+          <a:p>
+            <a:pPr algn="l"/>
+            <a:r>
+              <a:rPr sz="1300" b="1">
+                <a:solidFill>
+                  <a:srgbClr val="F8FAFC"/>
+                </a:solidFill>
+                <a:latin typeface="Calibri"/>
+              </a:rPr>
+              <a:t>Build   ·   Automate   ·   Monitor   ·   Deploy</a:t>
+            </a:r>
+          </a:p>
+        </p:txBody>
+      </p:sp>
+      <p:sp>
+        <p:nvSpPr>
+          <p:cNvPr id="110" name="TextBox 109"/>
+          <p:cNvSpPr txBox="1"/>
+          <p:nvPr/>
+        </p:nvSpPr>
+        <p:spPr>
+          <a:xfrm>
+            <a:off x="8778240" y="6446520"/>
+            <a:ext cx="2926080" cy="292608"/>
+          </a:xfrm>
+          <a:prstGeom prst="rect">
+            <a:avLst/>
+          </a:prstGeom>
+          <a:noFill/>
+        </p:spPr>
+        <p:txBody>
+          <a:bodyPr wrap="square">
+            <a:spAutoFit/>
+          </a:bodyPr>
+          <a:lstStyle/>
+          <a:p>
+            <a:pPr algn="r"/>
+            <a:r>
+              <a:rPr sz="1100" b="0">
+                <a:solidFill>
+                  <a:srgbClr val="94A3B8"/>
+                </a:solidFill>
+                <a:latin typeface="Calibri"/>
+              </a:rPr>
+              <a:t>Kethan Gummalla</a:t>
+            </a:r>
+          </a:p>
+        </p:txBody>
+      </p:sp>
     </p:spTree>
   </p:cSld>
   <p:clrMapOvr>

</xml_diff>

<commit_message>
Put approved on-the-road DevOps map on Slide 2 of the Day 2 PPT
Co-authored-by: Kethan <kethan-1818@users.noreply.github.com>
</commit_message>
<xml_diff>
--- a/fdc-day2/FDC_Day2_DevOps_Roadmap.pptx
+++ b/fdc-day2/FDC_Day2_DevOps_Roadmap.pptx
@@ -7584,1109 +7584,9 @@
         <p:nvPr/>
       </p:nvGrpSpPr>
       <p:grpSpPr/>
-      <p:sp>
-        <p:nvSpPr>
-          <p:cNvPr id="2" name="Rectangle 1"/>
-          <p:cNvSpPr/>
-          <p:nvPr/>
-        </p:nvSpPr>
-        <p:spPr>
-          <a:xfrm>
-            <a:off x="0" y="0"/>
-            <a:ext cx="12191695" cy="64008"/>
-          </a:xfrm>
-          <a:prstGeom prst="rect">
-            <a:avLst/>
-          </a:prstGeom>
-          <a:solidFill>
-            <a:srgbClr val="22D3EE"/>
-          </a:solidFill>
-          <a:ln>
-            <a:noFill/>
-          </a:ln>
-        </p:spPr>
-        <p:style>
-          <a:lnRef idx="1">
-            <a:schemeClr val="accent1"/>
-          </a:lnRef>
-          <a:fillRef idx="3">
-            <a:schemeClr val="accent1"/>
-          </a:fillRef>
-          <a:effectRef idx="2">
-            <a:schemeClr val="accent1"/>
-          </a:effectRef>
-          <a:fontRef idx="minor">
-            <a:schemeClr val="lt1"/>
-          </a:fontRef>
-        </p:style>
-        <p:txBody>
-          <a:bodyPr rtlCol="0" anchor="ctr"/>
-          <a:lstStyle/>
-          <a:p>
-            <a:pPr algn="ctr"/>
-          </a:p>
-        </p:txBody>
-      </p:sp>
-      <p:sp>
-        <p:nvSpPr>
-          <p:cNvPr id="3" name="TextBox 2"/>
-          <p:cNvSpPr txBox="1"/>
-          <p:nvPr/>
-        </p:nvSpPr>
-        <p:spPr>
-          <a:xfrm>
-            <a:off x="292608" y="128016"/>
-            <a:ext cx="7315200" cy="438912"/>
-          </a:xfrm>
-          <a:prstGeom prst="rect">
-            <a:avLst/>
-          </a:prstGeom>
-          <a:noFill/>
-        </p:spPr>
-        <p:txBody>
-          <a:bodyPr wrap="square">
-            <a:spAutoFit/>
-          </a:bodyPr>
-          <a:lstStyle/>
-          <a:p>
-            <a:pPr algn="l"/>
-            <a:r>
-              <a:rPr sz="2800" b="1">
-                <a:solidFill>
-                  <a:srgbClr val="141E2E"/>
-                </a:solidFill>
-                <a:latin typeface="Calibri"/>
-              </a:rPr>
-              <a:t>DevOps Roadmap</a:t>
-            </a:r>
-          </a:p>
-        </p:txBody>
-      </p:sp>
-      <p:sp>
-        <p:nvSpPr>
-          <p:cNvPr id="4" name="TextBox 3"/>
-          <p:cNvSpPr txBox="1"/>
-          <p:nvPr/>
-        </p:nvSpPr>
-        <p:spPr>
-          <a:xfrm>
-            <a:off x="292608" y="493776"/>
-            <a:ext cx="8686800" cy="256032"/>
-          </a:xfrm>
-          <a:prstGeom prst="rect">
-            <a:avLst/>
-          </a:prstGeom>
-          <a:noFill/>
-        </p:spPr>
-        <p:txBody>
-          <a:bodyPr wrap="square">
-            <a:spAutoFit/>
-          </a:bodyPr>
-          <a:lstStyle/>
-          <a:p>
-            <a:pPr algn="l"/>
-            <a:r>
-              <a:rPr sz="1100" b="0">
-                <a:solidFill>
-                  <a:srgbClr val="606E7E"/>
-                </a:solidFill>
-                <a:latin typeface="Calibri"/>
-              </a:rPr>
-              <a:t>Beginner’s Guide to Cloud Automation  ·  Friday Deployment Club  ·  Day 2</a:t>
-            </a:r>
-          </a:p>
-        </p:txBody>
-      </p:sp>
-      <p:sp>
-        <p:nvSpPr>
-          <p:cNvPr id="5" name="Rounded Rectangle 4"/>
-          <p:cNvSpPr/>
-          <p:nvPr/>
-        </p:nvSpPr>
-        <p:spPr>
-          <a:xfrm>
-            <a:off x="292608" y="804672"/>
-            <a:ext cx="164592" cy="128016"/>
-          </a:xfrm>
-          <a:prstGeom prst="roundRect">
-            <a:avLst/>
-          </a:prstGeom>
-          <a:solidFill>
-            <a:srgbClr val="F58220"/>
-          </a:solidFill>
-          <a:ln>
-            <a:noFill/>
-          </a:ln>
-        </p:spPr>
-        <p:style>
-          <a:lnRef idx="1">
-            <a:schemeClr val="accent1"/>
-          </a:lnRef>
-          <a:fillRef idx="3">
-            <a:schemeClr val="accent1"/>
-          </a:fillRef>
-          <a:effectRef idx="2">
-            <a:schemeClr val="accent1"/>
-          </a:effectRef>
-          <a:fontRef idx="minor">
-            <a:schemeClr val="lt1"/>
-          </a:fontRef>
-        </p:style>
-        <p:txBody>
-          <a:bodyPr rtlCol="0" anchor="ctr"/>
-          <a:lstStyle/>
-          <a:p>
-            <a:pPr algn="ctr"/>
-          </a:p>
-        </p:txBody>
-      </p:sp>
-      <p:sp>
-        <p:nvSpPr>
-          <p:cNvPr id="6" name="TextBox 5"/>
-          <p:cNvSpPr txBox="1"/>
-          <p:nvPr/>
-        </p:nvSpPr>
-        <p:spPr>
-          <a:xfrm>
-            <a:off x="493776" y="768096"/>
-            <a:ext cx="1920240" cy="201168"/>
-          </a:xfrm>
-          <a:prstGeom prst="rect">
-            <a:avLst/>
-          </a:prstGeom>
-          <a:noFill/>
-        </p:spPr>
-        <p:txBody>
-          <a:bodyPr wrap="square">
-            <a:spAutoFit/>
-          </a:bodyPr>
-          <a:lstStyle/>
-          <a:p>
-            <a:pPr algn="l"/>
-            <a:r>
-              <a:rPr sz="1000" b="1">
-                <a:solidFill>
-                  <a:srgbClr val="606E7E"/>
-                </a:solidFill>
-                <a:latin typeface="Calibri"/>
-              </a:rPr>
-              <a:t>Foundations</a:t>
-            </a:r>
-          </a:p>
-        </p:txBody>
-      </p:sp>
-      <p:sp>
-        <p:nvSpPr>
-          <p:cNvPr id="7" name="Rounded Rectangle 6"/>
-          <p:cNvSpPr/>
-          <p:nvPr/>
-        </p:nvSpPr>
-        <p:spPr>
-          <a:xfrm>
-            <a:off x="2441448" y="804672"/>
-            <a:ext cx="164592" cy="128016"/>
-          </a:xfrm>
-          <a:prstGeom prst="roundRect">
-            <a:avLst/>
-          </a:prstGeom>
-          <a:solidFill>
-            <a:srgbClr val="7C5CD4"/>
-          </a:solidFill>
-          <a:ln>
-            <a:noFill/>
-          </a:ln>
-        </p:spPr>
-        <p:style>
-          <a:lnRef idx="1">
-            <a:schemeClr val="accent1"/>
-          </a:lnRef>
-          <a:fillRef idx="3">
-            <a:schemeClr val="accent1"/>
-          </a:fillRef>
-          <a:effectRef idx="2">
-            <a:schemeClr val="accent1"/>
-          </a:effectRef>
-          <a:fontRef idx="minor">
-            <a:schemeClr val="lt1"/>
-          </a:fontRef>
-        </p:style>
-        <p:txBody>
-          <a:bodyPr rtlCol="0" anchor="ctr"/>
-          <a:lstStyle/>
-          <a:p>
-            <a:pPr algn="ctr"/>
-          </a:p>
-        </p:txBody>
-      </p:sp>
-      <p:sp>
-        <p:nvSpPr>
-          <p:cNvPr id="8" name="TextBox 7"/>
-          <p:cNvSpPr txBox="1"/>
-          <p:nvPr/>
-        </p:nvSpPr>
-        <p:spPr>
-          <a:xfrm>
-            <a:off x="2642616" y="768096"/>
-            <a:ext cx="1920240" cy="201168"/>
-          </a:xfrm>
-          <a:prstGeom prst="rect">
-            <a:avLst/>
-          </a:prstGeom>
-          <a:noFill/>
-        </p:spPr>
-        <p:txBody>
-          <a:bodyPr wrap="square">
-            <a:spAutoFit/>
-          </a:bodyPr>
-          <a:lstStyle/>
-          <a:p>
-            <a:pPr algn="l"/>
-            <a:r>
-              <a:rPr sz="1000" b="1">
-                <a:solidFill>
-                  <a:srgbClr val="606E7E"/>
-                </a:solidFill>
-                <a:latin typeface="Calibri"/>
-              </a:rPr>
-              <a:t>Containers &amp; CI/CD</a:t>
-            </a:r>
-          </a:p>
-        </p:txBody>
-      </p:sp>
-      <p:sp>
-        <p:nvSpPr>
-          <p:cNvPr id="9" name="Rounded Rectangle 8"/>
-          <p:cNvSpPr/>
-          <p:nvPr/>
-        </p:nvSpPr>
-        <p:spPr>
-          <a:xfrm>
-            <a:off x="4590288" y="804672"/>
-            <a:ext cx="164592" cy="128016"/>
-          </a:xfrm>
-          <a:prstGeom prst="roundRect">
-            <a:avLst/>
-          </a:prstGeom>
-          <a:solidFill>
-            <a:srgbClr val="387ED6"/>
-          </a:solidFill>
-          <a:ln>
-            <a:noFill/>
-          </a:ln>
-        </p:spPr>
-        <p:style>
-          <a:lnRef idx="1">
-            <a:schemeClr val="accent1"/>
-          </a:lnRef>
-          <a:fillRef idx="3">
-            <a:schemeClr val="accent1"/>
-          </a:fillRef>
-          <a:effectRef idx="2">
-            <a:schemeClr val="accent1"/>
-          </a:effectRef>
-          <a:fontRef idx="minor">
-            <a:schemeClr val="lt1"/>
-          </a:fontRef>
-        </p:style>
-        <p:txBody>
-          <a:bodyPr rtlCol="0" anchor="ctr"/>
-          <a:lstStyle/>
-          <a:p>
-            <a:pPr algn="ctr"/>
-          </a:p>
-        </p:txBody>
-      </p:sp>
-      <p:sp>
-        <p:nvSpPr>
-          <p:cNvPr id="10" name="TextBox 9"/>
-          <p:cNvSpPr txBox="1"/>
-          <p:nvPr/>
-        </p:nvSpPr>
-        <p:spPr>
-          <a:xfrm>
-            <a:off x="4791455" y="768096"/>
-            <a:ext cx="1920240" cy="201168"/>
-          </a:xfrm>
-          <a:prstGeom prst="rect">
-            <a:avLst/>
-          </a:prstGeom>
-          <a:noFill/>
-        </p:spPr>
-        <p:txBody>
-          <a:bodyPr wrap="square">
-            <a:spAutoFit/>
-          </a:bodyPr>
-          <a:lstStyle/>
-          <a:p>
-            <a:pPr algn="l"/>
-            <a:r>
-              <a:rPr sz="1000" b="1">
-                <a:solidFill>
-                  <a:srgbClr val="606E7E"/>
-                </a:solidFill>
-                <a:latin typeface="Calibri"/>
-              </a:rPr>
-              <a:t>Cloud</a:t>
-            </a:r>
-          </a:p>
-        </p:txBody>
-      </p:sp>
-      <p:sp>
-        <p:nvSpPr>
-          <p:cNvPr id="11" name="Rounded Rectangle 10"/>
-          <p:cNvSpPr/>
-          <p:nvPr/>
-        </p:nvSpPr>
-        <p:spPr>
-          <a:xfrm>
-            <a:off x="6739127" y="804672"/>
-            <a:ext cx="164592" cy="128016"/>
-          </a:xfrm>
-          <a:prstGeom prst="roundRect">
-            <a:avLst/>
-          </a:prstGeom>
-          <a:solidFill>
-            <a:srgbClr val="4F46B4"/>
-          </a:solidFill>
-          <a:ln>
-            <a:noFill/>
-          </a:ln>
-        </p:spPr>
-        <p:style>
-          <a:lnRef idx="1">
-            <a:schemeClr val="accent1"/>
-          </a:lnRef>
-          <a:fillRef idx="3">
-            <a:schemeClr val="accent1"/>
-          </a:fillRef>
-          <a:effectRef idx="2">
-            <a:schemeClr val="accent1"/>
-          </a:effectRef>
-          <a:fontRef idx="minor">
-            <a:schemeClr val="lt1"/>
-          </a:fontRef>
-        </p:style>
-        <p:txBody>
-          <a:bodyPr rtlCol="0" anchor="ctr"/>
-          <a:lstStyle/>
-          <a:p>
-            <a:pPr algn="ctr"/>
-          </a:p>
-        </p:txBody>
-      </p:sp>
-      <p:sp>
-        <p:nvSpPr>
-          <p:cNvPr id="12" name="TextBox 11"/>
-          <p:cNvSpPr txBox="1"/>
-          <p:nvPr/>
-        </p:nvSpPr>
-        <p:spPr>
-          <a:xfrm>
-            <a:off x="6940295" y="768096"/>
-            <a:ext cx="1920240" cy="201168"/>
-          </a:xfrm>
-          <a:prstGeom prst="rect">
-            <a:avLst/>
-          </a:prstGeom>
-          <a:noFill/>
-        </p:spPr>
-        <p:txBody>
-          <a:bodyPr wrap="square">
-            <a:spAutoFit/>
-          </a:bodyPr>
-          <a:lstStyle/>
-          <a:p>
-            <a:pPr algn="l"/>
-            <a:r>
-              <a:rPr sz="1000" b="1">
-                <a:solidFill>
-                  <a:srgbClr val="606E7E"/>
-                </a:solidFill>
-                <a:latin typeface="Calibri"/>
-              </a:rPr>
-              <a:t>Infra &amp; Orchestration</a:t>
-            </a:r>
-          </a:p>
-        </p:txBody>
-      </p:sp>
-      <p:sp>
-        <p:nvSpPr>
-          <p:cNvPr id="13" name="Rounded Rectangle 12"/>
-          <p:cNvSpPr/>
-          <p:nvPr/>
-        </p:nvSpPr>
-        <p:spPr>
-          <a:xfrm>
-            <a:off x="8887967" y="804672"/>
-            <a:ext cx="164592" cy="128016"/>
-          </a:xfrm>
-          <a:prstGeom prst="roundRect">
-            <a:avLst/>
-          </a:prstGeom>
-          <a:solidFill>
-            <a:srgbClr val="22A062"/>
-          </a:solidFill>
-          <a:ln>
-            <a:noFill/>
-          </a:ln>
-        </p:spPr>
-        <p:style>
-          <a:lnRef idx="1">
-            <a:schemeClr val="accent1"/>
-          </a:lnRef>
-          <a:fillRef idx="3">
-            <a:schemeClr val="accent1"/>
-          </a:fillRef>
-          <a:effectRef idx="2">
-            <a:schemeClr val="accent1"/>
-          </a:effectRef>
-          <a:fontRef idx="minor">
-            <a:schemeClr val="lt1"/>
-          </a:fontRef>
-        </p:style>
-        <p:txBody>
-          <a:bodyPr rtlCol="0" anchor="ctr"/>
-          <a:lstStyle/>
-          <a:p>
-            <a:pPr algn="ctr"/>
-          </a:p>
-        </p:txBody>
-      </p:sp>
-      <p:sp>
-        <p:nvSpPr>
-          <p:cNvPr id="14" name="TextBox 13"/>
-          <p:cNvSpPr txBox="1"/>
-          <p:nvPr/>
-        </p:nvSpPr>
-        <p:spPr>
-          <a:xfrm>
-            <a:off x="9089136" y="768096"/>
-            <a:ext cx="1920240" cy="201168"/>
-          </a:xfrm>
-          <a:prstGeom prst="rect">
-            <a:avLst/>
-          </a:prstGeom>
-          <a:noFill/>
-        </p:spPr>
-        <p:txBody>
-          <a:bodyPr wrap="square">
-            <a:spAutoFit/>
-          </a:bodyPr>
-          <a:lstStyle/>
-          <a:p>
-            <a:pPr algn="l"/>
-            <a:r>
-              <a:rPr sz="1000" b="1">
-                <a:solidFill>
-                  <a:srgbClr val="606E7E"/>
-                </a:solidFill>
-                <a:latin typeface="Calibri"/>
-              </a:rPr>
-              <a:t>Security &amp; Monitoring</a:t>
-            </a:r>
-          </a:p>
-        </p:txBody>
-      </p:sp>
-      <p:sp>
-        <p:nvSpPr>
-          <p:cNvPr id="15" name="Right Arrow 14"/>
-          <p:cNvSpPr/>
-          <p:nvPr/>
-        </p:nvSpPr>
-        <p:spPr>
-          <a:xfrm>
-            <a:off x="3079927" y="1783079"/>
-            <a:ext cx="128015" cy="146304"/>
-          </a:xfrm>
-          <a:prstGeom prst="rightArrow">
-            <a:avLst/>
-          </a:prstGeom>
-          <a:solidFill>
-            <a:srgbClr val="B8C0CC"/>
-          </a:solidFill>
-          <a:ln>
-            <a:noFill/>
-          </a:ln>
-        </p:spPr>
-        <p:style>
-          <a:lnRef idx="1">
-            <a:schemeClr val="accent1"/>
-          </a:lnRef>
-          <a:fillRef idx="3">
-            <a:schemeClr val="accent1"/>
-          </a:fillRef>
-          <a:effectRef idx="2">
-            <a:schemeClr val="accent1"/>
-          </a:effectRef>
-          <a:fontRef idx="minor">
-            <a:schemeClr val="lt1"/>
-          </a:fontRef>
-        </p:style>
-        <p:txBody>
-          <a:bodyPr rtlCol="0" anchor="ctr"/>
-          <a:lstStyle/>
-          <a:p>
-            <a:pPr algn="ctr"/>
-          </a:p>
-        </p:txBody>
-      </p:sp>
-      <p:sp>
-        <p:nvSpPr>
-          <p:cNvPr id="16" name="Right Arrow 15"/>
-          <p:cNvSpPr/>
-          <p:nvPr/>
-        </p:nvSpPr>
-        <p:spPr>
-          <a:xfrm>
-            <a:off x="6031839" y="1783079"/>
-            <a:ext cx="128015" cy="146304"/>
-          </a:xfrm>
-          <a:prstGeom prst="rightArrow">
-            <a:avLst/>
-          </a:prstGeom>
-          <a:solidFill>
-            <a:srgbClr val="B8C0CC"/>
-          </a:solidFill>
-          <a:ln>
-            <a:noFill/>
-          </a:ln>
-        </p:spPr>
-        <p:style>
-          <a:lnRef idx="1">
-            <a:schemeClr val="accent1"/>
-          </a:lnRef>
-          <a:fillRef idx="3">
-            <a:schemeClr val="accent1"/>
-          </a:fillRef>
-          <a:effectRef idx="2">
-            <a:schemeClr val="accent1"/>
-          </a:effectRef>
-          <a:fontRef idx="minor">
-            <a:schemeClr val="lt1"/>
-          </a:fontRef>
-        </p:style>
-        <p:txBody>
-          <a:bodyPr rtlCol="0" anchor="ctr"/>
-          <a:lstStyle/>
-          <a:p>
-            <a:pPr algn="ctr"/>
-          </a:p>
-        </p:txBody>
-      </p:sp>
-      <p:sp>
-        <p:nvSpPr>
-          <p:cNvPr id="17" name="Right Arrow 16"/>
-          <p:cNvSpPr/>
-          <p:nvPr/>
-        </p:nvSpPr>
-        <p:spPr>
-          <a:xfrm>
-            <a:off x="8983751" y="1783079"/>
-            <a:ext cx="128015" cy="146304"/>
-          </a:xfrm>
-          <a:prstGeom prst="rightArrow">
-            <a:avLst/>
-          </a:prstGeom>
-          <a:solidFill>
-            <a:srgbClr val="B8C0CC"/>
-          </a:solidFill>
-          <a:ln>
-            <a:noFill/>
-          </a:ln>
-        </p:spPr>
-        <p:style>
-          <a:lnRef idx="1">
-            <a:schemeClr val="accent1"/>
-          </a:lnRef>
-          <a:fillRef idx="3">
-            <a:schemeClr val="accent1"/>
-          </a:fillRef>
-          <a:effectRef idx="2">
-            <a:schemeClr val="accent1"/>
-          </a:effectRef>
-          <a:fontRef idx="minor">
-            <a:schemeClr val="lt1"/>
-          </a:fontRef>
-        </p:style>
-        <p:txBody>
-          <a:bodyPr rtlCol="0" anchor="ctr"/>
-          <a:lstStyle/>
-          <a:p>
-            <a:pPr algn="ctr"/>
-          </a:p>
-        </p:txBody>
-      </p:sp>
-      <p:sp>
-        <p:nvSpPr>
-          <p:cNvPr id="18" name="Right Arrow 17"/>
-          <p:cNvSpPr/>
-          <p:nvPr/>
-        </p:nvSpPr>
-        <p:spPr>
-          <a:xfrm>
-            <a:off x="3079927" y="3593591"/>
-            <a:ext cx="128015" cy="146304"/>
-          </a:xfrm>
-          <a:prstGeom prst="rightArrow">
-            <a:avLst/>
-          </a:prstGeom>
-          <a:solidFill>
-            <a:srgbClr val="B8C0CC"/>
-          </a:solidFill>
-          <a:ln>
-            <a:noFill/>
-          </a:ln>
-        </p:spPr>
-        <p:style>
-          <a:lnRef idx="1">
-            <a:schemeClr val="accent1"/>
-          </a:lnRef>
-          <a:fillRef idx="3">
-            <a:schemeClr val="accent1"/>
-          </a:fillRef>
-          <a:effectRef idx="2">
-            <a:schemeClr val="accent1"/>
-          </a:effectRef>
-          <a:fontRef idx="minor">
-            <a:schemeClr val="lt1"/>
-          </a:fontRef>
-        </p:style>
-        <p:txBody>
-          <a:bodyPr rtlCol="0" anchor="ctr"/>
-          <a:lstStyle/>
-          <a:p>
-            <a:pPr algn="ctr"/>
-          </a:p>
-        </p:txBody>
-      </p:sp>
-      <p:sp>
-        <p:nvSpPr>
-          <p:cNvPr id="19" name="Right Arrow 18"/>
-          <p:cNvSpPr/>
-          <p:nvPr/>
-        </p:nvSpPr>
-        <p:spPr>
-          <a:xfrm>
-            <a:off x="6031839" y="3593591"/>
-            <a:ext cx="128015" cy="146304"/>
-          </a:xfrm>
-          <a:prstGeom prst="rightArrow">
-            <a:avLst/>
-          </a:prstGeom>
-          <a:solidFill>
-            <a:srgbClr val="B8C0CC"/>
-          </a:solidFill>
-          <a:ln>
-            <a:noFill/>
-          </a:ln>
-        </p:spPr>
-        <p:style>
-          <a:lnRef idx="1">
-            <a:schemeClr val="accent1"/>
-          </a:lnRef>
-          <a:fillRef idx="3">
-            <a:schemeClr val="accent1"/>
-          </a:fillRef>
-          <a:effectRef idx="2">
-            <a:schemeClr val="accent1"/>
-          </a:effectRef>
-          <a:fontRef idx="minor">
-            <a:schemeClr val="lt1"/>
-          </a:fontRef>
-        </p:style>
-        <p:txBody>
-          <a:bodyPr rtlCol="0" anchor="ctr"/>
-          <a:lstStyle/>
-          <a:p>
-            <a:pPr algn="ctr"/>
-          </a:p>
-        </p:txBody>
-      </p:sp>
-      <p:sp>
-        <p:nvSpPr>
-          <p:cNvPr id="20" name="Right Arrow 19"/>
-          <p:cNvSpPr/>
-          <p:nvPr/>
-        </p:nvSpPr>
-        <p:spPr>
-          <a:xfrm>
-            <a:off x="8983751" y="3593591"/>
-            <a:ext cx="128015" cy="146304"/>
-          </a:xfrm>
-          <a:prstGeom prst="rightArrow">
-            <a:avLst/>
-          </a:prstGeom>
-          <a:solidFill>
-            <a:srgbClr val="B8C0CC"/>
-          </a:solidFill>
-          <a:ln>
-            <a:noFill/>
-          </a:ln>
-        </p:spPr>
-        <p:style>
-          <a:lnRef idx="1">
-            <a:schemeClr val="accent1"/>
-          </a:lnRef>
-          <a:fillRef idx="3">
-            <a:schemeClr val="accent1"/>
-          </a:fillRef>
-          <a:effectRef idx="2">
-            <a:schemeClr val="accent1"/>
-          </a:effectRef>
-          <a:fontRef idx="minor">
-            <a:schemeClr val="lt1"/>
-          </a:fontRef>
-        </p:style>
-        <p:txBody>
-          <a:bodyPr rtlCol="0" anchor="ctr"/>
-          <a:lstStyle/>
-          <a:p>
-            <a:pPr algn="ctr"/>
-          </a:p>
-        </p:txBody>
-      </p:sp>
-      <p:sp>
-        <p:nvSpPr>
-          <p:cNvPr id="21" name="Right Arrow 20"/>
-          <p:cNvSpPr/>
-          <p:nvPr/>
-        </p:nvSpPr>
-        <p:spPr>
-          <a:xfrm>
-            <a:off x="3079927" y="5404103"/>
-            <a:ext cx="128015" cy="146304"/>
-          </a:xfrm>
-          <a:prstGeom prst="rightArrow">
-            <a:avLst/>
-          </a:prstGeom>
-          <a:solidFill>
-            <a:srgbClr val="B8C0CC"/>
-          </a:solidFill>
-          <a:ln>
-            <a:noFill/>
-          </a:ln>
-        </p:spPr>
-        <p:style>
-          <a:lnRef idx="1">
-            <a:schemeClr val="accent1"/>
-          </a:lnRef>
-          <a:fillRef idx="3">
-            <a:schemeClr val="accent1"/>
-          </a:fillRef>
-          <a:effectRef idx="2">
-            <a:schemeClr val="accent1"/>
-          </a:effectRef>
-          <a:fontRef idx="minor">
-            <a:schemeClr val="lt1"/>
-          </a:fontRef>
-        </p:style>
-        <p:txBody>
-          <a:bodyPr rtlCol="0" anchor="ctr"/>
-          <a:lstStyle/>
-          <a:p>
-            <a:pPr algn="ctr"/>
-          </a:p>
-        </p:txBody>
-      </p:sp>
-      <p:sp>
-        <p:nvSpPr>
-          <p:cNvPr id="22" name="Right Arrow 21"/>
-          <p:cNvSpPr/>
-          <p:nvPr/>
-        </p:nvSpPr>
-        <p:spPr>
-          <a:xfrm>
-            <a:off x="6031839" y="5404103"/>
-            <a:ext cx="128015" cy="146304"/>
-          </a:xfrm>
-          <a:prstGeom prst="rightArrow">
-            <a:avLst/>
-          </a:prstGeom>
-          <a:solidFill>
-            <a:srgbClr val="B8C0CC"/>
-          </a:solidFill>
-          <a:ln>
-            <a:noFill/>
-          </a:ln>
-        </p:spPr>
-        <p:style>
-          <a:lnRef idx="1">
-            <a:schemeClr val="accent1"/>
-          </a:lnRef>
-          <a:fillRef idx="3">
-            <a:schemeClr val="accent1"/>
-          </a:fillRef>
-          <a:effectRef idx="2">
-            <a:schemeClr val="accent1"/>
-          </a:effectRef>
-          <a:fontRef idx="minor">
-            <a:schemeClr val="lt1"/>
-          </a:fontRef>
-        </p:style>
-        <p:txBody>
-          <a:bodyPr rtlCol="0" anchor="ctr"/>
-          <a:lstStyle/>
-          <a:p>
-            <a:pPr algn="ctr"/>
-          </a:p>
-        </p:txBody>
-      </p:sp>
-      <p:sp>
-        <p:nvSpPr>
-          <p:cNvPr id="23" name="Right Arrow 22"/>
-          <p:cNvSpPr/>
-          <p:nvPr/>
-        </p:nvSpPr>
-        <p:spPr>
-          <a:xfrm>
-            <a:off x="8983751" y="5404103"/>
-            <a:ext cx="128015" cy="146304"/>
-          </a:xfrm>
-          <a:prstGeom prst="rightArrow">
-            <a:avLst/>
-          </a:prstGeom>
-          <a:solidFill>
-            <a:srgbClr val="B8C0CC"/>
-          </a:solidFill>
-          <a:ln>
-            <a:noFill/>
-          </a:ln>
-        </p:spPr>
-        <p:style>
-          <a:lnRef idx="1">
-            <a:schemeClr val="accent1"/>
-          </a:lnRef>
-          <a:fillRef idx="3">
-            <a:schemeClr val="accent1"/>
-          </a:fillRef>
-          <a:effectRef idx="2">
-            <a:schemeClr val="accent1"/>
-          </a:effectRef>
-          <a:fontRef idx="minor">
-            <a:schemeClr val="lt1"/>
-          </a:fontRef>
-        </p:style>
-        <p:txBody>
-          <a:bodyPr rtlCol="0" anchor="ctr"/>
-          <a:lstStyle/>
-          <a:p>
-            <a:pPr algn="ctr"/>
-          </a:p>
-        </p:txBody>
-      </p:sp>
-      <p:sp>
-        <p:nvSpPr>
-          <p:cNvPr id="24" name="Rounded Rectangle 23"/>
-          <p:cNvSpPr/>
-          <p:nvPr/>
-        </p:nvSpPr>
-        <p:spPr>
-          <a:xfrm>
-            <a:off x="274320" y="1024128"/>
-            <a:ext cx="2787319" cy="1664207"/>
-          </a:xfrm>
-          <a:prstGeom prst="roundRect">
-            <a:avLst/>
-          </a:prstGeom>
-          <a:solidFill>
-            <a:srgbClr val="F8FAFC"/>
-          </a:solidFill>
-          <a:ln w="19050">
-            <a:solidFill>
-              <a:srgbClr val="E2E8F0"/>
-            </a:solidFill>
-          </a:ln>
-        </p:spPr>
-        <p:style>
-          <a:lnRef idx="1">
-            <a:schemeClr val="accent1"/>
-          </a:lnRef>
-          <a:fillRef idx="3">
-            <a:schemeClr val="accent1"/>
-          </a:fillRef>
-          <a:effectRef idx="2">
-            <a:schemeClr val="accent1"/>
-          </a:effectRef>
-          <a:fontRef idx="minor">
-            <a:schemeClr val="lt1"/>
-          </a:fontRef>
-        </p:style>
-        <p:txBody>
-          <a:bodyPr rtlCol="0" anchor="ctr"/>
-          <a:lstStyle/>
-          <a:p>
-            <a:pPr algn="ctr"/>
-          </a:p>
-        </p:txBody>
-      </p:sp>
-      <p:sp>
-        <p:nvSpPr>
-          <p:cNvPr id="25" name="Rounded Rectangle 24"/>
-          <p:cNvSpPr/>
-          <p:nvPr/>
-        </p:nvSpPr>
-        <p:spPr>
-          <a:xfrm>
-            <a:off x="274320" y="1024128"/>
-            <a:ext cx="91440" cy="1664207"/>
-          </a:xfrm>
-          <a:prstGeom prst="roundRect">
-            <a:avLst/>
-          </a:prstGeom>
-          <a:solidFill>
-            <a:srgbClr val="F58220"/>
-          </a:solidFill>
-          <a:ln>
-            <a:noFill/>
-          </a:ln>
-        </p:spPr>
-        <p:style>
-          <a:lnRef idx="1">
-            <a:schemeClr val="accent1"/>
-          </a:lnRef>
-          <a:fillRef idx="3">
-            <a:schemeClr val="accent1"/>
-          </a:fillRef>
-          <a:effectRef idx="2">
-            <a:schemeClr val="accent1"/>
-          </a:effectRef>
-          <a:fontRef idx="minor">
-            <a:schemeClr val="lt1"/>
-          </a:fontRef>
-        </p:style>
-        <p:txBody>
-          <a:bodyPr rtlCol="0" anchor="ctr"/>
-          <a:lstStyle/>
-          <a:p>
-            <a:pPr algn="ctr"/>
-          </a:p>
-        </p:txBody>
-      </p:sp>
-      <p:sp>
-        <p:nvSpPr>
-          <p:cNvPr id="26" name="Rounded Rectangle 25"/>
-          <p:cNvSpPr/>
-          <p:nvPr/>
-        </p:nvSpPr>
-        <p:spPr>
-          <a:xfrm>
-            <a:off x="438912" y="1133856"/>
-            <a:ext cx="438912" cy="256032"/>
-          </a:xfrm>
-          <a:prstGeom prst="roundRect">
-            <a:avLst/>
-          </a:prstGeom>
-          <a:solidFill>
-            <a:srgbClr val="F58220"/>
-          </a:solidFill>
-          <a:ln>
-            <a:noFill/>
-          </a:ln>
-        </p:spPr>
-        <p:style>
-          <a:lnRef idx="1">
-            <a:schemeClr val="accent1"/>
-          </a:lnRef>
-          <a:fillRef idx="3">
-            <a:schemeClr val="accent1"/>
-          </a:fillRef>
-          <a:effectRef idx="2">
-            <a:schemeClr val="accent1"/>
-          </a:effectRef>
-          <a:fontRef idx="minor">
-            <a:schemeClr val="lt1"/>
-          </a:fontRef>
-        </p:style>
-        <p:txBody>
-          <a:bodyPr rtlCol="0" anchor="ctr" wrap="square"/>
-          <a:lstStyle/>
-          <a:p>
-            <a:pPr algn="ctr"/>
-            <a:r>
-              <a:rPr sz="1100" b="1">
-                <a:solidFill>
-                  <a:srgbClr val="F8FAFC"/>
-                </a:solidFill>
-                <a:latin typeface="Calibri"/>
-              </a:rPr>
-              <a:t>01</a:t>
-            </a:r>
-          </a:p>
-        </p:txBody>
-      </p:sp>
-      <p:sp>
-        <p:nvSpPr>
-          <p:cNvPr id="27" name="TextBox 26"/>
-          <p:cNvSpPr txBox="1"/>
-          <p:nvPr/>
-        </p:nvSpPr>
-        <p:spPr>
-          <a:xfrm>
-            <a:off x="932688" y="1115568"/>
-            <a:ext cx="2010079" cy="292608"/>
-          </a:xfrm>
-          <a:prstGeom prst="rect">
-            <a:avLst/>
-          </a:prstGeom>
-          <a:noFill/>
-        </p:spPr>
-        <p:txBody>
-          <a:bodyPr wrap="square">
-            <a:spAutoFit/>
-          </a:bodyPr>
-          <a:lstStyle/>
-          <a:p>
-            <a:pPr algn="l"/>
-            <a:r>
-              <a:rPr sz="1300" b="1">
-                <a:solidFill>
-                  <a:srgbClr val="141E2E"/>
-                </a:solidFill>
-                <a:latin typeface="Calibri"/>
-              </a:rPr>
-              <a:t>Foundations</a:t>
-            </a:r>
-          </a:p>
-        </p:txBody>
-      </p:sp>
-      <p:sp>
-        <p:nvSpPr>
-          <p:cNvPr id="28" name="TextBox 27"/>
-          <p:cNvSpPr txBox="1"/>
-          <p:nvPr/>
-        </p:nvSpPr>
-        <p:spPr>
-          <a:xfrm>
-            <a:off x="932688" y="1371600"/>
-            <a:ext cx="2010079" cy="237744"/>
-          </a:xfrm>
-          <a:prstGeom prst="rect">
-            <a:avLst/>
-          </a:prstGeom>
-          <a:noFill/>
-        </p:spPr>
-        <p:txBody>
-          <a:bodyPr wrap="square">
-            <a:spAutoFit/>
-          </a:bodyPr>
-          <a:lstStyle/>
-          <a:p>
-            <a:pPr algn="l"/>
-            <a:r>
-              <a:rPr sz="1000" b="0">
-                <a:solidFill>
-                  <a:srgbClr val="606E7E"/>
-                </a:solidFill>
-                <a:latin typeface="Calibri"/>
-              </a:rPr>
-              <a:t>Linux · Bash · Git</a:t>
-            </a:r>
-          </a:p>
-        </p:txBody>
-      </p:sp>
       <p:pic>
         <p:nvPicPr>
-          <p:cNvPr id="29" name="Picture 28" descr="linux.png"/>
+          <p:cNvPr id="2" name="Picture 1" descr="devops_roadmap_infographic.png"/>
           <p:cNvPicPr>
             <a:picLocks noChangeAspect="1"/>
           </p:cNvPicPr>
@@ -8700,2992 +7600,14 @@
         </p:blipFill>
         <p:spPr>
           <a:xfrm>
-            <a:off x="1027899" y="1664208"/>
-            <a:ext cx="365760" cy="365760"/>
+            <a:off x="0" y="0"/>
+            <a:ext cx="12191695" cy="6858000"/>
           </a:xfrm>
           <a:prstGeom prst="rect">
             <a:avLst/>
           </a:prstGeom>
         </p:spPr>
       </p:pic>
-      <p:pic>
-        <p:nvPicPr>
-          <p:cNvPr id="30" name="Picture 29" descr="bash.png"/>
-          <p:cNvPicPr>
-            <a:picLocks noChangeAspect="1"/>
-          </p:cNvPicPr>
-          <p:nvPr/>
-        </p:nvPicPr>
-        <p:blipFill>
-          <a:blip r:embed="rId3"/>
-          <a:stretch>
-            <a:fillRect/>
-          </a:stretch>
-        </p:blipFill>
-        <p:spPr>
-          <a:xfrm>
-            <a:off x="1485099" y="1664208"/>
-            <a:ext cx="365760" cy="365760"/>
-          </a:xfrm>
-          <a:prstGeom prst="rect">
-            <a:avLst/>
-          </a:prstGeom>
-        </p:spPr>
-      </p:pic>
-      <p:pic>
-        <p:nvPicPr>
-          <p:cNvPr id="31" name="Picture 30" descr="git.png"/>
-          <p:cNvPicPr>
-            <a:picLocks noChangeAspect="1"/>
-          </p:cNvPicPr>
-          <p:nvPr/>
-        </p:nvPicPr>
-        <p:blipFill>
-          <a:blip r:embed="rId4"/>
-          <a:stretch>
-            <a:fillRect/>
-          </a:stretch>
-        </p:blipFill>
-        <p:spPr>
-          <a:xfrm>
-            <a:off x="1942299" y="1664208"/>
-            <a:ext cx="365760" cy="365760"/>
-          </a:xfrm>
-          <a:prstGeom prst="rect">
-            <a:avLst/>
-          </a:prstGeom>
-        </p:spPr>
-      </p:pic>
-      <p:sp>
-        <p:nvSpPr>
-          <p:cNvPr id="32" name="Rounded Rectangle 31"/>
-          <p:cNvSpPr/>
-          <p:nvPr/>
-        </p:nvSpPr>
-        <p:spPr>
-          <a:xfrm>
-            <a:off x="3226231" y="1024128"/>
-            <a:ext cx="2787319" cy="1664207"/>
-          </a:xfrm>
-          <a:prstGeom prst="roundRect">
-            <a:avLst/>
-          </a:prstGeom>
-          <a:solidFill>
-            <a:srgbClr val="F8FAFC"/>
-          </a:solidFill>
-          <a:ln w="19050">
-            <a:solidFill>
-              <a:srgbClr val="E2E8F0"/>
-            </a:solidFill>
-          </a:ln>
-        </p:spPr>
-        <p:style>
-          <a:lnRef idx="1">
-            <a:schemeClr val="accent1"/>
-          </a:lnRef>
-          <a:fillRef idx="3">
-            <a:schemeClr val="accent1"/>
-          </a:fillRef>
-          <a:effectRef idx="2">
-            <a:schemeClr val="accent1"/>
-          </a:effectRef>
-          <a:fontRef idx="minor">
-            <a:schemeClr val="lt1"/>
-          </a:fontRef>
-        </p:style>
-        <p:txBody>
-          <a:bodyPr rtlCol="0" anchor="ctr"/>
-          <a:lstStyle/>
-          <a:p>
-            <a:pPr algn="ctr"/>
-          </a:p>
-        </p:txBody>
-      </p:sp>
-      <p:sp>
-        <p:nvSpPr>
-          <p:cNvPr id="33" name="Rounded Rectangle 32"/>
-          <p:cNvSpPr/>
-          <p:nvPr/>
-        </p:nvSpPr>
-        <p:spPr>
-          <a:xfrm>
-            <a:off x="3226231" y="1024128"/>
-            <a:ext cx="91440" cy="1664207"/>
-          </a:xfrm>
-          <a:prstGeom prst="roundRect">
-            <a:avLst/>
-          </a:prstGeom>
-          <a:solidFill>
-            <a:srgbClr val="F58220"/>
-          </a:solidFill>
-          <a:ln>
-            <a:noFill/>
-          </a:ln>
-        </p:spPr>
-        <p:style>
-          <a:lnRef idx="1">
-            <a:schemeClr val="accent1"/>
-          </a:lnRef>
-          <a:fillRef idx="3">
-            <a:schemeClr val="accent1"/>
-          </a:fillRef>
-          <a:effectRef idx="2">
-            <a:schemeClr val="accent1"/>
-          </a:effectRef>
-          <a:fontRef idx="minor">
-            <a:schemeClr val="lt1"/>
-          </a:fontRef>
-        </p:style>
-        <p:txBody>
-          <a:bodyPr rtlCol="0" anchor="ctr"/>
-          <a:lstStyle/>
-          <a:p>
-            <a:pPr algn="ctr"/>
-          </a:p>
-        </p:txBody>
-      </p:sp>
-      <p:sp>
-        <p:nvSpPr>
-          <p:cNvPr id="34" name="Rounded Rectangle 33"/>
-          <p:cNvSpPr/>
-          <p:nvPr/>
-        </p:nvSpPr>
-        <p:spPr>
-          <a:xfrm>
-            <a:off x="3390823" y="1133856"/>
-            <a:ext cx="438912" cy="256032"/>
-          </a:xfrm>
-          <a:prstGeom prst="roundRect">
-            <a:avLst/>
-          </a:prstGeom>
-          <a:solidFill>
-            <a:srgbClr val="F58220"/>
-          </a:solidFill>
-          <a:ln>
-            <a:noFill/>
-          </a:ln>
-        </p:spPr>
-        <p:style>
-          <a:lnRef idx="1">
-            <a:schemeClr val="accent1"/>
-          </a:lnRef>
-          <a:fillRef idx="3">
-            <a:schemeClr val="accent1"/>
-          </a:fillRef>
-          <a:effectRef idx="2">
-            <a:schemeClr val="accent1"/>
-          </a:effectRef>
-          <a:fontRef idx="minor">
-            <a:schemeClr val="lt1"/>
-          </a:fontRef>
-        </p:style>
-        <p:txBody>
-          <a:bodyPr rtlCol="0" anchor="ctr" wrap="square"/>
-          <a:lstStyle/>
-          <a:p>
-            <a:pPr algn="ctr"/>
-            <a:r>
-              <a:rPr sz="1100" b="1">
-                <a:solidFill>
-                  <a:srgbClr val="F8FAFC"/>
-                </a:solidFill>
-                <a:latin typeface="Calibri"/>
-              </a:rPr>
-              <a:t>02</a:t>
-            </a:r>
-          </a:p>
-        </p:txBody>
-      </p:sp>
-      <p:sp>
-        <p:nvSpPr>
-          <p:cNvPr id="35" name="TextBox 34"/>
-          <p:cNvSpPr txBox="1"/>
-          <p:nvPr/>
-        </p:nvSpPr>
-        <p:spPr>
-          <a:xfrm>
-            <a:off x="3884599" y="1115568"/>
-            <a:ext cx="2010079" cy="292608"/>
-          </a:xfrm>
-          <a:prstGeom prst="rect">
-            <a:avLst/>
-          </a:prstGeom>
-          <a:noFill/>
-        </p:spPr>
-        <p:txBody>
-          <a:bodyPr wrap="square">
-            <a:spAutoFit/>
-          </a:bodyPr>
-          <a:lstStyle/>
-          <a:p>
-            <a:pPr algn="l"/>
-            <a:r>
-              <a:rPr sz="1300" b="1">
-                <a:solidFill>
-                  <a:srgbClr val="141E2E"/>
-                </a:solidFill>
-                <a:latin typeface="Calibri"/>
-              </a:rPr>
-              <a:t>Source Control</a:t>
-            </a:r>
-          </a:p>
-        </p:txBody>
-      </p:sp>
-      <p:sp>
-        <p:nvSpPr>
-          <p:cNvPr id="36" name="TextBox 35"/>
-          <p:cNvSpPr txBox="1"/>
-          <p:nvPr/>
-        </p:nvSpPr>
-        <p:spPr>
-          <a:xfrm>
-            <a:off x="3884599" y="1371600"/>
-            <a:ext cx="2010079" cy="237744"/>
-          </a:xfrm>
-          <a:prstGeom prst="rect">
-            <a:avLst/>
-          </a:prstGeom>
-          <a:noFill/>
-        </p:spPr>
-        <p:txBody>
-          <a:bodyPr wrap="square">
-            <a:spAutoFit/>
-          </a:bodyPr>
-          <a:lstStyle/>
-          <a:p>
-            <a:pPr algn="l"/>
-            <a:r>
-              <a:rPr sz="1000" b="0">
-                <a:solidFill>
-                  <a:srgbClr val="606E7E"/>
-                </a:solidFill>
-                <a:latin typeface="Calibri"/>
-              </a:rPr>
-              <a:t>Branches · PRs · Reviews</a:t>
-            </a:r>
-          </a:p>
-        </p:txBody>
-      </p:sp>
-      <p:pic>
-        <p:nvPicPr>
-          <p:cNvPr id="37" name="Picture 36" descr="git.png"/>
-          <p:cNvPicPr>
-            <a:picLocks noChangeAspect="1"/>
-          </p:cNvPicPr>
-          <p:nvPr/>
-        </p:nvPicPr>
-        <p:blipFill>
-          <a:blip r:embed="rId4"/>
-          <a:stretch>
-            <a:fillRect/>
-          </a:stretch>
-        </p:blipFill>
-        <p:spPr>
-          <a:xfrm>
-            <a:off x="4208411" y="1664208"/>
-            <a:ext cx="365760" cy="365760"/>
-          </a:xfrm>
-          <a:prstGeom prst="rect">
-            <a:avLst/>
-          </a:prstGeom>
-        </p:spPr>
-      </p:pic>
-      <p:pic>
-        <p:nvPicPr>
-          <p:cNvPr id="38" name="Picture 37" descr="github.png"/>
-          <p:cNvPicPr>
-            <a:picLocks noChangeAspect="1"/>
-          </p:cNvPicPr>
-          <p:nvPr/>
-        </p:nvPicPr>
-        <p:blipFill>
-          <a:blip r:embed="rId5"/>
-          <a:stretch>
-            <a:fillRect/>
-          </a:stretch>
-        </p:blipFill>
-        <p:spPr>
-          <a:xfrm>
-            <a:off x="4665611" y="1664208"/>
-            <a:ext cx="365760" cy="365760"/>
-          </a:xfrm>
-          <a:prstGeom prst="rect">
-            <a:avLst/>
-          </a:prstGeom>
-        </p:spPr>
-      </p:pic>
-      <p:sp>
-        <p:nvSpPr>
-          <p:cNvPr id="39" name="Rounded Rectangle 38"/>
-          <p:cNvSpPr/>
-          <p:nvPr/>
-        </p:nvSpPr>
-        <p:spPr>
-          <a:xfrm>
-            <a:off x="6178143" y="1024128"/>
-            <a:ext cx="2787319" cy="1664207"/>
-          </a:xfrm>
-          <a:prstGeom prst="roundRect">
-            <a:avLst/>
-          </a:prstGeom>
-          <a:solidFill>
-            <a:srgbClr val="F8FAFC"/>
-          </a:solidFill>
-          <a:ln w="19050">
-            <a:solidFill>
-              <a:srgbClr val="E2E8F0"/>
-            </a:solidFill>
-          </a:ln>
-        </p:spPr>
-        <p:style>
-          <a:lnRef idx="1">
-            <a:schemeClr val="accent1"/>
-          </a:lnRef>
-          <a:fillRef idx="3">
-            <a:schemeClr val="accent1"/>
-          </a:fillRef>
-          <a:effectRef idx="2">
-            <a:schemeClr val="accent1"/>
-          </a:effectRef>
-          <a:fontRef idx="minor">
-            <a:schemeClr val="lt1"/>
-          </a:fontRef>
-        </p:style>
-        <p:txBody>
-          <a:bodyPr rtlCol="0" anchor="ctr"/>
-          <a:lstStyle/>
-          <a:p>
-            <a:pPr algn="ctr"/>
-          </a:p>
-        </p:txBody>
-      </p:sp>
-      <p:sp>
-        <p:nvSpPr>
-          <p:cNvPr id="40" name="Rounded Rectangle 39"/>
-          <p:cNvSpPr/>
-          <p:nvPr/>
-        </p:nvSpPr>
-        <p:spPr>
-          <a:xfrm>
-            <a:off x="6178143" y="1024128"/>
-            <a:ext cx="91440" cy="1664207"/>
-          </a:xfrm>
-          <a:prstGeom prst="roundRect">
-            <a:avLst/>
-          </a:prstGeom>
-          <a:solidFill>
-            <a:srgbClr val="7C5CD4"/>
-          </a:solidFill>
-          <a:ln>
-            <a:noFill/>
-          </a:ln>
-        </p:spPr>
-        <p:style>
-          <a:lnRef idx="1">
-            <a:schemeClr val="accent1"/>
-          </a:lnRef>
-          <a:fillRef idx="3">
-            <a:schemeClr val="accent1"/>
-          </a:fillRef>
-          <a:effectRef idx="2">
-            <a:schemeClr val="accent1"/>
-          </a:effectRef>
-          <a:fontRef idx="minor">
-            <a:schemeClr val="lt1"/>
-          </a:fontRef>
-        </p:style>
-        <p:txBody>
-          <a:bodyPr rtlCol="0" anchor="ctr"/>
-          <a:lstStyle/>
-          <a:p>
-            <a:pPr algn="ctr"/>
-          </a:p>
-        </p:txBody>
-      </p:sp>
-      <p:sp>
-        <p:nvSpPr>
-          <p:cNvPr id="41" name="Rounded Rectangle 40"/>
-          <p:cNvSpPr/>
-          <p:nvPr/>
-        </p:nvSpPr>
-        <p:spPr>
-          <a:xfrm>
-            <a:off x="6342735" y="1133856"/>
-            <a:ext cx="438912" cy="256032"/>
-          </a:xfrm>
-          <a:prstGeom prst="roundRect">
-            <a:avLst/>
-          </a:prstGeom>
-          <a:solidFill>
-            <a:srgbClr val="7C5CD4"/>
-          </a:solidFill>
-          <a:ln>
-            <a:noFill/>
-          </a:ln>
-        </p:spPr>
-        <p:style>
-          <a:lnRef idx="1">
-            <a:schemeClr val="accent1"/>
-          </a:lnRef>
-          <a:fillRef idx="3">
-            <a:schemeClr val="accent1"/>
-          </a:fillRef>
-          <a:effectRef idx="2">
-            <a:schemeClr val="accent1"/>
-          </a:effectRef>
-          <a:fontRef idx="minor">
-            <a:schemeClr val="lt1"/>
-          </a:fontRef>
-        </p:style>
-        <p:txBody>
-          <a:bodyPr rtlCol="0" anchor="ctr" wrap="square"/>
-          <a:lstStyle/>
-          <a:p>
-            <a:pPr algn="ctr"/>
-            <a:r>
-              <a:rPr sz="1100" b="1">
-                <a:solidFill>
-                  <a:srgbClr val="F8FAFC"/>
-                </a:solidFill>
-                <a:latin typeface="Calibri"/>
-              </a:rPr>
-              <a:t>03</a:t>
-            </a:r>
-          </a:p>
-        </p:txBody>
-      </p:sp>
-      <p:sp>
-        <p:nvSpPr>
-          <p:cNvPr id="42" name="TextBox 41"/>
-          <p:cNvSpPr txBox="1"/>
-          <p:nvPr/>
-        </p:nvSpPr>
-        <p:spPr>
-          <a:xfrm>
-            <a:off x="6836511" y="1115568"/>
-            <a:ext cx="2010079" cy="292608"/>
-          </a:xfrm>
-          <a:prstGeom prst="rect">
-            <a:avLst/>
-          </a:prstGeom>
-          <a:noFill/>
-        </p:spPr>
-        <p:txBody>
-          <a:bodyPr wrap="square">
-            <a:spAutoFit/>
-          </a:bodyPr>
-          <a:lstStyle/>
-          <a:p>
-            <a:pPr algn="l"/>
-            <a:r>
-              <a:rPr sz="1300" b="1">
-                <a:solidFill>
-                  <a:srgbClr val="141E2E"/>
-                </a:solidFill>
-                <a:latin typeface="Calibri"/>
-              </a:rPr>
-              <a:t>Containerization</a:t>
-            </a:r>
-          </a:p>
-        </p:txBody>
-      </p:sp>
-      <p:sp>
-        <p:nvSpPr>
-          <p:cNvPr id="43" name="TextBox 42"/>
-          <p:cNvSpPr txBox="1"/>
-          <p:nvPr/>
-        </p:nvSpPr>
-        <p:spPr>
-          <a:xfrm>
-            <a:off x="6836511" y="1371600"/>
-            <a:ext cx="2010079" cy="237744"/>
-          </a:xfrm>
-          <a:prstGeom prst="rect">
-            <a:avLst/>
-          </a:prstGeom>
-          <a:noFill/>
-        </p:spPr>
-        <p:txBody>
-          <a:bodyPr wrap="square">
-            <a:spAutoFit/>
-          </a:bodyPr>
-          <a:lstStyle/>
-          <a:p>
-            <a:pPr algn="l"/>
-            <a:r>
-              <a:rPr sz="1000" b="0">
-                <a:solidFill>
-                  <a:srgbClr val="606E7E"/>
-                </a:solidFill>
-                <a:latin typeface="Calibri"/>
-              </a:rPr>
-              <a:t>Docker &amp; Images</a:t>
-            </a:r>
-          </a:p>
-        </p:txBody>
-      </p:sp>
-      <p:pic>
-        <p:nvPicPr>
-          <p:cNvPr id="44" name="Picture 43" descr="docker.png"/>
-          <p:cNvPicPr>
-            <a:picLocks noChangeAspect="1"/>
-          </p:cNvPicPr>
-          <p:nvPr/>
-        </p:nvPicPr>
-        <p:blipFill>
-          <a:blip r:embed="rId6"/>
-          <a:stretch>
-            <a:fillRect/>
-          </a:stretch>
-        </p:blipFill>
-        <p:spPr>
-          <a:xfrm>
-            <a:off x="7388923" y="1664208"/>
-            <a:ext cx="365760" cy="365760"/>
-          </a:xfrm>
-          <a:prstGeom prst="rect">
-            <a:avLst/>
-          </a:prstGeom>
-        </p:spPr>
-      </p:pic>
-      <p:sp>
-        <p:nvSpPr>
-          <p:cNvPr id="45" name="Rounded Rectangle 44"/>
-          <p:cNvSpPr/>
-          <p:nvPr/>
-        </p:nvSpPr>
-        <p:spPr>
-          <a:xfrm>
-            <a:off x="9130055" y="1024128"/>
-            <a:ext cx="2787319" cy="1664207"/>
-          </a:xfrm>
-          <a:prstGeom prst="roundRect">
-            <a:avLst/>
-          </a:prstGeom>
-          <a:solidFill>
-            <a:srgbClr val="F8FAFC"/>
-          </a:solidFill>
-          <a:ln w="19050">
-            <a:solidFill>
-              <a:srgbClr val="E2E8F0"/>
-            </a:solidFill>
-          </a:ln>
-        </p:spPr>
-        <p:style>
-          <a:lnRef idx="1">
-            <a:schemeClr val="accent1"/>
-          </a:lnRef>
-          <a:fillRef idx="3">
-            <a:schemeClr val="accent1"/>
-          </a:fillRef>
-          <a:effectRef idx="2">
-            <a:schemeClr val="accent1"/>
-          </a:effectRef>
-          <a:fontRef idx="minor">
-            <a:schemeClr val="lt1"/>
-          </a:fontRef>
-        </p:style>
-        <p:txBody>
-          <a:bodyPr rtlCol="0" anchor="ctr"/>
-          <a:lstStyle/>
-          <a:p>
-            <a:pPr algn="ctr"/>
-          </a:p>
-        </p:txBody>
-      </p:sp>
-      <p:sp>
-        <p:nvSpPr>
-          <p:cNvPr id="46" name="Rounded Rectangle 45"/>
-          <p:cNvSpPr/>
-          <p:nvPr/>
-        </p:nvSpPr>
-        <p:spPr>
-          <a:xfrm>
-            <a:off x="9130055" y="1024128"/>
-            <a:ext cx="91440" cy="1664207"/>
-          </a:xfrm>
-          <a:prstGeom prst="roundRect">
-            <a:avLst/>
-          </a:prstGeom>
-          <a:solidFill>
-            <a:srgbClr val="7C5CD4"/>
-          </a:solidFill>
-          <a:ln>
-            <a:noFill/>
-          </a:ln>
-        </p:spPr>
-        <p:style>
-          <a:lnRef idx="1">
-            <a:schemeClr val="accent1"/>
-          </a:lnRef>
-          <a:fillRef idx="3">
-            <a:schemeClr val="accent1"/>
-          </a:fillRef>
-          <a:effectRef idx="2">
-            <a:schemeClr val="accent1"/>
-          </a:effectRef>
-          <a:fontRef idx="minor">
-            <a:schemeClr val="lt1"/>
-          </a:fontRef>
-        </p:style>
-        <p:txBody>
-          <a:bodyPr rtlCol="0" anchor="ctr"/>
-          <a:lstStyle/>
-          <a:p>
-            <a:pPr algn="ctr"/>
-          </a:p>
-        </p:txBody>
-      </p:sp>
-      <p:sp>
-        <p:nvSpPr>
-          <p:cNvPr id="47" name="Rounded Rectangle 46"/>
-          <p:cNvSpPr/>
-          <p:nvPr/>
-        </p:nvSpPr>
-        <p:spPr>
-          <a:xfrm>
-            <a:off x="9294647" y="1133856"/>
-            <a:ext cx="438912" cy="256032"/>
-          </a:xfrm>
-          <a:prstGeom prst="roundRect">
-            <a:avLst/>
-          </a:prstGeom>
-          <a:solidFill>
-            <a:srgbClr val="7C5CD4"/>
-          </a:solidFill>
-          <a:ln>
-            <a:noFill/>
-          </a:ln>
-        </p:spPr>
-        <p:style>
-          <a:lnRef idx="1">
-            <a:schemeClr val="accent1"/>
-          </a:lnRef>
-          <a:fillRef idx="3">
-            <a:schemeClr val="accent1"/>
-          </a:fillRef>
-          <a:effectRef idx="2">
-            <a:schemeClr val="accent1"/>
-          </a:effectRef>
-          <a:fontRef idx="minor">
-            <a:schemeClr val="lt1"/>
-          </a:fontRef>
-        </p:style>
-        <p:txBody>
-          <a:bodyPr rtlCol="0" anchor="ctr" wrap="square"/>
-          <a:lstStyle/>
-          <a:p>
-            <a:pPr algn="ctr"/>
-            <a:r>
-              <a:rPr sz="1100" b="1">
-                <a:solidFill>
-                  <a:srgbClr val="F8FAFC"/>
-                </a:solidFill>
-                <a:latin typeface="Calibri"/>
-              </a:rPr>
-              <a:t>04</a:t>
-            </a:r>
-          </a:p>
-        </p:txBody>
-      </p:sp>
-      <p:sp>
-        <p:nvSpPr>
-          <p:cNvPr id="48" name="TextBox 47"/>
-          <p:cNvSpPr txBox="1"/>
-          <p:nvPr/>
-        </p:nvSpPr>
-        <p:spPr>
-          <a:xfrm>
-            <a:off x="9788423" y="1115568"/>
-            <a:ext cx="2010079" cy="292608"/>
-          </a:xfrm>
-          <a:prstGeom prst="rect">
-            <a:avLst/>
-          </a:prstGeom>
-          <a:noFill/>
-        </p:spPr>
-        <p:txBody>
-          <a:bodyPr wrap="square">
-            <a:spAutoFit/>
-          </a:bodyPr>
-          <a:lstStyle/>
-          <a:p>
-            <a:pPr algn="l"/>
-            <a:r>
-              <a:rPr sz="1300" b="1">
-                <a:solidFill>
-                  <a:srgbClr val="141E2E"/>
-                </a:solidFill>
-                <a:latin typeface="Calibri"/>
-              </a:rPr>
-              <a:t>CI / CD</a:t>
-            </a:r>
-          </a:p>
-        </p:txBody>
-      </p:sp>
-      <p:sp>
-        <p:nvSpPr>
-          <p:cNvPr id="49" name="TextBox 48"/>
-          <p:cNvSpPr txBox="1"/>
-          <p:nvPr/>
-        </p:nvSpPr>
-        <p:spPr>
-          <a:xfrm>
-            <a:off x="9788423" y="1371600"/>
-            <a:ext cx="2010079" cy="237744"/>
-          </a:xfrm>
-          <a:prstGeom prst="rect">
-            <a:avLst/>
-          </a:prstGeom>
-          <a:noFill/>
-        </p:spPr>
-        <p:txBody>
-          <a:bodyPr wrap="square">
-            <a:spAutoFit/>
-          </a:bodyPr>
-          <a:lstStyle/>
-          <a:p>
-            <a:pPr algn="l"/>
-            <a:r>
-              <a:rPr sz="1000" b="0">
-                <a:solidFill>
-                  <a:srgbClr val="606E7E"/>
-                </a:solidFill>
-                <a:latin typeface="Calibri"/>
-              </a:rPr>
-              <a:t>Jenkins · GitHub Actions</a:t>
-            </a:r>
-          </a:p>
-        </p:txBody>
-      </p:sp>
-      <p:pic>
-        <p:nvPicPr>
-          <p:cNvPr id="50" name="Picture 49" descr="jenkins.png"/>
-          <p:cNvPicPr>
-            <a:picLocks noChangeAspect="1"/>
-          </p:cNvPicPr>
-          <p:nvPr/>
-        </p:nvPicPr>
-        <p:blipFill>
-          <a:blip r:embed="rId7"/>
-          <a:stretch>
-            <a:fillRect/>
-          </a:stretch>
-        </p:blipFill>
-        <p:spPr>
-          <a:xfrm>
-            <a:off x="10112235" y="1664208"/>
-            <a:ext cx="365760" cy="365760"/>
-          </a:xfrm>
-          <a:prstGeom prst="rect">
-            <a:avLst/>
-          </a:prstGeom>
-        </p:spPr>
-      </p:pic>
-      <p:pic>
-        <p:nvPicPr>
-          <p:cNvPr id="51" name="Picture 50" descr="githubactions.png"/>
-          <p:cNvPicPr>
-            <a:picLocks noChangeAspect="1"/>
-          </p:cNvPicPr>
-          <p:nvPr/>
-        </p:nvPicPr>
-        <p:blipFill>
-          <a:blip r:embed="rId8"/>
-          <a:stretch>
-            <a:fillRect/>
-          </a:stretch>
-        </p:blipFill>
-        <p:spPr>
-          <a:xfrm>
-            <a:off x="10569435" y="1664208"/>
-            <a:ext cx="365760" cy="365760"/>
-          </a:xfrm>
-          <a:prstGeom prst="rect">
-            <a:avLst/>
-          </a:prstGeom>
-        </p:spPr>
-      </p:pic>
-      <p:sp>
-        <p:nvSpPr>
-          <p:cNvPr id="52" name="Rounded Rectangle 51"/>
-          <p:cNvSpPr/>
-          <p:nvPr/>
-        </p:nvSpPr>
-        <p:spPr>
-          <a:xfrm>
-            <a:off x="274320" y="2834639"/>
-            <a:ext cx="2787319" cy="1664207"/>
-          </a:xfrm>
-          <a:prstGeom prst="roundRect">
-            <a:avLst/>
-          </a:prstGeom>
-          <a:solidFill>
-            <a:srgbClr val="F8FAFC"/>
-          </a:solidFill>
-          <a:ln w="19050">
-            <a:solidFill>
-              <a:srgbClr val="E2E8F0"/>
-            </a:solidFill>
-          </a:ln>
-        </p:spPr>
-        <p:style>
-          <a:lnRef idx="1">
-            <a:schemeClr val="accent1"/>
-          </a:lnRef>
-          <a:fillRef idx="3">
-            <a:schemeClr val="accent1"/>
-          </a:fillRef>
-          <a:effectRef idx="2">
-            <a:schemeClr val="accent1"/>
-          </a:effectRef>
-          <a:fontRef idx="minor">
-            <a:schemeClr val="lt1"/>
-          </a:fontRef>
-        </p:style>
-        <p:txBody>
-          <a:bodyPr rtlCol="0" anchor="ctr"/>
-          <a:lstStyle/>
-          <a:p>
-            <a:pPr algn="ctr"/>
-          </a:p>
-        </p:txBody>
-      </p:sp>
-      <p:sp>
-        <p:nvSpPr>
-          <p:cNvPr id="53" name="Rounded Rectangle 52"/>
-          <p:cNvSpPr/>
-          <p:nvPr/>
-        </p:nvSpPr>
-        <p:spPr>
-          <a:xfrm>
-            <a:off x="274320" y="2834639"/>
-            <a:ext cx="91440" cy="1664207"/>
-          </a:xfrm>
-          <a:prstGeom prst="roundRect">
-            <a:avLst/>
-          </a:prstGeom>
-          <a:solidFill>
-            <a:srgbClr val="387ED6"/>
-          </a:solidFill>
-          <a:ln>
-            <a:noFill/>
-          </a:ln>
-        </p:spPr>
-        <p:style>
-          <a:lnRef idx="1">
-            <a:schemeClr val="accent1"/>
-          </a:lnRef>
-          <a:fillRef idx="3">
-            <a:schemeClr val="accent1"/>
-          </a:fillRef>
-          <a:effectRef idx="2">
-            <a:schemeClr val="accent1"/>
-          </a:effectRef>
-          <a:fontRef idx="minor">
-            <a:schemeClr val="lt1"/>
-          </a:fontRef>
-        </p:style>
-        <p:txBody>
-          <a:bodyPr rtlCol="0" anchor="ctr"/>
-          <a:lstStyle/>
-          <a:p>
-            <a:pPr algn="ctr"/>
-          </a:p>
-        </p:txBody>
-      </p:sp>
-      <p:sp>
-        <p:nvSpPr>
-          <p:cNvPr id="54" name="Rounded Rectangle 53"/>
-          <p:cNvSpPr/>
-          <p:nvPr/>
-        </p:nvSpPr>
-        <p:spPr>
-          <a:xfrm>
-            <a:off x="438912" y="2944368"/>
-            <a:ext cx="438912" cy="256032"/>
-          </a:xfrm>
-          <a:prstGeom prst="roundRect">
-            <a:avLst/>
-          </a:prstGeom>
-          <a:solidFill>
-            <a:srgbClr val="387ED6"/>
-          </a:solidFill>
-          <a:ln>
-            <a:noFill/>
-          </a:ln>
-        </p:spPr>
-        <p:style>
-          <a:lnRef idx="1">
-            <a:schemeClr val="accent1"/>
-          </a:lnRef>
-          <a:fillRef idx="3">
-            <a:schemeClr val="accent1"/>
-          </a:fillRef>
-          <a:effectRef idx="2">
-            <a:schemeClr val="accent1"/>
-          </a:effectRef>
-          <a:fontRef idx="minor">
-            <a:schemeClr val="lt1"/>
-          </a:fontRef>
-        </p:style>
-        <p:txBody>
-          <a:bodyPr rtlCol="0" anchor="ctr" wrap="square"/>
-          <a:lstStyle/>
-          <a:p>
-            <a:pPr algn="ctr"/>
-            <a:r>
-              <a:rPr sz="1100" b="1">
-                <a:solidFill>
-                  <a:srgbClr val="F8FAFC"/>
-                </a:solidFill>
-                <a:latin typeface="Calibri"/>
-              </a:rPr>
-              <a:t>05</a:t>
-            </a:r>
-          </a:p>
-        </p:txBody>
-      </p:sp>
-      <p:sp>
-        <p:nvSpPr>
-          <p:cNvPr id="55" name="TextBox 54"/>
-          <p:cNvSpPr txBox="1"/>
-          <p:nvPr/>
-        </p:nvSpPr>
-        <p:spPr>
-          <a:xfrm>
-            <a:off x="932688" y="2926079"/>
-            <a:ext cx="2010079" cy="292608"/>
-          </a:xfrm>
-          <a:prstGeom prst="rect">
-            <a:avLst/>
-          </a:prstGeom>
-          <a:noFill/>
-        </p:spPr>
-        <p:txBody>
-          <a:bodyPr wrap="square">
-            <a:spAutoFit/>
-          </a:bodyPr>
-          <a:lstStyle/>
-          <a:p>
-            <a:pPr algn="l"/>
-            <a:r>
-              <a:rPr sz="1300" b="1">
-                <a:solidFill>
-                  <a:srgbClr val="141E2E"/>
-                </a:solidFill>
-                <a:latin typeface="Calibri"/>
-              </a:rPr>
-              <a:t>Cloud Platforms</a:t>
-            </a:r>
-          </a:p>
-        </p:txBody>
-      </p:sp>
-      <p:sp>
-        <p:nvSpPr>
-          <p:cNvPr id="56" name="TextBox 55"/>
-          <p:cNvSpPr txBox="1"/>
-          <p:nvPr/>
-        </p:nvSpPr>
-        <p:spPr>
-          <a:xfrm>
-            <a:off x="932688" y="3182111"/>
-            <a:ext cx="2010079" cy="237744"/>
-          </a:xfrm>
-          <a:prstGeom prst="rect">
-            <a:avLst/>
-          </a:prstGeom>
-          <a:noFill/>
-        </p:spPr>
-        <p:txBody>
-          <a:bodyPr wrap="square">
-            <a:spAutoFit/>
-          </a:bodyPr>
-          <a:lstStyle/>
-          <a:p>
-            <a:pPr algn="l"/>
-            <a:r>
-              <a:rPr sz="1000" b="0">
-                <a:solidFill>
-                  <a:srgbClr val="606E7E"/>
-                </a:solidFill>
-                <a:latin typeface="Calibri"/>
-              </a:rPr>
-              <a:t>EC2 · VPC · IAM · S3 · ECS/EKS</a:t>
-            </a:r>
-          </a:p>
-        </p:txBody>
-      </p:sp>
-      <p:pic>
-        <p:nvPicPr>
-          <p:cNvPr id="57" name="Picture 56" descr="amazonaws.png"/>
-          <p:cNvPicPr>
-            <a:picLocks noChangeAspect="1"/>
-          </p:cNvPicPr>
-          <p:nvPr/>
-        </p:nvPicPr>
-        <p:blipFill>
-          <a:blip r:embed="rId9"/>
-          <a:stretch>
-            <a:fillRect/>
-          </a:stretch>
-        </p:blipFill>
-        <p:spPr>
-          <a:xfrm>
-            <a:off x="1027899" y="3474720"/>
-            <a:ext cx="365760" cy="365760"/>
-          </a:xfrm>
-          <a:prstGeom prst="rect">
-            <a:avLst/>
-          </a:prstGeom>
-        </p:spPr>
-      </p:pic>
-      <p:pic>
-        <p:nvPicPr>
-          <p:cNvPr id="58" name="Picture 57" descr="googlecloud.png"/>
-          <p:cNvPicPr>
-            <a:picLocks noChangeAspect="1"/>
-          </p:cNvPicPr>
-          <p:nvPr/>
-        </p:nvPicPr>
-        <p:blipFill>
-          <a:blip r:embed="rId10"/>
-          <a:stretch>
-            <a:fillRect/>
-          </a:stretch>
-        </p:blipFill>
-        <p:spPr>
-          <a:xfrm>
-            <a:off x="1485099" y="3474720"/>
-            <a:ext cx="365760" cy="365760"/>
-          </a:xfrm>
-          <a:prstGeom prst="rect">
-            <a:avLst/>
-          </a:prstGeom>
-        </p:spPr>
-      </p:pic>
-      <p:pic>
-        <p:nvPicPr>
-          <p:cNvPr id="59" name="Picture 58" descr="microsoftazure.png"/>
-          <p:cNvPicPr>
-            <a:picLocks noChangeAspect="1"/>
-          </p:cNvPicPr>
-          <p:nvPr/>
-        </p:nvPicPr>
-        <p:blipFill>
-          <a:blip r:embed="rId11"/>
-          <a:stretch>
-            <a:fillRect/>
-          </a:stretch>
-        </p:blipFill>
-        <p:spPr>
-          <a:xfrm>
-            <a:off x="1942299" y="3474720"/>
-            <a:ext cx="365760" cy="365760"/>
-          </a:xfrm>
-          <a:prstGeom prst="rect">
-            <a:avLst/>
-          </a:prstGeom>
-        </p:spPr>
-      </p:pic>
-      <p:sp>
-        <p:nvSpPr>
-          <p:cNvPr id="60" name="Rounded Rectangle 59"/>
-          <p:cNvSpPr/>
-          <p:nvPr/>
-        </p:nvSpPr>
-        <p:spPr>
-          <a:xfrm>
-            <a:off x="3226231" y="2834639"/>
-            <a:ext cx="2787319" cy="1664207"/>
-          </a:xfrm>
-          <a:prstGeom prst="roundRect">
-            <a:avLst/>
-          </a:prstGeom>
-          <a:solidFill>
-            <a:srgbClr val="F8FAFC"/>
-          </a:solidFill>
-          <a:ln w="19050">
-            <a:solidFill>
-              <a:srgbClr val="E2E8F0"/>
-            </a:solidFill>
-          </a:ln>
-        </p:spPr>
-        <p:style>
-          <a:lnRef idx="1">
-            <a:schemeClr val="accent1"/>
-          </a:lnRef>
-          <a:fillRef idx="3">
-            <a:schemeClr val="accent1"/>
-          </a:fillRef>
-          <a:effectRef idx="2">
-            <a:schemeClr val="accent1"/>
-          </a:effectRef>
-          <a:fontRef idx="minor">
-            <a:schemeClr val="lt1"/>
-          </a:fontRef>
-        </p:style>
-        <p:txBody>
-          <a:bodyPr rtlCol="0" anchor="ctr"/>
-          <a:lstStyle/>
-          <a:p>
-            <a:pPr algn="ctr"/>
-          </a:p>
-        </p:txBody>
-      </p:sp>
-      <p:sp>
-        <p:nvSpPr>
-          <p:cNvPr id="61" name="Rounded Rectangle 60"/>
-          <p:cNvSpPr/>
-          <p:nvPr/>
-        </p:nvSpPr>
-        <p:spPr>
-          <a:xfrm>
-            <a:off x="3226231" y="2834639"/>
-            <a:ext cx="91440" cy="1664207"/>
-          </a:xfrm>
-          <a:prstGeom prst="roundRect">
-            <a:avLst/>
-          </a:prstGeom>
-          <a:solidFill>
-            <a:srgbClr val="4F46B4"/>
-          </a:solidFill>
-          <a:ln>
-            <a:noFill/>
-          </a:ln>
-        </p:spPr>
-        <p:style>
-          <a:lnRef idx="1">
-            <a:schemeClr val="accent1"/>
-          </a:lnRef>
-          <a:fillRef idx="3">
-            <a:schemeClr val="accent1"/>
-          </a:fillRef>
-          <a:effectRef idx="2">
-            <a:schemeClr val="accent1"/>
-          </a:effectRef>
-          <a:fontRef idx="minor">
-            <a:schemeClr val="lt1"/>
-          </a:fontRef>
-        </p:style>
-        <p:txBody>
-          <a:bodyPr rtlCol="0" anchor="ctr"/>
-          <a:lstStyle/>
-          <a:p>
-            <a:pPr algn="ctr"/>
-          </a:p>
-        </p:txBody>
-      </p:sp>
-      <p:sp>
-        <p:nvSpPr>
-          <p:cNvPr id="62" name="Rounded Rectangle 61"/>
-          <p:cNvSpPr/>
-          <p:nvPr/>
-        </p:nvSpPr>
-        <p:spPr>
-          <a:xfrm>
-            <a:off x="3390823" y="2944368"/>
-            <a:ext cx="438912" cy="256032"/>
-          </a:xfrm>
-          <a:prstGeom prst="roundRect">
-            <a:avLst/>
-          </a:prstGeom>
-          <a:solidFill>
-            <a:srgbClr val="4F46B4"/>
-          </a:solidFill>
-          <a:ln>
-            <a:noFill/>
-          </a:ln>
-        </p:spPr>
-        <p:style>
-          <a:lnRef idx="1">
-            <a:schemeClr val="accent1"/>
-          </a:lnRef>
-          <a:fillRef idx="3">
-            <a:schemeClr val="accent1"/>
-          </a:fillRef>
-          <a:effectRef idx="2">
-            <a:schemeClr val="accent1"/>
-          </a:effectRef>
-          <a:fontRef idx="minor">
-            <a:schemeClr val="lt1"/>
-          </a:fontRef>
-        </p:style>
-        <p:txBody>
-          <a:bodyPr rtlCol="0" anchor="ctr" wrap="square"/>
-          <a:lstStyle/>
-          <a:p>
-            <a:pPr algn="ctr"/>
-            <a:r>
-              <a:rPr sz="1100" b="1">
-                <a:solidFill>
-                  <a:srgbClr val="F8FAFC"/>
-                </a:solidFill>
-                <a:latin typeface="Calibri"/>
-              </a:rPr>
-              <a:t>06</a:t>
-            </a:r>
-          </a:p>
-        </p:txBody>
-      </p:sp>
-      <p:sp>
-        <p:nvSpPr>
-          <p:cNvPr id="63" name="TextBox 62"/>
-          <p:cNvSpPr txBox="1"/>
-          <p:nvPr/>
-        </p:nvSpPr>
-        <p:spPr>
-          <a:xfrm>
-            <a:off x="3884599" y="2926079"/>
-            <a:ext cx="2010079" cy="292608"/>
-          </a:xfrm>
-          <a:prstGeom prst="rect">
-            <a:avLst/>
-          </a:prstGeom>
-          <a:noFill/>
-        </p:spPr>
-        <p:txBody>
-          <a:bodyPr wrap="square">
-            <a:spAutoFit/>
-          </a:bodyPr>
-          <a:lstStyle/>
-          <a:p>
-            <a:pPr algn="l"/>
-            <a:r>
-              <a:rPr sz="1300" b="1">
-                <a:solidFill>
-                  <a:srgbClr val="141E2E"/>
-                </a:solidFill>
-                <a:latin typeface="Calibri"/>
-              </a:rPr>
-              <a:t>Infrastructure as Code</a:t>
-            </a:r>
-          </a:p>
-        </p:txBody>
-      </p:sp>
-      <p:sp>
-        <p:nvSpPr>
-          <p:cNvPr id="64" name="TextBox 63"/>
-          <p:cNvSpPr txBox="1"/>
-          <p:nvPr/>
-        </p:nvSpPr>
-        <p:spPr>
-          <a:xfrm>
-            <a:off x="3884599" y="3182111"/>
-            <a:ext cx="2010079" cy="237744"/>
-          </a:xfrm>
-          <a:prstGeom prst="rect">
-            <a:avLst/>
-          </a:prstGeom>
-          <a:noFill/>
-        </p:spPr>
-        <p:txBody>
-          <a:bodyPr wrap="square">
-            <a:spAutoFit/>
-          </a:bodyPr>
-          <a:lstStyle/>
-          <a:p>
-            <a:pPr algn="l"/>
-            <a:r>
-              <a:rPr sz="1000" b="0">
-                <a:solidFill>
-                  <a:srgbClr val="606E7E"/>
-                </a:solidFill>
-                <a:latin typeface="Calibri"/>
-              </a:rPr>
-              <a:t>Terraform · CloudFormation</a:t>
-            </a:r>
-          </a:p>
-        </p:txBody>
-      </p:sp>
-      <p:pic>
-        <p:nvPicPr>
-          <p:cNvPr id="65" name="Picture 64" descr="terraform.png"/>
-          <p:cNvPicPr>
-            <a:picLocks noChangeAspect="1"/>
-          </p:cNvPicPr>
-          <p:nvPr/>
-        </p:nvPicPr>
-        <p:blipFill>
-          <a:blip r:embed="rId12"/>
-          <a:stretch>
-            <a:fillRect/>
-          </a:stretch>
-        </p:blipFill>
-        <p:spPr>
-          <a:xfrm>
-            <a:off x="4208411" y="3474720"/>
-            <a:ext cx="365760" cy="365760"/>
-          </a:xfrm>
-          <a:prstGeom prst="rect">
-            <a:avLst/>
-          </a:prstGeom>
-        </p:spPr>
-      </p:pic>
-      <p:pic>
-        <p:nvPicPr>
-          <p:cNvPr id="66" name="Picture 65" descr="cloudformation.png"/>
-          <p:cNvPicPr>
-            <a:picLocks noChangeAspect="1"/>
-          </p:cNvPicPr>
-          <p:nvPr/>
-        </p:nvPicPr>
-        <p:blipFill>
-          <a:blip r:embed="rId13"/>
-          <a:stretch>
-            <a:fillRect/>
-          </a:stretch>
-        </p:blipFill>
-        <p:spPr>
-          <a:xfrm>
-            <a:off x="4665611" y="3474720"/>
-            <a:ext cx="365760" cy="365760"/>
-          </a:xfrm>
-          <a:prstGeom prst="rect">
-            <a:avLst/>
-          </a:prstGeom>
-        </p:spPr>
-      </p:pic>
-      <p:sp>
-        <p:nvSpPr>
-          <p:cNvPr id="67" name="Rounded Rectangle 66"/>
-          <p:cNvSpPr/>
-          <p:nvPr/>
-        </p:nvSpPr>
-        <p:spPr>
-          <a:xfrm>
-            <a:off x="6178143" y="2834639"/>
-            <a:ext cx="2787319" cy="1664207"/>
-          </a:xfrm>
-          <a:prstGeom prst="roundRect">
-            <a:avLst/>
-          </a:prstGeom>
-          <a:solidFill>
-            <a:srgbClr val="F8FAFC"/>
-          </a:solidFill>
-          <a:ln w="19050">
-            <a:solidFill>
-              <a:srgbClr val="E2E8F0"/>
-            </a:solidFill>
-          </a:ln>
-        </p:spPr>
-        <p:style>
-          <a:lnRef idx="1">
-            <a:schemeClr val="accent1"/>
-          </a:lnRef>
-          <a:fillRef idx="3">
-            <a:schemeClr val="accent1"/>
-          </a:fillRef>
-          <a:effectRef idx="2">
-            <a:schemeClr val="accent1"/>
-          </a:effectRef>
-          <a:fontRef idx="minor">
-            <a:schemeClr val="lt1"/>
-          </a:fontRef>
-        </p:style>
-        <p:txBody>
-          <a:bodyPr rtlCol="0" anchor="ctr"/>
-          <a:lstStyle/>
-          <a:p>
-            <a:pPr algn="ctr"/>
-          </a:p>
-        </p:txBody>
-      </p:sp>
-      <p:sp>
-        <p:nvSpPr>
-          <p:cNvPr id="68" name="Rounded Rectangle 67"/>
-          <p:cNvSpPr/>
-          <p:nvPr/>
-        </p:nvSpPr>
-        <p:spPr>
-          <a:xfrm>
-            <a:off x="6178143" y="2834639"/>
-            <a:ext cx="91440" cy="1664207"/>
-          </a:xfrm>
-          <a:prstGeom prst="roundRect">
-            <a:avLst/>
-          </a:prstGeom>
-          <a:solidFill>
-            <a:srgbClr val="4F46B4"/>
-          </a:solidFill>
-          <a:ln>
-            <a:noFill/>
-          </a:ln>
-        </p:spPr>
-        <p:style>
-          <a:lnRef idx="1">
-            <a:schemeClr val="accent1"/>
-          </a:lnRef>
-          <a:fillRef idx="3">
-            <a:schemeClr val="accent1"/>
-          </a:fillRef>
-          <a:effectRef idx="2">
-            <a:schemeClr val="accent1"/>
-          </a:effectRef>
-          <a:fontRef idx="minor">
-            <a:schemeClr val="lt1"/>
-          </a:fontRef>
-        </p:style>
-        <p:txBody>
-          <a:bodyPr rtlCol="0" anchor="ctr"/>
-          <a:lstStyle/>
-          <a:p>
-            <a:pPr algn="ctr"/>
-          </a:p>
-        </p:txBody>
-      </p:sp>
-      <p:sp>
-        <p:nvSpPr>
-          <p:cNvPr id="69" name="Rounded Rectangle 68"/>
-          <p:cNvSpPr/>
-          <p:nvPr/>
-        </p:nvSpPr>
-        <p:spPr>
-          <a:xfrm>
-            <a:off x="6342735" y="2944368"/>
-            <a:ext cx="438912" cy="256032"/>
-          </a:xfrm>
-          <a:prstGeom prst="roundRect">
-            <a:avLst/>
-          </a:prstGeom>
-          <a:solidFill>
-            <a:srgbClr val="4F46B4"/>
-          </a:solidFill>
-          <a:ln>
-            <a:noFill/>
-          </a:ln>
-        </p:spPr>
-        <p:style>
-          <a:lnRef idx="1">
-            <a:schemeClr val="accent1"/>
-          </a:lnRef>
-          <a:fillRef idx="3">
-            <a:schemeClr val="accent1"/>
-          </a:fillRef>
-          <a:effectRef idx="2">
-            <a:schemeClr val="accent1"/>
-          </a:effectRef>
-          <a:fontRef idx="minor">
-            <a:schemeClr val="lt1"/>
-          </a:fontRef>
-        </p:style>
-        <p:txBody>
-          <a:bodyPr rtlCol="0" anchor="ctr" wrap="square"/>
-          <a:lstStyle/>
-          <a:p>
-            <a:pPr algn="ctr"/>
-            <a:r>
-              <a:rPr sz="1100" b="1">
-                <a:solidFill>
-                  <a:srgbClr val="F8FAFC"/>
-                </a:solidFill>
-                <a:latin typeface="Calibri"/>
-              </a:rPr>
-              <a:t>07</a:t>
-            </a:r>
-          </a:p>
-        </p:txBody>
-      </p:sp>
-      <p:sp>
-        <p:nvSpPr>
-          <p:cNvPr id="70" name="TextBox 69"/>
-          <p:cNvSpPr txBox="1"/>
-          <p:nvPr/>
-        </p:nvSpPr>
-        <p:spPr>
-          <a:xfrm>
-            <a:off x="6836511" y="2926079"/>
-            <a:ext cx="2010079" cy="292608"/>
-          </a:xfrm>
-          <a:prstGeom prst="rect">
-            <a:avLst/>
-          </a:prstGeom>
-          <a:noFill/>
-        </p:spPr>
-        <p:txBody>
-          <a:bodyPr wrap="square">
-            <a:spAutoFit/>
-          </a:bodyPr>
-          <a:lstStyle/>
-          <a:p>
-            <a:pPr algn="l"/>
-            <a:r>
-              <a:rPr sz="1300" b="1">
-                <a:solidFill>
-                  <a:srgbClr val="141E2E"/>
-                </a:solidFill>
-                <a:latin typeface="Calibri"/>
-              </a:rPr>
-              <a:t>Config &amp; Automation</a:t>
-            </a:r>
-          </a:p>
-        </p:txBody>
-      </p:sp>
-      <p:sp>
-        <p:nvSpPr>
-          <p:cNvPr id="71" name="TextBox 70"/>
-          <p:cNvSpPr txBox="1"/>
-          <p:nvPr/>
-        </p:nvSpPr>
-        <p:spPr>
-          <a:xfrm>
-            <a:off x="6836511" y="3182111"/>
-            <a:ext cx="2010079" cy="237744"/>
-          </a:xfrm>
-          <a:prstGeom prst="rect">
-            <a:avLst/>
-          </a:prstGeom>
-          <a:noFill/>
-        </p:spPr>
-        <p:txBody>
-          <a:bodyPr wrap="square">
-            <a:spAutoFit/>
-          </a:bodyPr>
-          <a:lstStyle/>
-          <a:p>
-            <a:pPr algn="l"/>
-            <a:r>
-              <a:rPr sz="1000" b="0">
-                <a:solidFill>
-                  <a:srgbClr val="606E7E"/>
-                </a:solidFill>
-                <a:latin typeface="Calibri"/>
-              </a:rPr>
-              <a:t>Ansible · AWS SSM</a:t>
-            </a:r>
-          </a:p>
-        </p:txBody>
-      </p:sp>
-      <p:pic>
-        <p:nvPicPr>
-          <p:cNvPr id="72" name="Picture 71" descr="ansible.png"/>
-          <p:cNvPicPr>
-            <a:picLocks noChangeAspect="1"/>
-          </p:cNvPicPr>
-          <p:nvPr/>
-        </p:nvPicPr>
-        <p:blipFill>
-          <a:blip r:embed="rId14"/>
-          <a:stretch>
-            <a:fillRect/>
-          </a:stretch>
-        </p:blipFill>
-        <p:spPr>
-          <a:xfrm>
-            <a:off x="7388923" y="3474720"/>
-            <a:ext cx="365760" cy="365760"/>
-          </a:xfrm>
-          <a:prstGeom prst="rect">
-            <a:avLst/>
-          </a:prstGeom>
-        </p:spPr>
-      </p:pic>
-      <p:sp>
-        <p:nvSpPr>
-          <p:cNvPr id="73" name="Rounded Rectangle 72"/>
-          <p:cNvSpPr/>
-          <p:nvPr/>
-        </p:nvSpPr>
-        <p:spPr>
-          <a:xfrm>
-            <a:off x="9130055" y="2834639"/>
-            <a:ext cx="2787319" cy="1664207"/>
-          </a:xfrm>
-          <a:prstGeom prst="roundRect">
-            <a:avLst/>
-          </a:prstGeom>
-          <a:solidFill>
-            <a:srgbClr val="F8FAFC"/>
-          </a:solidFill>
-          <a:ln w="19050">
-            <a:solidFill>
-              <a:srgbClr val="E2E8F0"/>
-            </a:solidFill>
-          </a:ln>
-        </p:spPr>
-        <p:style>
-          <a:lnRef idx="1">
-            <a:schemeClr val="accent1"/>
-          </a:lnRef>
-          <a:fillRef idx="3">
-            <a:schemeClr val="accent1"/>
-          </a:fillRef>
-          <a:effectRef idx="2">
-            <a:schemeClr val="accent1"/>
-          </a:effectRef>
-          <a:fontRef idx="minor">
-            <a:schemeClr val="lt1"/>
-          </a:fontRef>
-        </p:style>
-        <p:txBody>
-          <a:bodyPr rtlCol="0" anchor="ctr"/>
-          <a:lstStyle/>
-          <a:p>
-            <a:pPr algn="ctr"/>
-          </a:p>
-        </p:txBody>
-      </p:sp>
-      <p:sp>
-        <p:nvSpPr>
-          <p:cNvPr id="74" name="Rounded Rectangle 73"/>
-          <p:cNvSpPr/>
-          <p:nvPr/>
-        </p:nvSpPr>
-        <p:spPr>
-          <a:xfrm>
-            <a:off x="9130055" y="2834639"/>
-            <a:ext cx="91440" cy="1664207"/>
-          </a:xfrm>
-          <a:prstGeom prst="roundRect">
-            <a:avLst/>
-          </a:prstGeom>
-          <a:solidFill>
-            <a:srgbClr val="4F46B4"/>
-          </a:solidFill>
-          <a:ln>
-            <a:noFill/>
-          </a:ln>
-        </p:spPr>
-        <p:style>
-          <a:lnRef idx="1">
-            <a:schemeClr val="accent1"/>
-          </a:lnRef>
-          <a:fillRef idx="3">
-            <a:schemeClr val="accent1"/>
-          </a:fillRef>
-          <a:effectRef idx="2">
-            <a:schemeClr val="accent1"/>
-          </a:effectRef>
-          <a:fontRef idx="minor">
-            <a:schemeClr val="lt1"/>
-          </a:fontRef>
-        </p:style>
-        <p:txBody>
-          <a:bodyPr rtlCol="0" anchor="ctr"/>
-          <a:lstStyle/>
-          <a:p>
-            <a:pPr algn="ctr"/>
-          </a:p>
-        </p:txBody>
-      </p:sp>
-      <p:sp>
-        <p:nvSpPr>
-          <p:cNvPr id="75" name="Rounded Rectangle 74"/>
-          <p:cNvSpPr/>
-          <p:nvPr/>
-        </p:nvSpPr>
-        <p:spPr>
-          <a:xfrm>
-            <a:off x="9294647" y="2944368"/>
-            <a:ext cx="438912" cy="256032"/>
-          </a:xfrm>
-          <a:prstGeom prst="roundRect">
-            <a:avLst/>
-          </a:prstGeom>
-          <a:solidFill>
-            <a:srgbClr val="4F46B4"/>
-          </a:solidFill>
-          <a:ln>
-            <a:noFill/>
-          </a:ln>
-        </p:spPr>
-        <p:style>
-          <a:lnRef idx="1">
-            <a:schemeClr val="accent1"/>
-          </a:lnRef>
-          <a:fillRef idx="3">
-            <a:schemeClr val="accent1"/>
-          </a:fillRef>
-          <a:effectRef idx="2">
-            <a:schemeClr val="accent1"/>
-          </a:effectRef>
-          <a:fontRef idx="minor">
-            <a:schemeClr val="lt1"/>
-          </a:fontRef>
-        </p:style>
-        <p:txBody>
-          <a:bodyPr rtlCol="0" anchor="ctr" wrap="square"/>
-          <a:lstStyle/>
-          <a:p>
-            <a:pPr algn="ctr"/>
-            <a:r>
-              <a:rPr sz="1100" b="1">
-                <a:solidFill>
-                  <a:srgbClr val="F8FAFC"/>
-                </a:solidFill>
-                <a:latin typeface="Calibri"/>
-              </a:rPr>
-              <a:t>08</a:t>
-            </a:r>
-          </a:p>
-        </p:txBody>
-      </p:sp>
-      <p:sp>
-        <p:nvSpPr>
-          <p:cNvPr id="76" name="TextBox 75"/>
-          <p:cNvSpPr txBox="1"/>
-          <p:nvPr/>
-        </p:nvSpPr>
-        <p:spPr>
-          <a:xfrm>
-            <a:off x="9788423" y="2926079"/>
-            <a:ext cx="2010079" cy="292608"/>
-          </a:xfrm>
-          <a:prstGeom prst="rect">
-            <a:avLst/>
-          </a:prstGeom>
-          <a:noFill/>
-        </p:spPr>
-        <p:txBody>
-          <a:bodyPr wrap="square">
-            <a:spAutoFit/>
-          </a:bodyPr>
-          <a:lstStyle/>
-          <a:p>
-            <a:pPr algn="l"/>
-            <a:r>
-              <a:rPr sz="1300" b="1">
-                <a:solidFill>
-                  <a:srgbClr val="141E2E"/>
-                </a:solidFill>
-                <a:latin typeface="Calibri"/>
-              </a:rPr>
-              <a:t>Kubernetes</a:t>
-            </a:r>
-          </a:p>
-        </p:txBody>
-      </p:sp>
-      <p:sp>
-        <p:nvSpPr>
-          <p:cNvPr id="77" name="TextBox 76"/>
-          <p:cNvSpPr txBox="1"/>
-          <p:nvPr/>
-        </p:nvSpPr>
-        <p:spPr>
-          <a:xfrm>
-            <a:off x="9788423" y="3182111"/>
-            <a:ext cx="2010079" cy="237744"/>
-          </a:xfrm>
-          <a:prstGeom prst="rect">
-            <a:avLst/>
-          </a:prstGeom>
-          <a:noFill/>
-        </p:spPr>
-        <p:txBody>
-          <a:bodyPr wrap="square">
-            <a:spAutoFit/>
-          </a:bodyPr>
-          <a:lstStyle/>
-          <a:p>
-            <a:pPr algn="l"/>
-            <a:r>
-              <a:rPr sz="1000" b="0">
-                <a:solidFill>
-                  <a:srgbClr val="606E7E"/>
-                </a:solidFill>
-                <a:latin typeface="Calibri"/>
-              </a:rPr>
-              <a:t>K8s · Helm</a:t>
-            </a:r>
-          </a:p>
-        </p:txBody>
-      </p:sp>
-      <p:pic>
-        <p:nvPicPr>
-          <p:cNvPr id="78" name="Picture 77" descr="kubernetes.png"/>
-          <p:cNvPicPr>
-            <a:picLocks noChangeAspect="1"/>
-          </p:cNvPicPr>
-          <p:nvPr/>
-        </p:nvPicPr>
-        <p:blipFill>
-          <a:blip r:embed="rId15"/>
-          <a:stretch>
-            <a:fillRect/>
-          </a:stretch>
-        </p:blipFill>
-        <p:spPr>
-          <a:xfrm>
-            <a:off x="10112235" y="3474720"/>
-            <a:ext cx="365760" cy="365760"/>
-          </a:xfrm>
-          <a:prstGeom prst="rect">
-            <a:avLst/>
-          </a:prstGeom>
-        </p:spPr>
-      </p:pic>
-      <p:pic>
-        <p:nvPicPr>
-          <p:cNvPr id="79" name="Picture 78" descr="helm.png"/>
-          <p:cNvPicPr>
-            <a:picLocks noChangeAspect="1"/>
-          </p:cNvPicPr>
-          <p:nvPr/>
-        </p:nvPicPr>
-        <p:blipFill>
-          <a:blip r:embed="rId16"/>
-          <a:stretch>
-            <a:fillRect/>
-          </a:stretch>
-        </p:blipFill>
-        <p:spPr>
-          <a:xfrm>
-            <a:off x="10569435" y="3474720"/>
-            <a:ext cx="365760" cy="365760"/>
-          </a:xfrm>
-          <a:prstGeom prst="rect">
-            <a:avLst/>
-          </a:prstGeom>
-        </p:spPr>
-      </p:pic>
-      <p:sp>
-        <p:nvSpPr>
-          <p:cNvPr id="80" name="Rounded Rectangle 79"/>
-          <p:cNvSpPr/>
-          <p:nvPr/>
-        </p:nvSpPr>
-        <p:spPr>
-          <a:xfrm>
-            <a:off x="274320" y="4645151"/>
-            <a:ext cx="2787319" cy="1664207"/>
-          </a:xfrm>
-          <a:prstGeom prst="roundRect">
-            <a:avLst/>
-          </a:prstGeom>
-          <a:solidFill>
-            <a:srgbClr val="F8FAFC"/>
-          </a:solidFill>
-          <a:ln w="19050">
-            <a:solidFill>
-              <a:srgbClr val="E2E8F0"/>
-            </a:solidFill>
-          </a:ln>
-        </p:spPr>
-        <p:style>
-          <a:lnRef idx="1">
-            <a:schemeClr val="accent1"/>
-          </a:lnRef>
-          <a:fillRef idx="3">
-            <a:schemeClr val="accent1"/>
-          </a:fillRef>
-          <a:effectRef idx="2">
-            <a:schemeClr val="accent1"/>
-          </a:effectRef>
-          <a:fontRef idx="minor">
-            <a:schemeClr val="lt1"/>
-          </a:fontRef>
-        </p:style>
-        <p:txBody>
-          <a:bodyPr rtlCol="0" anchor="ctr"/>
-          <a:lstStyle/>
-          <a:p>
-            <a:pPr algn="ctr"/>
-          </a:p>
-        </p:txBody>
-      </p:sp>
-      <p:sp>
-        <p:nvSpPr>
-          <p:cNvPr id="81" name="Rounded Rectangle 80"/>
-          <p:cNvSpPr/>
-          <p:nvPr/>
-        </p:nvSpPr>
-        <p:spPr>
-          <a:xfrm>
-            <a:off x="274320" y="4645151"/>
-            <a:ext cx="91440" cy="1664207"/>
-          </a:xfrm>
-          <a:prstGeom prst="roundRect">
-            <a:avLst/>
-          </a:prstGeom>
-          <a:solidFill>
-            <a:srgbClr val="22A062"/>
-          </a:solidFill>
-          <a:ln>
-            <a:noFill/>
-          </a:ln>
-        </p:spPr>
-        <p:style>
-          <a:lnRef idx="1">
-            <a:schemeClr val="accent1"/>
-          </a:lnRef>
-          <a:fillRef idx="3">
-            <a:schemeClr val="accent1"/>
-          </a:fillRef>
-          <a:effectRef idx="2">
-            <a:schemeClr val="accent1"/>
-          </a:effectRef>
-          <a:fontRef idx="minor">
-            <a:schemeClr val="lt1"/>
-          </a:fontRef>
-        </p:style>
-        <p:txBody>
-          <a:bodyPr rtlCol="0" anchor="ctr"/>
-          <a:lstStyle/>
-          <a:p>
-            <a:pPr algn="ctr"/>
-          </a:p>
-        </p:txBody>
-      </p:sp>
-      <p:sp>
-        <p:nvSpPr>
-          <p:cNvPr id="82" name="Rounded Rectangle 81"/>
-          <p:cNvSpPr/>
-          <p:nvPr/>
-        </p:nvSpPr>
-        <p:spPr>
-          <a:xfrm>
-            <a:off x="438912" y="4754879"/>
-            <a:ext cx="438912" cy="256032"/>
-          </a:xfrm>
-          <a:prstGeom prst="roundRect">
-            <a:avLst/>
-          </a:prstGeom>
-          <a:solidFill>
-            <a:srgbClr val="22A062"/>
-          </a:solidFill>
-          <a:ln>
-            <a:noFill/>
-          </a:ln>
-        </p:spPr>
-        <p:style>
-          <a:lnRef idx="1">
-            <a:schemeClr val="accent1"/>
-          </a:lnRef>
-          <a:fillRef idx="3">
-            <a:schemeClr val="accent1"/>
-          </a:fillRef>
-          <a:effectRef idx="2">
-            <a:schemeClr val="accent1"/>
-          </a:effectRef>
-          <a:fontRef idx="minor">
-            <a:schemeClr val="lt1"/>
-          </a:fontRef>
-        </p:style>
-        <p:txBody>
-          <a:bodyPr rtlCol="0" anchor="ctr" wrap="square"/>
-          <a:lstStyle/>
-          <a:p>
-            <a:pPr algn="ctr"/>
-            <a:r>
-              <a:rPr sz="1100" b="1">
-                <a:solidFill>
-                  <a:srgbClr val="F8FAFC"/>
-                </a:solidFill>
-                <a:latin typeface="Calibri"/>
-              </a:rPr>
-              <a:t>09</a:t>
-            </a:r>
-          </a:p>
-        </p:txBody>
-      </p:sp>
-      <p:sp>
-        <p:nvSpPr>
-          <p:cNvPr id="83" name="TextBox 82"/>
-          <p:cNvSpPr txBox="1"/>
-          <p:nvPr/>
-        </p:nvSpPr>
-        <p:spPr>
-          <a:xfrm>
-            <a:off x="932688" y="4736591"/>
-            <a:ext cx="2010079" cy="292608"/>
-          </a:xfrm>
-          <a:prstGeom prst="rect">
-            <a:avLst/>
-          </a:prstGeom>
-          <a:noFill/>
-        </p:spPr>
-        <p:txBody>
-          <a:bodyPr wrap="square">
-            <a:spAutoFit/>
-          </a:bodyPr>
-          <a:lstStyle/>
-          <a:p>
-            <a:pPr algn="l"/>
-            <a:r>
-              <a:rPr sz="1300" b="1">
-                <a:solidFill>
-                  <a:srgbClr val="141E2E"/>
-                </a:solidFill>
-                <a:latin typeface="Calibri"/>
-              </a:rPr>
-              <a:t>Security</a:t>
-            </a:r>
-          </a:p>
-        </p:txBody>
-      </p:sp>
-      <p:sp>
-        <p:nvSpPr>
-          <p:cNvPr id="84" name="TextBox 83"/>
-          <p:cNvSpPr txBox="1"/>
-          <p:nvPr/>
-        </p:nvSpPr>
-        <p:spPr>
-          <a:xfrm>
-            <a:off x="932688" y="4992623"/>
-            <a:ext cx="2010079" cy="237744"/>
-          </a:xfrm>
-          <a:prstGeom prst="rect">
-            <a:avLst/>
-          </a:prstGeom>
-          <a:noFill/>
-        </p:spPr>
-        <p:txBody>
-          <a:bodyPr wrap="square">
-            <a:spAutoFit/>
-          </a:bodyPr>
-          <a:lstStyle/>
-          <a:p>
-            <a:pPr algn="l"/>
-            <a:r>
-              <a:rPr sz="1000" b="0">
-                <a:solidFill>
-                  <a:srgbClr val="606E7E"/>
-                </a:solidFill>
-                <a:latin typeface="Calibri"/>
-              </a:rPr>
-              <a:t>IAM · Scanning · Secrets</a:t>
-            </a:r>
-          </a:p>
-        </p:txBody>
-      </p:sp>
-      <p:pic>
-        <p:nvPicPr>
-          <p:cNvPr id="85" name="Picture 84" descr="security.png"/>
-          <p:cNvPicPr>
-            <a:picLocks noChangeAspect="1"/>
-          </p:cNvPicPr>
-          <p:nvPr/>
-        </p:nvPicPr>
-        <p:blipFill>
-          <a:blip r:embed="rId17"/>
-          <a:stretch>
-            <a:fillRect/>
-          </a:stretch>
-        </p:blipFill>
-        <p:spPr>
-          <a:xfrm>
-            <a:off x="1485099" y="5285231"/>
-            <a:ext cx="365760" cy="365760"/>
-          </a:xfrm>
-          <a:prstGeom prst="rect">
-            <a:avLst/>
-          </a:prstGeom>
-        </p:spPr>
-      </p:pic>
-      <p:sp>
-        <p:nvSpPr>
-          <p:cNvPr id="86" name="Rounded Rectangle 85"/>
-          <p:cNvSpPr/>
-          <p:nvPr/>
-        </p:nvSpPr>
-        <p:spPr>
-          <a:xfrm>
-            <a:off x="3226231" y="4645151"/>
-            <a:ext cx="2787319" cy="1664207"/>
-          </a:xfrm>
-          <a:prstGeom prst="roundRect">
-            <a:avLst/>
-          </a:prstGeom>
-          <a:solidFill>
-            <a:srgbClr val="F8FAFC"/>
-          </a:solidFill>
-          <a:ln w="19050">
-            <a:solidFill>
-              <a:srgbClr val="E2E8F0"/>
-            </a:solidFill>
-          </a:ln>
-        </p:spPr>
-        <p:style>
-          <a:lnRef idx="1">
-            <a:schemeClr val="accent1"/>
-          </a:lnRef>
-          <a:fillRef idx="3">
-            <a:schemeClr val="accent1"/>
-          </a:fillRef>
-          <a:effectRef idx="2">
-            <a:schemeClr val="accent1"/>
-          </a:effectRef>
-          <a:fontRef idx="minor">
-            <a:schemeClr val="lt1"/>
-          </a:fontRef>
-        </p:style>
-        <p:txBody>
-          <a:bodyPr rtlCol="0" anchor="ctr"/>
-          <a:lstStyle/>
-          <a:p>
-            <a:pPr algn="ctr"/>
-          </a:p>
-        </p:txBody>
-      </p:sp>
-      <p:sp>
-        <p:nvSpPr>
-          <p:cNvPr id="87" name="Rounded Rectangle 86"/>
-          <p:cNvSpPr/>
-          <p:nvPr/>
-        </p:nvSpPr>
-        <p:spPr>
-          <a:xfrm>
-            <a:off x="3226231" y="4645151"/>
-            <a:ext cx="91440" cy="1664207"/>
-          </a:xfrm>
-          <a:prstGeom prst="roundRect">
-            <a:avLst/>
-          </a:prstGeom>
-          <a:solidFill>
-            <a:srgbClr val="22A062"/>
-          </a:solidFill>
-          <a:ln>
-            <a:noFill/>
-          </a:ln>
-        </p:spPr>
-        <p:style>
-          <a:lnRef idx="1">
-            <a:schemeClr val="accent1"/>
-          </a:lnRef>
-          <a:fillRef idx="3">
-            <a:schemeClr val="accent1"/>
-          </a:fillRef>
-          <a:effectRef idx="2">
-            <a:schemeClr val="accent1"/>
-          </a:effectRef>
-          <a:fontRef idx="minor">
-            <a:schemeClr val="lt1"/>
-          </a:fontRef>
-        </p:style>
-        <p:txBody>
-          <a:bodyPr rtlCol="0" anchor="ctr"/>
-          <a:lstStyle/>
-          <a:p>
-            <a:pPr algn="ctr"/>
-          </a:p>
-        </p:txBody>
-      </p:sp>
-      <p:sp>
-        <p:nvSpPr>
-          <p:cNvPr id="88" name="Rounded Rectangle 87"/>
-          <p:cNvSpPr/>
-          <p:nvPr/>
-        </p:nvSpPr>
-        <p:spPr>
-          <a:xfrm>
-            <a:off x="3390823" y="4754879"/>
-            <a:ext cx="438912" cy="256032"/>
-          </a:xfrm>
-          <a:prstGeom prst="roundRect">
-            <a:avLst/>
-          </a:prstGeom>
-          <a:solidFill>
-            <a:srgbClr val="22A062"/>
-          </a:solidFill>
-          <a:ln>
-            <a:noFill/>
-          </a:ln>
-        </p:spPr>
-        <p:style>
-          <a:lnRef idx="1">
-            <a:schemeClr val="accent1"/>
-          </a:lnRef>
-          <a:fillRef idx="3">
-            <a:schemeClr val="accent1"/>
-          </a:fillRef>
-          <a:effectRef idx="2">
-            <a:schemeClr val="accent1"/>
-          </a:effectRef>
-          <a:fontRef idx="minor">
-            <a:schemeClr val="lt1"/>
-          </a:fontRef>
-        </p:style>
-        <p:txBody>
-          <a:bodyPr rtlCol="0" anchor="ctr" wrap="square"/>
-          <a:lstStyle/>
-          <a:p>
-            <a:pPr algn="ctr"/>
-            <a:r>
-              <a:rPr sz="1100" b="1">
-                <a:solidFill>
-                  <a:srgbClr val="F8FAFC"/>
-                </a:solidFill>
-                <a:latin typeface="Calibri"/>
-              </a:rPr>
-              <a:t>10</a:t>
-            </a:r>
-          </a:p>
-        </p:txBody>
-      </p:sp>
-      <p:sp>
-        <p:nvSpPr>
-          <p:cNvPr id="89" name="TextBox 88"/>
-          <p:cNvSpPr txBox="1"/>
-          <p:nvPr/>
-        </p:nvSpPr>
-        <p:spPr>
-          <a:xfrm>
-            <a:off x="3884599" y="4736591"/>
-            <a:ext cx="2010079" cy="292608"/>
-          </a:xfrm>
-          <a:prstGeom prst="rect">
-            <a:avLst/>
-          </a:prstGeom>
-          <a:noFill/>
-        </p:spPr>
-        <p:txBody>
-          <a:bodyPr wrap="square">
-            <a:spAutoFit/>
-          </a:bodyPr>
-          <a:lstStyle/>
-          <a:p>
-            <a:pPr algn="l"/>
-            <a:r>
-              <a:rPr sz="1300" b="1">
-                <a:solidFill>
-                  <a:srgbClr val="141E2E"/>
-                </a:solidFill>
-                <a:latin typeface="Calibri"/>
-              </a:rPr>
-              <a:t>Observability</a:t>
-            </a:r>
-          </a:p>
-        </p:txBody>
-      </p:sp>
-      <p:sp>
-        <p:nvSpPr>
-          <p:cNvPr id="90" name="TextBox 89"/>
-          <p:cNvSpPr txBox="1"/>
-          <p:nvPr/>
-        </p:nvSpPr>
-        <p:spPr>
-          <a:xfrm>
-            <a:off x="3884599" y="4992623"/>
-            <a:ext cx="2010079" cy="237744"/>
-          </a:xfrm>
-          <a:prstGeom prst="rect">
-            <a:avLst/>
-          </a:prstGeom>
-          <a:noFill/>
-        </p:spPr>
-        <p:txBody>
-          <a:bodyPr wrap="square">
-            <a:spAutoFit/>
-          </a:bodyPr>
-          <a:lstStyle/>
-          <a:p>
-            <a:pPr algn="l"/>
-            <a:r>
-              <a:rPr sz="1000" b="0">
-                <a:solidFill>
-                  <a:srgbClr val="606E7E"/>
-                </a:solidFill>
-                <a:latin typeface="Calibri"/>
-              </a:rPr>
-              <a:t>Prometheus · Grafana · Logs</a:t>
-            </a:r>
-          </a:p>
-        </p:txBody>
-      </p:sp>
-      <p:pic>
-        <p:nvPicPr>
-          <p:cNvPr id="91" name="Picture 90" descr="prometheus.png"/>
-          <p:cNvPicPr>
-            <a:picLocks noChangeAspect="1"/>
-          </p:cNvPicPr>
-          <p:nvPr/>
-        </p:nvPicPr>
-        <p:blipFill>
-          <a:blip r:embed="rId18"/>
-          <a:stretch>
-            <a:fillRect/>
-          </a:stretch>
-        </p:blipFill>
-        <p:spPr>
-          <a:xfrm>
-            <a:off x="4208411" y="5285231"/>
-            <a:ext cx="365760" cy="365760"/>
-          </a:xfrm>
-          <a:prstGeom prst="rect">
-            <a:avLst/>
-          </a:prstGeom>
-        </p:spPr>
-      </p:pic>
-      <p:pic>
-        <p:nvPicPr>
-          <p:cNvPr id="92" name="Picture 91" descr="grafana.png"/>
-          <p:cNvPicPr>
-            <a:picLocks noChangeAspect="1"/>
-          </p:cNvPicPr>
-          <p:nvPr/>
-        </p:nvPicPr>
-        <p:blipFill>
-          <a:blip r:embed="rId19"/>
-          <a:stretch>
-            <a:fillRect/>
-          </a:stretch>
-        </p:blipFill>
-        <p:spPr>
-          <a:xfrm>
-            <a:off x="4665611" y="5285231"/>
-            <a:ext cx="365760" cy="365760"/>
-          </a:xfrm>
-          <a:prstGeom prst="rect">
-            <a:avLst/>
-          </a:prstGeom>
-        </p:spPr>
-      </p:pic>
-      <p:sp>
-        <p:nvSpPr>
-          <p:cNvPr id="93" name="Rounded Rectangle 92"/>
-          <p:cNvSpPr/>
-          <p:nvPr/>
-        </p:nvSpPr>
-        <p:spPr>
-          <a:xfrm>
-            <a:off x="6178143" y="4645151"/>
-            <a:ext cx="2787319" cy="1664207"/>
-          </a:xfrm>
-          <a:prstGeom prst="roundRect">
-            <a:avLst/>
-          </a:prstGeom>
-          <a:solidFill>
-            <a:srgbClr val="F8FAFC"/>
-          </a:solidFill>
-          <a:ln w="19050">
-            <a:solidFill>
-              <a:srgbClr val="E2E8F0"/>
-            </a:solidFill>
-          </a:ln>
-        </p:spPr>
-        <p:style>
-          <a:lnRef idx="1">
-            <a:schemeClr val="accent1"/>
-          </a:lnRef>
-          <a:fillRef idx="3">
-            <a:schemeClr val="accent1"/>
-          </a:fillRef>
-          <a:effectRef idx="2">
-            <a:schemeClr val="accent1"/>
-          </a:effectRef>
-          <a:fontRef idx="minor">
-            <a:schemeClr val="lt1"/>
-          </a:fontRef>
-        </p:style>
-        <p:txBody>
-          <a:bodyPr rtlCol="0" anchor="ctr"/>
-          <a:lstStyle/>
-          <a:p>
-            <a:pPr algn="ctr"/>
-          </a:p>
-        </p:txBody>
-      </p:sp>
-      <p:sp>
-        <p:nvSpPr>
-          <p:cNvPr id="94" name="Rounded Rectangle 93"/>
-          <p:cNvSpPr/>
-          <p:nvPr/>
-        </p:nvSpPr>
-        <p:spPr>
-          <a:xfrm>
-            <a:off x="6178143" y="4645151"/>
-            <a:ext cx="91440" cy="1664207"/>
-          </a:xfrm>
-          <a:prstGeom prst="roundRect">
-            <a:avLst/>
-          </a:prstGeom>
-          <a:solidFill>
-            <a:srgbClr val="22A062"/>
-          </a:solidFill>
-          <a:ln>
-            <a:noFill/>
-          </a:ln>
-        </p:spPr>
-        <p:style>
-          <a:lnRef idx="1">
-            <a:schemeClr val="accent1"/>
-          </a:lnRef>
-          <a:fillRef idx="3">
-            <a:schemeClr val="accent1"/>
-          </a:fillRef>
-          <a:effectRef idx="2">
-            <a:schemeClr val="accent1"/>
-          </a:effectRef>
-          <a:fontRef idx="minor">
-            <a:schemeClr val="lt1"/>
-          </a:fontRef>
-        </p:style>
-        <p:txBody>
-          <a:bodyPr rtlCol="0" anchor="ctr"/>
-          <a:lstStyle/>
-          <a:p>
-            <a:pPr algn="ctr"/>
-          </a:p>
-        </p:txBody>
-      </p:sp>
-      <p:sp>
-        <p:nvSpPr>
-          <p:cNvPr id="95" name="Rounded Rectangle 94"/>
-          <p:cNvSpPr/>
-          <p:nvPr/>
-        </p:nvSpPr>
-        <p:spPr>
-          <a:xfrm>
-            <a:off x="6342735" y="4754879"/>
-            <a:ext cx="438912" cy="256032"/>
-          </a:xfrm>
-          <a:prstGeom prst="roundRect">
-            <a:avLst/>
-          </a:prstGeom>
-          <a:solidFill>
-            <a:srgbClr val="22A062"/>
-          </a:solidFill>
-          <a:ln>
-            <a:noFill/>
-          </a:ln>
-        </p:spPr>
-        <p:style>
-          <a:lnRef idx="1">
-            <a:schemeClr val="accent1"/>
-          </a:lnRef>
-          <a:fillRef idx="3">
-            <a:schemeClr val="accent1"/>
-          </a:fillRef>
-          <a:effectRef idx="2">
-            <a:schemeClr val="accent1"/>
-          </a:effectRef>
-          <a:fontRef idx="minor">
-            <a:schemeClr val="lt1"/>
-          </a:fontRef>
-        </p:style>
-        <p:txBody>
-          <a:bodyPr rtlCol="0" anchor="ctr" wrap="square"/>
-          <a:lstStyle/>
-          <a:p>
-            <a:pPr algn="ctr"/>
-            <a:r>
-              <a:rPr sz="1100" b="1">
-                <a:solidFill>
-                  <a:srgbClr val="F8FAFC"/>
-                </a:solidFill>
-                <a:latin typeface="Calibri"/>
-              </a:rPr>
-              <a:t>11</a:t>
-            </a:r>
-          </a:p>
-        </p:txBody>
-      </p:sp>
-      <p:sp>
-        <p:nvSpPr>
-          <p:cNvPr id="96" name="TextBox 95"/>
-          <p:cNvSpPr txBox="1"/>
-          <p:nvPr/>
-        </p:nvSpPr>
-        <p:spPr>
-          <a:xfrm>
-            <a:off x="6836511" y="4736591"/>
-            <a:ext cx="2010079" cy="292608"/>
-          </a:xfrm>
-          <a:prstGeom prst="rect">
-            <a:avLst/>
-          </a:prstGeom>
-          <a:noFill/>
-        </p:spPr>
-        <p:txBody>
-          <a:bodyPr wrap="square">
-            <a:spAutoFit/>
-          </a:bodyPr>
-          <a:lstStyle/>
-          <a:p>
-            <a:pPr algn="l"/>
-            <a:r>
-              <a:rPr sz="1300" b="1">
-                <a:solidFill>
-                  <a:srgbClr val="141E2E"/>
-                </a:solidFill>
-                <a:latin typeface="Calibri"/>
-              </a:rPr>
-              <a:t>GitOps</a:t>
-            </a:r>
-          </a:p>
-        </p:txBody>
-      </p:sp>
-      <p:sp>
-        <p:nvSpPr>
-          <p:cNvPr id="97" name="TextBox 96"/>
-          <p:cNvSpPr txBox="1"/>
-          <p:nvPr/>
-        </p:nvSpPr>
-        <p:spPr>
-          <a:xfrm>
-            <a:off x="6836511" y="4992623"/>
-            <a:ext cx="2010079" cy="237744"/>
-          </a:xfrm>
-          <a:prstGeom prst="rect">
-            <a:avLst/>
-          </a:prstGeom>
-          <a:noFill/>
-        </p:spPr>
-        <p:txBody>
-          <a:bodyPr wrap="square">
-            <a:spAutoFit/>
-          </a:bodyPr>
-          <a:lstStyle/>
-          <a:p>
-            <a:pPr algn="l"/>
-            <a:r>
-              <a:rPr sz="1000" b="0">
-                <a:solidFill>
-                  <a:srgbClr val="606E7E"/>
-                </a:solidFill>
-                <a:latin typeface="Calibri"/>
-              </a:rPr>
-              <a:t>ArgoCD · Flux</a:t>
-            </a:r>
-          </a:p>
-        </p:txBody>
-      </p:sp>
-      <p:pic>
-        <p:nvPicPr>
-          <p:cNvPr id="98" name="Picture 97" descr="argocd.png"/>
-          <p:cNvPicPr>
-            <a:picLocks noChangeAspect="1"/>
-          </p:cNvPicPr>
-          <p:nvPr/>
-        </p:nvPicPr>
-        <p:blipFill>
-          <a:blip r:embed="rId20"/>
-          <a:stretch>
-            <a:fillRect/>
-          </a:stretch>
-        </p:blipFill>
-        <p:spPr>
-          <a:xfrm>
-            <a:off x="6931723" y="5285231"/>
-            <a:ext cx="365760" cy="365760"/>
-          </a:xfrm>
-          <a:prstGeom prst="rect">
-            <a:avLst/>
-          </a:prstGeom>
-        </p:spPr>
-      </p:pic>
-      <p:pic>
-        <p:nvPicPr>
-          <p:cNvPr id="99" name="Picture 98" descr="flux.png"/>
-          <p:cNvPicPr>
-            <a:picLocks noChangeAspect="1"/>
-          </p:cNvPicPr>
-          <p:nvPr/>
-        </p:nvPicPr>
-        <p:blipFill>
-          <a:blip r:embed="rId21"/>
-          <a:stretch>
-            <a:fillRect/>
-          </a:stretch>
-        </p:blipFill>
-        <p:spPr>
-          <a:xfrm>
-            <a:off x="7388923" y="5285231"/>
-            <a:ext cx="365760" cy="365760"/>
-          </a:xfrm>
-          <a:prstGeom prst="rect">
-            <a:avLst/>
-          </a:prstGeom>
-        </p:spPr>
-      </p:pic>
-      <p:pic>
-        <p:nvPicPr>
-          <p:cNvPr id="100" name="Picture 99" descr="git.png"/>
-          <p:cNvPicPr>
-            <a:picLocks noChangeAspect="1"/>
-          </p:cNvPicPr>
-          <p:nvPr/>
-        </p:nvPicPr>
-        <p:blipFill>
-          <a:blip r:embed="rId4"/>
-          <a:stretch>
-            <a:fillRect/>
-          </a:stretch>
-        </p:blipFill>
-        <p:spPr>
-          <a:xfrm>
-            <a:off x="7846123" y="5285231"/>
-            <a:ext cx="365760" cy="365760"/>
-          </a:xfrm>
-          <a:prstGeom prst="rect">
-            <a:avLst/>
-          </a:prstGeom>
-        </p:spPr>
-      </p:pic>
-      <p:sp>
-        <p:nvSpPr>
-          <p:cNvPr id="101" name="Rounded Rectangle 100"/>
-          <p:cNvSpPr/>
-          <p:nvPr/>
-        </p:nvSpPr>
-        <p:spPr>
-          <a:xfrm>
-            <a:off x="9130055" y="4645151"/>
-            <a:ext cx="2787319" cy="1664207"/>
-          </a:xfrm>
-          <a:prstGeom prst="roundRect">
-            <a:avLst/>
-          </a:prstGeom>
-          <a:solidFill>
-            <a:srgbClr val="141E2E"/>
-          </a:solidFill>
-          <a:ln>
-            <a:noFill/>
-          </a:ln>
-        </p:spPr>
-        <p:style>
-          <a:lnRef idx="1">
-            <a:schemeClr val="accent1"/>
-          </a:lnRef>
-          <a:fillRef idx="3">
-            <a:schemeClr val="accent1"/>
-          </a:fillRef>
-          <a:effectRef idx="2">
-            <a:schemeClr val="accent1"/>
-          </a:effectRef>
-          <a:fontRef idx="minor">
-            <a:schemeClr val="lt1"/>
-          </a:fontRef>
-        </p:style>
-        <p:txBody>
-          <a:bodyPr rtlCol="0" anchor="ctr"/>
-          <a:lstStyle/>
-          <a:p>
-            <a:pPr algn="ctr"/>
-          </a:p>
-        </p:txBody>
-      </p:sp>
-      <p:sp>
-        <p:nvSpPr>
-          <p:cNvPr id="102" name="Rounded Rectangle 101"/>
-          <p:cNvSpPr/>
-          <p:nvPr/>
-        </p:nvSpPr>
-        <p:spPr>
-          <a:xfrm>
-            <a:off x="9130055" y="4645151"/>
-            <a:ext cx="91440" cy="1664207"/>
-          </a:xfrm>
-          <a:prstGeom prst="roundRect">
-            <a:avLst/>
-          </a:prstGeom>
-          <a:solidFill>
-            <a:srgbClr val="EC4899"/>
-          </a:solidFill>
-          <a:ln>
-            <a:noFill/>
-          </a:ln>
-        </p:spPr>
-        <p:style>
-          <a:lnRef idx="1">
-            <a:schemeClr val="accent1"/>
-          </a:lnRef>
-          <a:fillRef idx="3">
-            <a:schemeClr val="accent1"/>
-          </a:fillRef>
-          <a:effectRef idx="2">
-            <a:schemeClr val="accent1"/>
-          </a:effectRef>
-          <a:fontRef idx="minor">
-            <a:schemeClr val="lt1"/>
-          </a:fontRef>
-        </p:style>
-        <p:txBody>
-          <a:bodyPr rtlCol="0" anchor="ctr"/>
-          <a:lstStyle/>
-          <a:p>
-            <a:pPr algn="ctr"/>
-          </a:p>
-        </p:txBody>
-      </p:sp>
-      <p:sp>
-        <p:nvSpPr>
-          <p:cNvPr id="103" name="TextBox 102"/>
-          <p:cNvSpPr txBox="1"/>
-          <p:nvPr/>
-        </p:nvSpPr>
-        <p:spPr>
-          <a:xfrm>
-            <a:off x="9331223" y="4754879"/>
-            <a:ext cx="2467279" cy="237744"/>
-          </a:xfrm>
-          <a:prstGeom prst="rect">
-            <a:avLst/>
-          </a:prstGeom>
-          <a:noFill/>
-        </p:spPr>
-        <p:txBody>
-          <a:bodyPr wrap="square">
-            <a:spAutoFit/>
-          </a:bodyPr>
-          <a:lstStyle/>
-          <a:p>
-            <a:pPr algn="l"/>
-            <a:r>
-              <a:rPr sz="1100" b="1">
-                <a:solidFill>
-                  <a:srgbClr val="EC4899"/>
-                </a:solidFill>
-                <a:latin typeface="Calibri"/>
-              </a:rPr>
-              <a:t>GOAL</a:t>
-            </a:r>
-          </a:p>
-        </p:txBody>
-      </p:sp>
-      <p:sp>
-        <p:nvSpPr>
-          <p:cNvPr id="104" name="TextBox 103"/>
-          <p:cNvSpPr txBox="1"/>
-          <p:nvPr/>
-        </p:nvSpPr>
-        <p:spPr>
-          <a:xfrm>
-            <a:off x="9331223" y="5010912"/>
-            <a:ext cx="2467279" cy="292608"/>
-          </a:xfrm>
-          <a:prstGeom prst="rect">
-            <a:avLst/>
-          </a:prstGeom>
-          <a:noFill/>
-        </p:spPr>
-        <p:txBody>
-          <a:bodyPr wrap="square">
-            <a:spAutoFit/>
-          </a:bodyPr>
-          <a:lstStyle/>
-          <a:p>
-            <a:pPr algn="l"/>
-            <a:r>
-              <a:rPr sz="1600" b="1">
-                <a:solidFill>
-                  <a:srgbClr val="F8FAFC"/>
-                </a:solidFill>
-                <a:latin typeface="Calibri"/>
-              </a:rPr>
-              <a:t>Build</a:t>
-            </a:r>
-          </a:p>
-        </p:txBody>
-      </p:sp>
-      <p:sp>
-        <p:nvSpPr>
-          <p:cNvPr id="105" name="TextBox 104"/>
-          <p:cNvSpPr txBox="1"/>
-          <p:nvPr/>
-        </p:nvSpPr>
-        <p:spPr>
-          <a:xfrm>
-            <a:off x="9331223" y="5303520"/>
-            <a:ext cx="2467279" cy="292608"/>
-          </a:xfrm>
-          <a:prstGeom prst="rect">
-            <a:avLst/>
-          </a:prstGeom>
-          <a:noFill/>
-        </p:spPr>
-        <p:txBody>
-          <a:bodyPr wrap="square">
-            <a:spAutoFit/>
-          </a:bodyPr>
-          <a:lstStyle/>
-          <a:p>
-            <a:pPr algn="l"/>
-            <a:r>
-              <a:rPr sz="1600" b="1">
-                <a:solidFill>
-                  <a:srgbClr val="F8FAFC"/>
-                </a:solidFill>
-                <a:latin typeface="Calibri"/>
-              </a:rPr>
-              <a:t>Automate</a:t>
-            </a:r>
-          </a:p>
-        </p:txBody>
-      </p:sp>
-      <p:sp>
-        <p:nvSpPr>
-          <p:cNvPr id="106" name="TextBox 105"/>
-          <p:cNvSpPr txBox="1"/>
-          <p:nvPr/>
-        </p:nvSpPr>
-        <p:spPr>
-          <a:xfrm>
-            <a:off x="9331223" y="5596127"/>
-            <a:ext cx="2467279" cy="292608"/>
-          </a:xfrm>
-          <a:prstGeom prst="rect">
-            <a:avLst/>
-          </a:prstGeom>
-          <a:noFill/>
-        </p:spPr>
-        <p:txBody>
-          <a:bodyPr wrap="square">
-            <a:spAutoFit/>
-          </a:bodyPr>
-          <a:lstStyle/>
-          <a:p>
-            <a:pPr algn="l"/>
-            <a:r>
-              <a:rPr sz="1600" b="1">
-                <a:solidFill>
-                  <a:srgbClr val="F8FAFC"/>
-                </a:solidFill>
-                <a:latin typeface="Calibri"/>
-              </a:rPr>
-              <a:t>Monitor</a:t>
-            </a:r>
-          </a:p>
-        </p:txBody>
-      </p:sp>
-      <p:sp>
-        <p:nvSpPr>
-          <p:cNvPr id="107" name="TextBox 106"/>
-          <p:cNvSpPr txBox="1"/>
-          <p:nvPr/>
-        </p:nvSpPr>
-        <p:spPr>
-          <a:xfrm>
-            <a:off x="9331223" y="5888736"/>
-            <a:ext cx="2467279" cy="292608"/>
-          </a:xfrm>
-          <a:prstGeom prst="rect">
-            <a:avLst/>
-          </a:prstGeom>
-          <a:noFill/>
-        </p:spPr>
-        <p:txBody>
-          <a:bodyPr wrap="square">
-            <a:spAutoFit/>
-          </a:bodyPr>
-          <a:lstStyle/>
-          <a:p>
-            <a:pPr algn="l"/>
-            <a:r>
-              <a:rPr sz="1600" b="1">
-                <a:solidFill>
-                  <a:srgbClr val="F8FAFC"/>
-                </a:solidFill>
-                <a:latin typeface="Calibri"/>
-              </a:rPr>
-              <a:t>Deploy</a:t>
-            </a:r>
-          </a:p>
-        </p:txBody>
-      </p:sp>
-      <p:sp>
-        <p:nvSpPr>
-          <p:cNvPr id="108" name="Rounded Rectangle 107"/>
-          <p:cNvSpPr/>
-          <p:nvPr/>
-        </p:nvSpPr>
-        <p:spPr>
-          <a:xfrm>
-            <a:off x="274320" y="6419088"/>
-            <a:ext cx="11640312" cy="347472"/>
-          </a:xfrm>
-          <a:prstGeom prst="roundRect">
-            <a:avLst/>
-          </a:prstGeom>
-          <a:solidFill>
-            <a:srgbClr val="141E2E"/>
-          </a:solidFill>
-          <a:ln>
-            <a:noFill/>
-          </a:ln>
-        </p:spPr>
-        <p:style>
-          <a:lnRef idx="1">
-            <a:schemeClr val="accent1"/>
-          </a:lnRef>
-          <a:fillRef idx="3">
-            <a:schemeClr val="accent1"/>
-          </a:fillRef>
-          <a:effectRef idx="2">
-            <a:schemeClr val="accent1"/>
-          </a:effectRef>
-          <a:fontRef idx="minor">
-            <a:schemeClr val="lt1"/>
-          </a:fontRef>
-        </p:style>
-        <p:txBody>
-          <a:bodyPr rtlCol="0" anchor="ctr"/>
-          <a:lstStyle/>
-          <a:p>
-            <a:pPr algn="ctr"/>
-          </a:p>
-        </p:txBody>
-      </p:sp>
-      <p:sp>
-        <p:nvSpPr>
-          <p:cNvPr id="109" name="TextBox 108"/>
-          <p:cNvSpPr txBox="1"/>
-          <p:nvPr/>
-        </p:nvSpPr>
-        <p:spPr>
-          <a:xfrm>
-            <a:off x="411480" y="6446520"/>
-            <a:ext cx="7772400" cy="292608"/>
-          </a:xfrm>
-          <a:prstGeom prst="rect">
-            <a:avLst/>
-          </a:prstGeom>
-          <a:noFill/>
-        </p:spPr>
-        <p:txBody>
-          <a:bodyPr wrap="square">
-            <a:spAutoFit/>
-          </a:bodyPr>
-          <a:lstStyle/>
-          <a:p>
-            <a:pPr algn="l"/>
-            <a:r>
-              <a:rPr sz="1300" b="1">
-                <a:solidFill>
-                  <a:srgbClr val="F8FAFC"/>
-                </a:solidFill>
-                <a:latin typeface="Calibri"/>
-              </a:rPr>
-              <a:t>Build   ·   Automate   ·   Monitor   ·   Deploy</a:t>
-            </a:r>
-          </a:p>
-        </p:txBody>
-      </p:sp>
-      <p:sp>
-        <p:nvSpPr>
-          <p:cNvPr id="110" name="TextBox 109"/>
-          <p:cNvSpPr txBox="1"/>
-          <p:nvPr/>
-        </p:nvSpPr>
-        <p:spPr>
-          <a:xfrm>
-            <a:off x="8778240" y="6446520"/>
-            <a:ext cx="2926080" cy="292608"/>
-          </a:xfrm>
-          <a:prstGeom prst="rect">
-            <a:avLst/>
-          </a:prstGeom>
-          <a:noFill/>
-        </p:spPr>
-        <p:txBody>
-          <a:bodyPr wrap="square">
-            <a:spAutoFit/>
-          </a:bodyPr>
-          <a:lstStyle/>
-          <a:p>
-            <a:pPr algn="r"/>
-            <a:r>
-              <a:rPr sz="1100" b="0">
-                <a:solidFill>
-                  <a:srgbClr val="94A3B8"/>
-                </a:solidFill>
-                <a:latin typeface="Calibri"/>
-              </a:rPr>
-              <a:t>Kethan Gummalla</a:t>
-            </a:r>
-          </a:p>
-        </p:txBody>
-      </p:sp>
     </p:spTree>
   </p:cSld>
   <p:clrMapOvr>

</xml_diff>